<commit_message>
Add pelvic yield sensitivity + chart zero-exclusion
Deck (now 3 slides):
- Slide 2 chart: exclude zero-harvest weeks from each biweekly point
  (only 666506 affected); keep flat-250 basis.
- Slide 1: add an inviting one-line sensitivity finding in the highlighted
  answer paragraph, pointing to the new reference slide.
- Slide 3 (new, reference): themed sensitivity table, color-coded headroom.

Model workbook: new formatted "Pelvic Yield Sensitivity" sheet (styles added
to styles.xml; 6 charts + conditional formatting/data validation preserved).

Weekly_goals: "Attainment @250 (Pelvics)" tab regenerated with the same
zero-exclusion so its biweekly block matches the slide; 18 charts preserved.

Sensitivity follows Tissue_Model formulas (Pigs=Net/Yield; Labor carries
rework on wasted pigs), validated against the model's own outputs.

Co-Authored-By: Claude Opus 4.8 <noreply@anthropic.com>
Claude-Session: https://claude.ai/code/session_01LKMb7stbjGviiyFb298aFR
</commit_message>
<xml_diff>
--- a/tissue-capacity-model/deliverables/Tissue_Capacity_2026_2027.pptx
+++ b/tissue-capacity-model/deliverables/Tissue_Capacity_2026_2027.pptx
@@ -10,6 +10,7 @@
   <p:sldIdLst>
     <p:sldId id="256" r:id="rId2"/>
     <p:sldId id="257" r:id="rId3"/>
+    <p:sldId id="258" r:id="rId9"/>
   </p:sldIdLst>
   <p:sldSz cx="12192000" cy="6858000"/>
   <p:notesSz cx="6858000" cy="12192000"/>
@@ -327,7 +328,7 @@
                 <c:formatCode>General</c:formatCode>
                 <c:ptCount val="12"/>
                 <c:pt idx="0">
-                  <c:v>40</c:v>
+                  <c:v>80</c:v>
                 </c:pt>
                 <c:pt idx="1">
                   <c:v>7</c:v>
@@ -357,7 +358,7 @@
                   <c:v>53.6</c:v>
                 </c:pt>
                 <c:pt idx="10">
-                  <c:v>40.6</c:v>
+                  <c:v>81.2</c:v>
                 </c:pt>
                 <c:pt idx="11">
                   <c:v>28.8</c:v>
@@ -1539,6 +1540,15 @@
               </a:rPr>
               <a:t>, so it cannot cover 125% of 2027 demand. Every other site clears 125%.</a:t>
             </a:r>
+            <a:r>
+              <a:rPr sz="1100" b="1" i="1">
+                <a:solidFill>
+                  <a:srgbClr val="12345B"/>
+                </a:solidFill>
+                <a:latin typeface="Calibri"/>
+              </a:rPr>
+              <a:t>   ▸ A pelvic-yield fix pays back fast: +10% harvest yield frees ~79 pigs and ~1.5 labor-hrs/wk at Martins — see slide 3 for the full 5–25% sensitivity.</a:t>
+            </a:r>
             <a:endParaRPr lang="en-US" sz="1450" dirty="0"/>
           </a:p>
         </p:txBody>
@@ -5586,7 +5596,7 @@
                 <a:ea typeface="Calibri" pitchFamily="34" charset="-122"/>
                 <a:cs typeface="Calibri" pitchFamily="34" charset="-120"/>
               </a:rPr>
-              <a:t>Left: each site is independent; labor &amp; freezer are shared per site, kill capacity is set by tissues that can't come from one pig.  Right: attainment = harvested ÷ 250/wk flat ask (biweekly); Male Pelvic excluded (being wound down).  Codes are Intuitive part numbers.</a:t>
+              <a:t>Left: each site is independent; labor &amp; freezer are shared per site, kill capacity is set by tissues that can't come from one pig.  Right: attainment = harvested ÷ 250/wk flat ask (biweekly); Male Pelvic excluded (wound down); zero-harvest weeks excluded from each biweekly point.  Codes are Intuitive part numbers.</a:t>
             </a:r>
             <a:endParaRPr lang="en-US" sz="850" dirty="0"/>
           </a:p>
@@ -5629,6 +5639,1201 @@
             <a:r>
               <a:rPr lang="en-US" dirty="0"/>
               <a:t>Why is the attainment dropping: Possible culprits: harvesting yield, labor</a:t>
+            </a:r>
+          </a:p>
+        </p:txBody>
+      </p:sp>
+    </p:spTree>
+  </p:cSld>
+  <p:clrMapOvr>
+    <a:masterClrMapping/>
+  </p:clrMapOvr>
+</p:sld>
+</file>
+
+<file path=ppt/slides/slide3.xml><?xml version="1.0" encoding="utf-8"?>
+<p:sld xmlns:a="http://schemas.openxmlformats.org/drawingml/2006/main" xmlns:p="http://schemas.openxmlformats.org/presentationml/2006/main" xmlns:r="http://schemas.openxmlformats.org/officeDocument/2006/relationships">
+  <p:cSld>
+    <p:spTree>
+      <p:nvGrpSpPr>
+        <p:cNvPr id="1" name=""/>
+        <p:cNvGrpSpPr/>
+        <p:nvPr/>
+      </p:nvGrpSpPr>
+      <p:grpSpPr/>
+      <p:sp>
+        <p:nvSpPr>
+          <p:cNvPr id="2" name="TextBox 1"/>
+          <p:cNvSpPr txBox="1"/>
+          <p:nvPr/>
+        </p:nvSpPr>
+        <p:spPr>
+          <a:xfrm>
+            <a:off x="457200" y="274320"/>
+            <a:ext cx="11274552" cy="457200"/>
+          </a:xfrm>
+          <a:prstGeom prst="rect">
+            <a:avLst/>
+          </a:prstGeom>
+          <a:noFill/>
+        </p:spPr>
+        <p:txBody>
+          <a:bodyPr wrap="square">
+            <a:spAutoFit/>
+          </a:bodyPr>
+          <a:lstStyle/>
+          <a:p>
+            <a:pPr algn="l"/>
+            <a:r>
+              <a:rPr sz="2400" b="1">
+                <a:solidFill>
+                  <a:srgbClr val="12345B"/>
+                </a:solidFill>
+                <a:latin typeface="Cambria"/>
+              </a:rPr>
+              <a:t>Reference — Pelvic Harvest-Yield Sensitivity (Martins)</a:t>
+            </a:r>
+          </a:p>
+        </p:txBody>
+      </p:sp>
+      <p:sp>
+        <p:nvSpPr>
+          <p:cNvPr id="3" name="TextBox 2"/>
+          <p:cNvSpPr txBox="1"/>
+          <p:nvPr/>
+        </p:nvSpPr>
+        <p:spPr>
+          <a:xfrm>
+            <a:off x="457200" y="804672"/>
+            <a:ext cx="11274552" cy="731520"/>
+          </a:xfrm>
+          <a:prstGeom prst="rect">
+            <a:avLst/>
+          </a:prstGeom>
+          <a:noFill/>
+        </p:spPr>
+        <p:txBody>
+          <a:bodyPr wrap="square">
+            <a:spAutoFit/>
+          </a:bodyPr>
+          <a:lstStyle/>
+          <a:p>
+            <a:pPr algn="l"/>
+            <a:r>
+              <a:rPr sz="1200" b="1">
+                <a:solidFill>
+                  <a:srgbClr val="20303D"/>
+                </a:solidFill>
+                <a:latin typeface="Calibri"/>
+              </a:rPr>
+              <a:t>Backup for the slide-1 finding. </a:t>
+            </a:r>
+            <a:r>
+              <a:rPr sz="1100" b="0">
+                <a:solidFill>
+                  <a:srgbClr val="20303D"/>
+                </a:solidFill>
+                <a:latin typeface="Calibri"/>
+              </a:rPr>
+              <a:t>Capacity returned at Martins if the pelvic-block study lifts harvesting yield above today's 25%. Follows the Tissue_Model exactly: </a:t>
+            </a:r>
+            <a:r>
+              <a:rPr sz="1100" b="0">
+                <a:solidFill>
+                  <a:srgbClr val="5A6A7A"/>
+                </a:solidFill>
+                <a:latin typeface="Calibri"/>
+              </a:rPr>
+              <a:t>Pigs Consumed = Net Harvest ÷ Harvest Yield;  Planned Labor carries the rework on every wasted pig.  Gains shown relative to the 25% base.</a:t>
+            </a:r>
+          </a:p>
+        </p:txBody>
+      </p:sp>
+      <p:graphicFrame>
+        <p:nvGraphicFramePr>
+          <p:cNvPr id="4" name="Table 3"/>
+          <p:cNvGraphicFramePr>
+            <a:graphicFrameLocks noGrp="1"/>
+          </p:cNvGraphicFramePr>
+          <p:nvPr/>
+        </p:nvGraphicFramePr>
+        <p:xfrm>
+          <a:off x="1188720" y="1828800"/>
+          <a:ext cx="9811512" cy="2606040"/>
+        </p:xfrm>
+        <a:graphic>
+          <a:graphicData uri="http://schemas.openxmlformats.org/drawingml/2006/table">
+            <a:tbl>
+              <a:tblPr>
+                <a:tableStyleId>{5C22544A-7EE6-4342-B048-85BDC9FD1C3A}</a:tableStyleId>
+              </a:tblPr>
+              <a:tblGrid>
+                <a:gridCol w="1490472"/>
+                <a:gridCol w="1600200"/>
+                <a:gridCol w="1691640"/>
+                <a:gridCol w="1691640"/>
+                <a:gridCol w="1691640"/>
+                <a:gridCol w="1645920"/>
+              </a:tblGrid>
+              <a:tr h="372291">
+                <a:tc>
+                  <a:txBody>
+                    <a:bodyPr/>
+                    <a:lstStyle/>
+                    <a:p>
+                      <a:pPr algn="ctr"/>
+                      <a:r>
+                        <a:rPr sz="1150" b="1">
+                          <a:solidFill>
+                            <a:srgbClr val="FFFFFF"/>
+                          </a:solidFill>
+                          <a:latin typeface="Calibri"/>
+                        </a:rPr>
+                        <a:t>Yield gain</a:t>
+                      </a:r>
+                    </a:p>
+                  </a:txBody>
+                  <a:tcPr anchor="ctr" marL="54864" marR="54864" marT="27432" marB="27432">
+                    <a:solidFill>
+                      <a:srgbClr val="12345B"/>
+                    </a:solidFill>
+                  </a:tcPr>
+                </a:tc>
+                <a:tc>
+                  <a:txBody>
+                    <a:bodyPr/>
+                    <a:lstStyle/>
+                    <a:p>
+                      <a:pPr algn="ctr"/>
+                      <a:r>
+                        <a:rPr sz="1150" b="1">
+                          <a:solidFill>
+                            <a:srgbClr val="FFFFFF"/>
+                          </a:solidFill>
+                          <a:latin typeface="Calibri"/>
+                        </a:rPr>
+                        <a:t>Harvest yield</a:t>
+                      </a:r>
+                    </a:p>
+                  </a:txBody>
+                  <a:tcPr anchor="ctr" marL="54864" marR="54864" marT="27432" marB="27432">
+                    <a:solidFill>
+                      <a:srgbClr val="12345B"/>
+                    </a:solidFill>
+                  </a:tcPr>
+                </a:tc>
+                <a:tc>
+                  <a:txBody>
+                    <a:bodyPr/>
+                    <a:lstStyle/>
+                    <a:p>
+                      <a:pPr algn="ctr"/>
+                      <a:r>
+                        <a:rPr sz="1150" b="1">
+                          <a:solidFill>
+                            <a:srgbClr val="FFFFFF"/>
+                          </a:solidFill>
+                          <a:latin typeface="Calibri"/>
+                        </a:rPr>
+                        <a:t>Pigs freed / wk</a:t>
+                      </a:r>
+                    </a:p>
+                  </a:txBody>
+                  <a:tcPr anchor="ctr" marL="54864" marR="54864" marT="27432" marB="27432">
+                    <a:solidFill>
+                      <a:srgbClr val="12345B"/>
+                    </a:solidFill>
+                  </a:tcPr>
+                </a:tc>
+                <a:tc>
+                  <a:txBody>
+                    <a:bodyPr/>
+                    <a:lstStyle/>
+                    <a:p>
+                      <a:pPr algn="ctr"/>
+                      <a:r>
+                        <a:rPr sz="1150" b="1">
+                          <a:solidFill>
+                            <a:srgbClr val="FFFFFF"/>
+                          </a:solidFill>
+                          <a:latin typeface="Calibri"/>
+                        </a:rPr>
+                        <a:t>Labor freed / wk</a:t>
+                      </a:r>
+                    </a:p>
+                  </a:txBody>
+                  <a:tcPr anchor="ctr" marL="54864" marR="54864" marT="27432" marB="27432">
+                    <a:solidFill>
+                      <a:srgbClr val="12345B"/>
+                    </a:solidFill>
+                  </a:tcPr>
+                </a:tc>
+                <a:tc>
+                  <a:txBody>
+                    <a:bodyPr/>
+                    <a:lstStyle/>
+                    <a:p>
+                      <a:pPr algn="ctr"/>
+                      <a:r>
+                        <a:rPr sz="1150" b="1">
+                          <a:solidFill>
+                            <a:srgbClr val="FFFFFF"/>
+                          </a:solidFill>
+                          <a:latin typeface="Calibri"/>
+                        </a:rPr>
+                        <a:t>Labor headroom</a:t>
+                      </a:r>
+                    </a:p>
+                  </a:txBody>
+                  <a:tcPr anchor="ctr" marL="54864" marR="54864" marT="27432" marB="27432">
+                    <a:solidFill>
+                      <a:srgbClr val="12345B"/>
+                    </a:solidFill>
+                  </a:tcPr>
+                </a:tc>
+                <a:tc>
+                  <a:txBody>
+                    <a:bodyPr/>
+                    <a:lstStyle/>
+                    <a:p>
+                      <a:pPr algn="ctr"/>
+                      <a:r>
+                        <a:rPr sz="1150" b="1">
+                          <a:solidFill>
+                            <a:srgbClr val="FFFFFF"/>
+                          </a:solidFill>
+                          <a:latin typeface="Calibri"/>
+                        </a:rPr>
+                        <a:t>Pig headroom</a:t>
+                      </a:r>
+                    </a:p>
+                  </a:txBody>
+                  <a:tcPr anchor="ctr" marL="54864" marR="54864" marT="27432" marB="27432">
+                    <a:solidFill>
+                      <a:srgbClr val="12345B"/>
+                    </a:solidFill>
+                  </a:tcPr>
+                </a:tc>
+              </a:tr>
+              <a:tr h="372291">
+                <a:tc>
+                  <a:txBody>
+                    <a:bodyPr/>
+                    <a:lstStyle/>
+                    <a:p>
+                      <a:pPr algn="ctr"/>
+                      <a:r>
+                        <a:rPr sz="1100" b="1">
+                          <a:solidFill>
+                            <a:srgbClr val="12345B"/>
+                          </a:solidFill>
+                          <a:latin typeface="Calibri"/>
+                        </a:rPr>
+                        <a:t>Today</a:t>
+                      </a:r>
+                    </a:p>
+                  </a:txBody>
+                  <a:tcPr anchor="ctr" marL="54864" marR="54864" marT="27432" marB="27432">
+                    <a:solidFill>
+                      <a:srgbClr val="E3E9F1"/>
+                    </a:solidFill>
+                  </a:tcPr>
+                </a:tc>
+                <a:tc>
+                  <a:txBody>
+                    <a:bodyPr/>
+                    <a:lstStyle/>
+                    <a:p>
+                      <a:pPr algn="ctr"/>
+                      <a:r>
+                        <a:rPr sz="1100" b="0">
+                          <a:solidFill>
+                            <a:srgbClr val="20303D"/>
+                          </a:solidFill>
+                          <a:latin typeface="Calibri"/>
+                        </a:rPr>
+                        <a:t>25.0%</a:t>
+                      </a:r>
+                    </a:p>
+                  </a:txBody>
+                  <a:tcPr anchor="ctr" marL="54864" marR="54864" marT="27432" marB="27432">
+                    <a:solidFill>
+                      <a:srgbClr val="E3E9F1"/>
+                    </a:solidFill>
+                  </a:tcPr>
+                </a:tc>
+                <a:tc>
+                  <a:txBody>
+                    <a:bodyPr/>
+                    <a:lstStyle/>
+                    <a:p>
+                      <a:pPr algn="ctr"/>
+                      <a:r>
+                        <a:rPr sz="1100" b="0">
+                          <a:solidFill>
+                            <a:srgbClr val="20303D"/>
+                          </a:solidFill>
+                          <a:latin typeface="Calibri"/>
+                        </a:rPr>
+                        <a:t>—</a:t>
+                      </a:r>
+                    </a:p>
+                  </a:txBody>
+                  <a:tcPr anchor="ctr" marL="54864" marR="54864" marT="27432" marB="27432">
+                    <a:solidFill>
+                      <a:srgbClr val="E3E9F1"/>
+                    </a:solidFill>
+                  </a:tcPr>
+                </a:tc>
+                <a:tc>
+                  <a:txBody>
+                    <a:bodyPr/>
+                    <a:lstStyle/>
+                    <a:p>
+                      <a:pPr algn="ctr"/>
+                      <a:r>
+                        <a:rPr sz="1100" b="0">
+                          <a:solidFill>
+                            <a:srgbClr val="20303D"/>
+                          </a:solidFill>
+                          <a:latin typeface="Calibri"/>
+                        </a:rPr>
+                        <a:t>—</a:t>
+                      </a:r>
+                    </a:p>
+                  </a:txBody>
+                  <a:tcPr anchor="ctr" marL="54864" marR="54864" marT="27432" marB="27432">
+                    <a:solidFill>
+                      <a:srgbClr val="E3E9F1"/>
+                    </a:solidFill>
+                  </a:tcPr>
+                </a:tc>
+                <a:tc>
+                  <a:txBody>
+                    <a:bodyPr/>
+                    <a:lstStyle/>
+                    <a:p>
+                      <a:pPr algn="ctr"/>
+                      <a:r>
+                        <a:rPr sz="1100" b="1">
+                          <a:solidFill>
+                            <a:srgbClr val="B0392B"/>
+                          </a:solidFill>
+                          <a:latin typeface="Calibri"/>
+                        </a:rPr>
+                        <a:t>1.01×</a:t>
+                      </a:r>
+                    </a:p>
+                  </a:txBody>
+                  <a:tcPr anchor="ctr" marL="54864" marR="54864" marT="27432" marB="27432">
+                    <a:solidFill>
+                      <a:srgbClr val="E3E9F1"/>
+                    </a:solidFill>
+                  </a:tcPr>
+                </a:tc>
+                <a:tc>
+                  <a:txBody>
+                    <a:bodyPr/>
+                    <a:lstStyle/>
+                    <a:p>
+                      <a:pPr algn="ctr"/>
+                      <a:r>
+                        <a:rPr sz="1100" b="1">
+                          <a:solidFill>
+                            <a:srgbClr val="B0392B"/>
+                          </a:solidFill>
+                          <a:latin typeface="Calibri"/>
+                        </a:rPr>
+                        <a:t>1.23×</a:t>
+                      </a:r>
+                    </a:p>
+                  </a:txBody>
+                  <a:tcPr anchor="ctr" marL="54864" marR="54864" marT="27432" marB="27432">
+                    <a:solidFill>
+                      <a:srgbClr val="E3E9F1"/>
+                    </a:solidFill>
+                  </a:tcPr>
+                </a:tc>
+              </a:tr>
+              <a:tr h="372291">
+                <a:tc>
+                  <a:txBody>
+                    <a:bodyPr/>
+                    <a:lstStyle/>
+                    <a:p>
+                      <a:pPr algn="ctr"/>
+                      <a:r>
+                        <a:rPr sz="1100" b="1">
+                          <a:solidFill>
+                            <a:srgbClr val="12345B"/>
+                          </a:solidFill>
+                          <a:latin typeface="Calibri"/>
+                        </a:rPr>
+                        <a:t>+5%</a:t>
+                      </a:r>
+                    </a:p>
+                  </a:txBody>
+                  <a:tcPr anchor="ctr" marL="54864" marR="54864" marT="27432" marB="27432">
+                    <a:solidFill>
+                      <a:srgbClr val="F2F5F9"/>
+                    </a:solidFill>
+                  </a:tcPr>
+                </a:tc>
+                <a:tc>
+                  <a:txBody>
+                    <a:bodyPr/>
+                    <a:lstStyle/>
+                    <a:p>
+                      <a:pPr algn="ctr"/>
+                      <a:r>
+                        <a:rPr sz="1100" b="0">
+                          <a:solidFill>
+                            <a:srgbClr val="20303D"/>
+                          </a:solidFill>
+                          <a:latin typeface="Calibri"/>
+                        </a:rPr>
+                        <a:t>26.3%</a:t>
+                      </a:r>
+                    </a:p>
+                  </a:txBody>
+                  <a:tcPr anchor="ctr" marL="54864" marR="54864" marT="27432" marB="27432">
+                    <a:solidFill>
+                      <a:srgbClr val="F2F5F9"/>
+                    </a:solidFill>
+                  </a:tcPr>
+                </a:tc>
+                <a:tc>
+                  <a:txBody>
+                    <a:bodyPr/>
+                    <a:lstStyle/>
+                    <a:p>
+                      <a:pPr algn="ctr"/>
+                      <a:r>
+                        <a:rPr sz="1100" b="0">
+                          <a:solidFill>
+                            <a:srgbClr val="20303D"/>
+                          </a:solidFill>
+                          <a:latin typeface="Calibri"/>
+                        </a:rPr>
+                        <a:t>41</a:t>
+                      </a:r>
+                    </a:p>
+                  </a:txBody>
+                  <a:tcPr anchor="ctr" marL="54864" marR="54864" marT="27432" marB="27432">
+                    <a:solidFill>
+                      <a:srgbClr val="F2F5F9"/>
+                    </a:solidFill>
+                  </a:tcPr>
+                </a:tc>
+                <a:tc>
+                  <a:txBody>
+                    <a:bodyPr/>
+                    <a:lstStyle/>
+                    <a:p>
+                      <a:pPr algn="ctr"/>
+                      <a:r>
+                        <a:rPr sz="1100" b="0">
+                          <a:solidFill>
+                            <a:srgbClr val="20303D"/>
+                          </a:solidFill>
+                          <a:latin typeface="Calibri"/>
+                        </a:rPr>
+                        <a:t>0.8 h</a:t>
+                      </a:r>
+                    </a:p>
+                  </a:txBody>
+                  <a:tcPr anchor="ctr" marL="54864" marR="54864" marT="27432" marB="27432">
+                    <a:solidFill>
+                      <a:srgbClr val="F2F5F9"/>
+                    </a:solidFill>
+                  </a:tcPr>
+                </a:tc>
+                <a:tc>
+                  <a:txBody>
+                    <a:bodyPr/>
+                    <a:lstStyle/>
+                    <a:p>
+                      <a:pPr algn="ctr"/>
+                      <a:r>
+                        <a:rPr sz="1100" b="1">
+                          <a:solidFill>
+                            <a:srgbClr val="B0392B"/>
+                          </a:solidFill>
+                          <a:latin typeface="Calibri"/>
+                        </a:rPr>
+                        <a:t>1.04×</a:t>
+                      </a:r>
+                    </a:p>
+                  </a:txBody>
+                  <a:tcPr anchor="ctr" marL="54864" marR="54864" marT="27432" marB="27432">
+                    <a:solidFill>
+                      <a:srgbClr val="F2F5F9"/>
+                    </a:solidFill>
+                  </a:tcPr>
+                </a:tc>
+                <a:tc>
+                  <a:txBody>
+                    <a:bodyPr/>
+                    <a:lstStyle/>
+                    <a:p>
+                      <a:pPr algn="ctr"/>
+                      <a:r>
+                        <a:rPr sz="1100" b="1">
+                          <a:solidFill>
+                            <a:srgbClr val="1E7F3E"/>
+                          </a:solidFill>
+                          <a:latin typeface="Calibri"/>
+                        </a:rPr>
+                        <a:t>1.29×</a:t>
+                      </a:r>
+                    </a:p>
+                  </a:txBody>
+                  <a:tcPr anchor="ctr" marL="54864" marR="54864" marT="27432" marB="27432">
+                    <a:solidFill>
+                      <a:srgbClr val="F2F5F9"/>
+                    </a:solidFill>
+                  </a:tcPr>
+                </a:tc>
+              </a:tr>
+              <a:tr h="372291">
+                <a:tc>
+                  <a:txBody>
+                    <a:bodyPr/>
+                    <a:lstStyle/>
+                    <a:p>
+                      <a:pPr algn="ctr"/>
+                      <a:r>
+                        <a:rPr sz="1100" b="1">
+                          <a:solidFill>
+                            <a:srgbClr val="12345B"/>
+                          </a:solidFill>
+                          <a:latin typeface="Calibri"/>
+                        </a:rPr>
+                        <a:t>+10%</a:t>
+                      </a:r>
+                    </a:p>
+                  </a:txBody>
+                  <a:tcPr anchor="ctr" marL="54864" marR="54864" marT="27432" marB="27432">
+                    <a:solidFill>
+                      <a:srgbClr val="FFFFFF"/>
+                    </a:solidFill>
+                  </a:tcPr>
+                </a:tc>
+                <a:tc>
+                  <a:txBody>
+                    <a:bodyPr/>
+                    <a:lstStyle/>
+                    <a:p>
+                      <a:pPr algn="ctr"/>
+                      <a:r>
+                        <a:rPr sz="1100" b="0">
+                          <a:solidFill>
+                            <a:srgbClr val="20303D"/>
+                          </a:solidFill>
+                          <a:latin typeface="Calibri"/>
+                        </a:rPr>
+                        <a:t>27.5%</a:t>
+                      </a:r>
+                    </a:p>
+                  </a:txBody>
+                  <a:tcPr anchor="ctr" marL="54864" marR="54864" marT="27432" marB="27432">
+                    <a:solidFill>
+                      <a:srgbClr val="FFFFFF"/>
+                    </a:solidFill>
+                  </a:tcPr>
+                </a:tc>
+                <a:tc>
+                  <a:txBody>
+                    <a:bodyPr/>
+                    <a:lstStyle/>
+                    <a:p>
+                      <a:pPr algn="ctr"/>
+                      <a:r>
+                        <a:rPr sz="1100" b="0">
+                          <a:solidFill>
+                            <a:srgbClr val="20303D"/>
+                          </a:solidFill>
+                          <a:latin typeface="Calibri"/>
+                        </a:rPr>
+                        <a:t>79</a:t>
+                      </a:r>
+                    </a:p>
+                  </a:txBody>
+                  <a:tcPr anchor="ctr" marL="54864" marR="54864" marT="27432" marB="27432">
+                    <a:solidFill>
+                      <a:srgbClr val="FFFFFF"/>
+                    </a:solidFill>
+                  </a:tcPr>
+                </a:tc>
+                <a:tc>
+                  <a:txBody>
+                    <a:bodyPr/>
+                    <a:lstStyle/>
+                    <a:p>
+                      <a:pPr algn="ctr"/>
+                      <a:r>
+                        <a:rPr sz="1100" b="0">
+                          <a:solidFill>
+                            <a:srgbClr val="20303D"/>
+                          </a:solidFill>
+                          <a:latin typeface="Calibri"/>
+                        </a:rPr>
+                        <a:t>1.5 h</a:t>
+                      </a:r>
+                    </a:p>
+                  </a:txBody>
+                  <a:tcPr anchor="ctr" marL="54864" marR="54864" marT="27432" marB="27432">
+                    <a:solidFill>
+                      <a:srgbClr val="FFFFFF"/>
+                    </a:solidFill>
+                  </a:tcPr>
+                </a:tc>
+                <a:tc>
+                  <a:txBody>
+                    <a:bodyPr/>
+                    <a:lstStyle/>
+                    <a:p>
+                      <a:pPr algn="ctr"/>
+                      <a:r>
+                        <a:rPr sz="1100" b="1">
+                          <a:solidFill>
+                            <a:srgbClr val="B0392B"/>
+                          </a:solidFill>
+                          <a:latin typeface="Calibri"/>
+                        </a:rPr>
+                        <a:t>1.06×</a:t>
+                      </a:r>
+                    </a:p>
+                  </a:txBody>
+                  <a:tcPr anchor="ctr" marL="54864" marR="54864" marT="27432" marB="27432">
+                    <a:solidFill>
+                      <a:srgbClr val="FFFFFF"/>
+                    </a:solidFill>
+                  </a:tcPr>
+                </a:tc>
+                <a:tc>
+                  <a:txBody>
+                    <a:bodyPr/>
+                    <a:lstStyle/>
+                    <a:p>
+                      <a:pPr algn="ctr"/>
+                      <a:r>
+                        <a:rPr sz="1100" b="1">
+                          <a:solidFill>
+                            <a:srgbClr val="1E7F3E"/>
+                          </a:solidFill>
+                          <a:latin typeface="Calibri"/>
+                        </a:rPr>
+                        <a:t>1.35×</a:t>
+                      </a:r>
+                    </a:p>
+                  </a:txBody>
+                  <a:tcPr anchor="ctr" marL="54864" marR="54864" marT="27432" marB="27432">
+                    <a:solidFill>
+                      <a:srgbClr val="FFFFFF"/>
+                    </a:solidFill>
+                  </a:tcPr>
+                </a:tc>
+              </a:tr>
+              <a:tr h="372291">
+                <a:tc>
+                  <a:txBody>
+                    <a:bodyPr/>
+                    <a:lstStyle/>
+                    <a:p>
+                      <a:pPr algn="ctr"/>
+                      <a:r>
+                        <a:rPr sz="1100" b="1">
+                          <a:solidFill>
+                            <a:srgbClr val="12345B"/>
+                          </a:solidFill>
+                          <a:latin typeface="Calibri"/>
+                        </a:rPr>
+                        <a:t>+15%</a:t>
+                      </a:r>
+                    </a:p>
+                  </a:txBody>
+                  <a:tcPr anchor="ctr" marL="54864" marR="54864" marT="27432" marB="27432">
+                    <a:solidFill>
+                      <a:srgbClr val="F2F5F9"/>
+                    </a:solidFill>
+                  </a:tcPr>
+                </a:tc>
+                <a:tc>
+                  <a:txBody>
+                    <a:bodyPr/>
+                    <a:lstStyle/>
+                    <a:p>
+                      <a:pPr algn="ctr"/>
+                      <a:r>
+                        <a:rPr sz="1100" b="0">
+                          <a:solidFill>
+                            <a:srgbClr val="20303D"/>
+                          </a:solidFill>
+                          <a:latin typeface="Calibri"/>
+                        </a:rPr>
+                        <a:t>28.8%</a:t>
+                      </a:r>
+                    </a:p>
+                  </a:txBody>
+                  <a:tcPr anchor="ctr" marL="54864" marR="54864" marT="27432" marB="27432">
+                    <a:solidFill>
+                      <a:srgbClr val="F2F5F9"/>
+                    </a:solidFill>
+                  </a:tcPr>
+                </a:tc>
+                <a:tc>
+                  <a:txBody>
+                    <a:bodyPr/>
+                    <a:lstStyle/>
+                    <a:p>
+                      <a:pPr algn="ctr"/>
+                      <a:r>
+                        <a:rPr sz="1100" b="0">
+                          <a:solidFill>
+                            <a:srgbClr val="20303D"/>
+                          </a:solidFill>
+                          <a:latin typeface="Calibri"/>
+                        </a:rPr>
+                        <a:t>113</a:t>
+                      </a:r>
+                    </a:p>
+                  </a:txBody>
+                  <a:tcPr anchor="ctr" marL="54864" marR="54864" marT="27432" marB="27432">
+                    <a:solidFill>
+                      <a:srgbClr val="F2F5F9"/>
+                    </a:solidFill>
+                  </a:tcPr>
+                </a:tc>
+                <a:tc>
+                  <a:txBody>
+                    <a:bodyPr/>
+                    <a:lstStyle/>
+                    <a:p>
+                      <a:pPr algn="ctr"/>
+                      <a:r>
+                        <a:rPr sz="1100" b="0">
+                          <a:solidFill>
+                            <a:srgbClr val="20303D"/>
+                          </a:solidFill>
+                          <a:latin typeface="Calibri"/>
+                        </a:rPr>
+                        <a:t>2.2 h</a:t>
+                      </a:r>
+                    </a:p>
+                  </a:txBody>
+                  <a:tcPr anchor="ctr" marL="54864" marR="54864" marT="27432" marB="27432">
+                    <a:solidFill>
+                      <a:srgbClr val="F2F5F9"/>
+                    </a:solidFill>
+                  </a:tcPr>
+                </a:tc>
+                <a:tc>
+                  <a:txBody>
+                    <a:bodyPr/>
+                    <a:lstStyle/>
+                    <a:p>
+                      <a:pPr algn="ctr"/>
+                      <a:r>
+                        <a:rPr sz="1100" b="1">
+                          <a:solidFill>
+                            <a:srgbClr val="B0392B"/>
+                          </a:solidFill>
+                          <a:latin typeface="Calibri"/>
+                        </a:rPr>
+                        <a:t>1.08×</a:t>
+                      </a:r>
+                    </a:p>
+                  </a:txBody>
+                  <a:tcPr anchor="ctr" marL="54864" marR="54864" marT="27432" marB="27432">
+                    <a:solidFill>
+                      <a:srgbClr val="F2F5F9"/>
+                    </a:solidFill>
+                  </a:tcPr>
+                </a:tc>
+                <a:tc>
+                  <a:txBody>
+                    <a:bodyPr/>
+                    <a:lstStyle/>
+                    <a:p>
+                      <a:pPr algn="ctr"/>
+                      <a:r>
+                        <a:rPr sz="1100" b="1">
+                          <a:solidFill>
+                            <a:srgbClr val="1E7F3E"/>
+                          </a:solidFill>
+                          <a:latin typeface="Calibri"/>
+                        </a:rPr>
+                        <a:t>1.40×</a:t>
+                      </a:r>
+                    </a:p>
+                  </a:txBody>
+                  <a:tcPr anchor="ctr" marL="54864" marR="54864" marT="27432" marB="27432">
+                    <a:solidFill>
+                      <a:srgbClr val="F2F5F9"/>
+                    </a:solidFill>
+                  </a:tcPr>
+                </a:tc>
+              </a:tr>
+              <a:tr h="372291">
+                <a:tc>
+                  <a:txBody>
+                    <a:bodyPr/>
+                    <a:lstStyle/>
+                    <a:p>
+                      <a:pPr algn="ctr"/>
+                      <a:r>
+                        <a:rPr sz="1100" b="1">
+                          <a:solidFill>
+                            <a:srgbClr val="12345B"/>
+                          </a:solidFill>
+                          <a:latin typeface="Calibri"/>
+                        </a:rPr>
+                        <a:t>+20%</a:t>
+                      </a:r>
+                    </a:p>
+                  </a:txBody>
+                  <a:tcPr anchor="ctr" marL="54864" marR="54864" marT="27432" marB="27432">
+                    <a:solidFill>
+                      <a:srgbClr val="FFFFFF"/>
+                    </a:solidFill>
+                  </a:tcPr>
+                </a:tc>
+                <a:tc>
+                  <a:txBody>
+                    <a:bodyPr/>
+                    <a:lstStyle/>
+                    <a:p>
+                      <a:pPr algn="ctr"/>
+                      <a:r>
+                        <a:rPr sz="1100" b="0">
+                          <a:solidFill>
+                            <a:srgbClr val="20303D"/>
+                          </a:solidFill>
+                          <a:latin typeface="Calibri"/>
+                        </a:rPr>
+                        <a:t>30.0%</a:t>
+                      </a:r>
+                    </a:p>
+                  </a:txBody>
+                  <a:tcPr anchor="ctr" marL="54864" marR="54864" marT="27432" marB="27432">
+                    <a:solidFill>
+                      <a:srgbClr val="FFFFFF"/>
+                    </a:solidFill>
+                  </a:tcPr>
+                </a:tc>
+                <a:tc>
+                  <a:txBody>
+                    <a:bodyPr/>
+                    <a:lstStyle/>
+                    <a:p>
+                      <a:pPr algn="ctr"/>
+                      <a:r>
+                        <a:rPr sz="1100" b="0">
+                          <a:solidFill>
+                            <a:srgbClr val="20303D"/>
+                          </a:solidFill>
+                          <a:latin typeface="Calibri"/>
+                        </a:rPr>
+                        <a:t>144</a:t>
+                      </a:r>
+                    </a:p>
+                  </a:txBody>
+                  <a:tcPr anchor="ctr" marL="54864" marR="54864" marT="27432" marB="27432">
+                    <a:solidFill>
+                      <a:srgbClr val="FFFFFF"/>
+                    </a:solidFill>
+                  </a:tcPr>
+                </a:tc>
+                <a:tc>
+                  <a:txBody>
+                    <a:bodyPr/>
+                    <a:lstStyle/>
+                    <a:p>
+                      <a:pPr algn="ctr"/>
+                      <a:r>
+                        <a:rPr sz="1100" b="0">
+                          <a:solidFill>
+                            <a:srgbClr val="20303D"/>
+                          </a:solidFill>
+                          <a:latin typeface="Calibri"/>
+                        </a:rPr>
+                        <a:t>2.8 h</a:t>
+                      </a:r>
+                    </a:p>
+                  </a:txBody>
+                  <a:tcPr anchor="ctr" marL="54864" marR="54864" marT="27432" marB="27432">
+                    <a:solidFill>
+                      <a:srgbClr val="FFFFFF"/>
+                    </a:solidFill>
+                  </a:tcPr>
+                </a:tc>
+                <a:tc>
+                  <a:txBody>
+                    <a:bodyPr/>
+                    <a:lstStyle/>
+                    <a:p>
+                      <a:pPr algn="ctr"/>
+                      <a:r>
+                        <a:rPr sz="1100" b="1">
+                          <a:solidFill>
+                            <a:srgbClr val="B0392B"/>
+                          </a:solidFill>
+                          <a:latin typeface="Calibri"/>
+                        </a:rPr>
+                        <a:t>1.10×</a:t>
+                      </a:r>
+                    </a:p>
+                  </a:txBody>
+                  <a:tcPr anchor="ctr" marL="54864" marR="54864" marT="27432" marB="27432">
+                    <a:solidFill>
+                      <a:srgbClr val="FFFFFF"/>
+                    </a:solidFill>
+                  </a:tcPr>
+                </a:tc>
+                <a:tc>
+                  <a:txBody>
+                    <a:bodyPr/>
+                    <a:lstStyle/>
+                    <a:p>
+                      <a:pPr algn="ctr"/>
+                      <a:r>
+                        <a:rPr sz="1100" b="1">
+                          <a:solidFill>
+                            <a:srgbClr val="1E7F3E"/>
+                          </a:solidFill>
+                          <a:latin typeface="Calibri"/>
+                        </a:rPr>
+                        <a:t>1.46×</a:t>
+                      </a:r>
+                    </a:p>
+                  </a:txBody>
+                  <a:tcPr anchor="ctr" marL="54864" marR="54864" marT="27432" marB="27432">
+                    <a:solidFill>
+                      <a:srgbClr val="FFFFFF"/>
+                    </a:solidFill>
+                  </a:tcPr>
+                </a:tc>
+              </a:tr>
+              <a:tr h="372294">
+                <a:tc>
+                  <a:txBody>
+                    <a:bodyPr/>
+                    <a:lstStyle/>
+                    <a:p>
+                      <a:pPr algn="ctr"/>
+                      <a:r>
+                        <a:rPr sz="1100" b="1">
+                          <a:solidFill>
+                            <a:srgbClr val="12345B"/>
+                          </a:solidFill>
+                          <a:latin typeface="Calibri"/>
+                        </a:rPr>
+                        <a:t>+25%</a:t>
+                      </a:r>
+                    </a:p>
+                  </a:txBody>
+                  <a:tcPr anchor="ctr" marL="54864" marR="54864" marT="27432" marB="27432">
+                    <a:solidFill>
+                      <a:srgbClr val="F2F5F9"/>
+                    </a:solidFill>
+                  </a:tcPr>
+                </a:tc>
+                <a:tc>
+                  <a:txBody>
+                    <a:bodyPr/>
+                    <a:lstStyle/>
+                    <a:p>
+                      <a:pPr algn="ctr"/>
+                      <a:r>
+                        <a:rPr sz="1100" b="0">
+                          <a:solidFill>
+                            <a:srgbClr val="20303D"/>
+                          </a:solidFill>
+                          <a:latin typeface="Calibri"/>
+                        </a:rPr>
+                        <a:t>31.3%</a:t>
+                      </a:r>
+                    </a:p>
+                  </a:txBody>
+                  <a:tcPr anchor="ctr" marL="54864" marR="54864" marT="27432" marB="27432">
+                    <a:solidFill>
+                      <a:srgbClr val="F2F5F9"/>
+                    </a:solidFill>
+                  </a:tcPr>
+                </a:tc>
+                <a:tc>
+                  <a:txBody>
+                    <a:bodyPr/>
+                    <a:lstStyle/>
+                    <a:p>
+                      <a:pPr algn="ctr"/>
+                      <a:r>
+                        <a:rPr sz="1100" b="0">
+                          <a:solidFill>
+                            <a:srgbClr val="20303D"/>
+                          </a:solidFill>
+                          <a:latin typeface="Calibri"/>
+                        </a:rPr>
+                        <a:t>173</a:t>
+                      </a:r>
+                    </a:p>
+                  </a:txBody>
+                  <a:tcPr anchor="ctr" marL="54864" marR="54864" marT="27432" marB="27432">
+                    <a:solidFill>
+                      <a:srgbClr val="F2F5F9"/>
+                    </a:solidFill>
+                  </a:tcPr>
+                </a:tc>
+                <a:tc>
+                  <a:txBody>
+                    <a:bodyPr/>
+                    <a:lstStyle/>
+                    <a:p>
+                      <a:pPr algn="ctr"/>
+                      <a:r>
+                        <a:rPr sz="1100" b="0">
+                          <a:solidFill>
+                            <a:srgbClr val="20303D"/>
+                          </a:solidFill>
+                          <a:latin typeface="Calibri"/>
+                        </a:rPr>
+                        <a:t>3.4 h</a:t>
+                      </a:r>
+                    </a:p>
+                  </a:txBody>
+                  <a:tcPr anchor="ctr" marL="54864" marR="54864" marT="27432" marB="27432">
+                    <a:solidFill>
+                      <a:srgbClr val="F2F5F9"/>
+                    </a:solidFill>
+                  </a:tcPr>
+                </a:tc>
+                <a:tc>
+                  <a:txBody>
+                    <a:bodyPr/>
+                    <a:lstStyle/>
+                    <a:p>
+                      <a:pPr algn="ctr"/>
+                      <a:r>
+                        <a:rPr sz="1100" b="1">
+                          <a:solidFill>
+                            <a:srgbClr val="B0392B"/>
+                          </a:solidFill>
+                          <a:latin typeface="Calibri"/>
+                        </a:rPr>
+                        <a:t>1.12×</a:t>
+                      </a:r>
+                    </a:p>
+                  </a:txBody>
+                  <a:tcPr anchor="ctr" marL="54864" marR="54864" marT="27432" marB="27432">
+                    <a:solidFill>
+                      <a:srgbClr val="F2F5F9"/>
+                    </a:solidFill>
+                  </a:tcPr>
+                </a:tc>
+                <a:tc>
+                  <a:txBody>
+                    <a:bodyPr/>
+                    <a:lstStyle/>
+                    <a:p>
+                      <a:pPr algn="ctr"/>
+                      <a:r>
+                        <a:rPr sz="1100" b="1">
+                          <a:solidFill>
+                            <a:srgbClr val="1E7F3E"/>
+                          </a:solidFill>
+                          <a:latin typeface="Calibri"/>
+                        </a:rPr>
+                        <a:t>1.52×</a:t>
+                      </a:r>
+                    </a:p>
+                  </a:txBody>
+                  <a:tcPr anchor="ctr" marL="54864" marR="54864" marT="27432" marB="27432">
+                    <a:solidFill>
+                      <a:srgbClr val="F2F5F9"/>
+                    </a:solidFill>
+                  </a:tcPr>
+                </a:tc>
+              </a:tr>
+            </a:tbl>
+          </a:graphicData>
+        </a:graphic>
+      </p:graphicFrame>
+      <p:sp>
+        <p:nvSpPr>
+          <p:cNvPr id="5" name="TextBox 4"/>
+          <p:cNvSpPr txBox="1"/>
+          <p:nvPr/>
+        </p:nvSpPr>
+        <p:spPr>
+          <a:xfrm>
+            <a:off x="1188720" y="4617720"/>
+            <a:ext cx="9811512" cy="548640"/>
+          </a:xfrm>
+          <a:prstGeom prst="rect">
+            <a:avLst/>
+          </a:prstGeom>
+          <a:noFill/>
+        </p:spPr>
+        <p:txBody>
+          <a:bodyPr wrap="square">
+            <a:spAutoFit/>
+          </a:bodyPr>
+          <a:lstStyle/>
+          <a:p>
+            <a:pPr algn="l"/>
+            <a:r>
+              <a:rPr sz="1100" b="1">
+                <a:solidFill>
+                  <a:srgbClr val="12345B"/>
+                </a:solidFill>
+                <a:latin typeface="Calibri"/>
+              </a:rPr>
+              <a:t>How to read:  </a:t>
+            </a:r>
+            <a:r>
+              <a:rPr sz="1100" b="0">
+                <a:solidFill>
+                  <a:srgbClr val="20303D"/>
+                </a:solidFill>
+                <a:latin typeface="Calibri"/>
+              </a:rPr>
+              <a:t>pigs clear the 125% target by +5%, but labor — the binding constraint at Martins — reaches only 1.12× even at +25%. Yield helps materially, yet labor still needs re-balancing off Martins (Milestone 3).</a:t>
+            </a:r>
+          </a:p>
+        </p:txBody>
+      </p:sp>
+      <p:sp>
+        <p:nvSpPr>
+          <p:cNvPr id="6" name="TextBox 5"/>
+          <p:cNvSpPr txBox="1"/>
+          <p:nvPr/>
+        </p:nvSpPr>
+        <p:spPr>
+          <a:xfrm>
+            <a:off x="457200" y="6473952"/>
+            <a:ext cx="11274552" cy="274320"/>
+          </a:xfrm>
+          <a:prstGeom prst="rect">
+            <a:avLst/>
+          </a:prstGeom>
+          <a:noFill/>
+        </p:spPr>
+        <p:txBody>
+          <a:bodyPr wrap="square">
+            <a:spAutoFit/>
+          </a:bodyPr>
+          <a:lstStyle/>
+          <a:p>
+            <a:pPr algn="l"/>
+            <a:r>
+              <a:rPr sz="850" b="0">
+                <a:solidFill>
+                  <a:srgbClr val="5A6A7A"/>
+                </a:solidFill>
+                <a:latin typeface="Calibri"/>
+              </a:rPr>
+              <a:t>Source: Part_Supplier_RiskAssessmentTool_v2.xlsx · Tissue_Model (666541 + 666506 @ Martins).  Headroom = 1 ÷ binding-constraint utilization at busiest-quarter 2027 demand.</a:t>
             </a:r>
           </a:p>
         </p:txBody>

</xml_diff>

<commit_message>
Switch pelvic yield sensitivity to percentage points
- Model yield gains as +5..+25 percentage points (yield 30%→50%) instead
  of relative. Labor headroom now crosses 1.25x at +20 pts (yield 45%);
  pigs clear immediately.
- Deck slide 3 reference table + model "Pelvic Yield Sensitivity" sheet
  updated to the points basis (headroom color-coding shows the labor
  crossing). 6 model charts preserved.
- Reword slide-1 highlighted finding: +10 pts frees ~246 pigs & ~4.8
  labor-hrs/wk; ~+20 pts clears 125% on labor.

Co-Authored-By: Claude Opus 4.8 <noreply@anthropic.com>
Claude-Session: https://claude.ai/code/session_01LKMb7stbjGviiyFb298aFR
</commit_message>
<xml_diff>
--- a/tissue-capacity-model/deliverables/Tissue_Capacity_2026_2027.pptx
+++ b/tissue-capacity-model/deliverables/Tissue_Capacity_2026_2027.pptx
@@ -1547,7 +1547,7 @@
                 </a:solidFill>
                 <a:latin typeface="Calibri"/>
               </a:rPr>
-              <a:t>   ▸ A pelvic-yield fix pays back fast: +10% harvest yield frees ~79 pigs and ~1.5 labor-hrs/wk at Martins — see slide 3 for the full 5–25% sensitivity.</a:t>
+              <a:t>   ▸ Lifting pelvic harvest yield pays back hard: +10 pts (25%→35%) frees ~246 pigs &amp; ~4.8 labor-hrs/wk at Martins, and ~+20 pts (→45%) finally clears 125% on labor — see slide 3.</a:t>
             </a:r>
             <a:endParaRPr lang="en-US" sz="1450" dirty="0"/>
           </a:p>
@@ -5683,7 +5683,6 @@
           </a:bodyPr>
           <a:lstStyle/>
           <a:p>
-            <a:pPr algn="l"/>
             <a:r>
               <a:rPr sz="2400" b="1">
                 <a:solidFill>
@@ -5718,7 +5717,6 @@
           </a:bodyPr>
           <a:lstStyle/>
           <a:p>
-            <a:pPr algn="l"/>
             <a:r>
               <a:rPr sz="1200" b="1">
                 <a:solidFill>
@@ -5735,7 +5733,7 @@
                 </a:solidFill>
                 <a:latin typeface="Calibri"/>
               </a:rPr>
-              <a:t>Capacity returned at Martins if the pelvic-block study lifts harvesting yield above today's 25%. Follows the Tissue_Model exactly: </a:t>
+              <a:t>Capacity returned at Martins if the pelvic-block study lifts harvesting yield above today's 25%. Follows the Tissue_Model: </a:t>
             </a:r>
             <a:r>
               <a:rPr sz="1100" b="0">
@@ -5744,7 +5742,7 @@
                 </a:solidFill>
                 <a:latin typeface="Calibri"/>
               </a:rPr>
-              <a:t>Pigs Consumed = Net Harvest ÷ Harvest Yield;  Planned Labor carries the rework on every wasted pig.  Gains shown relative to the 25% base.</a:t>
+              <a:t>Pigs Consumed = Net Harvest ÷ Harvest Yield;  Planned Labor carries the rework on every wasted pig.  Gains shown as percentage points above the 25% base.</a:t>
             </a:r>
           </a:p>
         </p:txBody>
@@ -5952,7 +5950,7 @@
                           </a:solidFill>
                           <a:latin typeface="Calibri"/>
                         </a:rPr>
-                        <a:t>25.0%</a:t>
+                        <a:t>25%</a:t>
                       </a:r>
                     </a:p>
                   </a:txBody>
@@ -6069,7 +6067,7 @@
                           </a:solidFill>
                           <a:latin typeface="Calibri"/>
                         </a:rPr>
-                        <a:t>+5%</a:t>
+                        <a:t>+5 pts</a:t>
                       </a:r>
                     </a:p>
                   </a:txBody>
@@ -6092,7 +6090,7 @@
                           </a:solidFill>
                           <a:latin typeface="Calibri"/>
                         </a:rPr>
-                        <a:t>26.3%</a:t>
+                        <a:t>30%</a:t>
                       </a:r>
                     </a:p>
                   </a:txBody>
@@ -6115,7 +6113,7 @@
                           </a:solidFill>
                           <a:latin typeface="Calibri"/>
                         </a:rPr>
-                        <a:t>41</a:t>
+                        <a:t>144</a:t>
                       </a:r>
                     </a:p>
                   </a:txBody>
@@ -6138,7 +6136,7 @@
                           </a:solidFill>
                           <a:latin typeface="Calibri"/>
                         </a:rPr>
-                        <a:t>0.8 h</a:t>
+                        <a:t>2.8 h</a:t>
                       </a:r>
                     </a:p>
                   </a:txBody>
@@ -6161,7 +6159,7 @@
                           </a:solidFill>
                           <a:latin typeface="Calibri"/>
                         </a:rPr>
-                        <a:t>1.04×</a:t>
+                        <a:t>1.10×</a:t>
                       </a:r>
                     </a:p>
                   </a:txBody>
@@ -6184,7 +6182,7 @@
                           </a:solidFill>
                           <a:latin typeface="Calibri"/>
                         </a:rPr>
-                        <a:t>1.29×</a:t>
+                        <a:t>1.46×</a:t>
                       </a:r>
                     </a:p>
                   </a:txBody>
@@ -6209,7 +6207,7 @@
                           </a:solidFill>
                           <a:latin typeface="Calibri"/>
                         </a:rPr>
-                        <a:t>+10%</a:t>
+                        <a:t>+10 pts</a:t>
                       </a:r>
                     </a:p>
                   </a:txBody>
@@ -6232,7 +6230,7 @@
                           </a:solidFill>
                           <a:latin typeface="Calibri"/>
                         </a:rPr>
-                        <a:t>27.5%</a:t>
+                        <a:t>35%</a:t>
                       </a:r>
                     </a:p>
                   </a:txBody>
@@ -6255,7 +6253,7 @@
                           </a:solidFill>
                           <a:latin typeface="Calibri"/>
                         </a:rPr>
-                        <a:t>79</a:t>
+                        <a:t>246</a:t>
                       </a:r>
                     </a:p>
                   </a:txBody>
@@ -6278,7 +6276,7 @@
                           </a:solidFill>
                           <a:latin typeface="Calibri"/>
                         </a:rPr>
-                        <a:t>1.5 h</a:t>
+                        <a:t>4.8 h</a:t>
                       </a:r>
                     </a:p>
                   </a:txBody>
@@ -6301,7 +6299,7 @@
                           </a:solidFill>
                           <a:latin typeface="Calibri"/>
                         </a:rPr>
-                        <a:t>1.06×</a:t>
+                        <a:t>1.17×</a:t>
                       </a:r>
                     </a:p>
                   </a:txBody>
@@ -6324,7 +6322,7 @@
                           </a:solidFill>
                           <a:latin typeface="Calibri"/>
                         </a:rPr>
-                        <a:t>1.35×</a:t>
+                        <a:t>1.68×</a:t>
                       </a:r>
                     </a:p>
                   </a:txBody>
@@ -6349,7 +6347,7 @@
                           </a:solidFill>
                           <a:latin typeface="Calibri"/>
                         </a:rPr>
-                        <a:t>+15%</a:t>
+                        <a:t>+15 pts</a:t>
                       </a:r>
                     </a:p>
                   </a:txBody>
@@ -6372,7 +6370,7 @@
                           </a:solidFill>
                           <a:latin typeface="Calibri"/>
                         </a:rPr>
-                        <a:t>28.8%</a:t>
+                        <a:t>40%</a:t>
                       </a:r>
                     </a:p>
                   </a:txBody>
@@ -6395,7 +6393,7 @@
                           </a:solidFill>
                           <a:latin typeface="Calibri"/>
                         </a:rPr>
-                        <a:t>113</a:t>
+                        <a:t>324</a:t>
                       </a:r>
                     </a:p>
                   </a:txBody>
@@ -6418,7 +6416,7 @@
                           </a:solidFill>
                           <a:latin typeface="Calibri"/>
                         </a:rPr>
-                        <a:t>2.2 h</a:t>
+                        <a:t>6.3 h</a:t>
                       </a:r>
                     </a:p>
                   </a:txBody>
@@ -6441,7 +6439,7 @@
                           </a:solidFill>
                           <a:latin typeface="Calibri"/>
                         </a:rPr>
-                        <a:t>1.08×</a:t>
+                        <a:t>1.23×</a:t>
                       </a:r>
                     </a:p>
                   </a:txBody>
@@ -6464,7 +6462,7 @@
                           </a:solidFill>
                           <a:latin typeface="Calibri"/>
                         </a:rPr>
-                        <a:t>1.40×</a:t>
+                        <a:t>1.90×</a:t>
                       </a:r>
                     </a:p>
                   </a:txBody>
@@ -6489,7 +6487,7 @@
                           </a:solidFill>
                           <a:latin typeface="Calibri"/>
                         </a:rPr>
-                        <a:t>+20%</a:t>
+                        <a:t>+20 pts</a:t>
                       </a:r>
                     </a:p>
                   </a:txBody>
@@ -6512,7 +6510,7 @@
                           </a:solidFill>
                           <a:latin typeface="Calibri"/>
                         </a:rPr>
-                        <a:t>30.0%</a:t>
+                        <a:t>45%</a:t>
                       </a:r>
                     </a:p>
                   </a:txBody>
@@ -6535,7 +6533,7 @@
                           </a:solidFill>
                           <a:latin typeface="Calibri"/>
                         </a:rPr>
-                        <a:t>144</a:t>
+                        <a:t>384</a:t>
                       </a:r>
                     </a:p>
                   </a:txBody>
@@ -6558,30 +6556,7 @@
                           </a:solidFill>
                           <a:latin typeface="Calibri"/>
                         </a:rPr>
-                        <a:t>2.8 h</a:t>
-                      </a:r>
-                    </a:p>
-                  </a:txBody>
-                  <a:tcPr anchor="ctr" marL="54864" marR="54864" marT="27432" marB="27432">
-                    <a:solidFill>
-                      <a:srgbClr val="FFFFFF"/>
-                    </a:solidFill>
-                  </a:tcPr>
-                </a:tc>
-                <a:tc>
-                  <a:txBody>
-                    <a:bodyPr/>
-                    <a:lstStyle/>
-                    <a:p>
-                      <a:pPr algn="ctr"/>
-                      <a:r>
-                        <a:rPr sz="1100" b="1">
-                          <a:solidFill>
-                            <a:srgbClr val="B0392B"/>
-                          </a:solidFill>
-                          <a:latin typeface="Calibri"/>
-                        </a:rPr>
-                        <a:t>1.10×</a:t>
+                        <a:t>7.5 h</a:t>
                       </a:r>
                     </a:p>
                   </a:txBody>
@@ -6604,7 +6579,30 @@
                           </a:solidFill>
                           <a:latin typeface="Calibri"/>
                         </a:rPr>
-                        <a:t>1.46×</a:t>
+                        <a:t>1.28×</a:t>
+                      </a:r>
+                    </a:p>
+                  </a:txBody>
+                  <a:tcPr anchor="ctr" marL="54864" marR="54864" marT="27432" marB="27432">
+                    <a:solidFill>
+                      <a:srgbClr val="FFFFFF"/>
+                    </a:solidFill>
+                  </a:tcPr>
+                </a:tc>
+                <a:tc>
+                  <a:txBody>
+                    <a:bodyPr/>
+                    <a:lstStyle/>
+                    <a:p>
+                      <a:pPr algn="ctr"/>
+                      <a:r>
+                        <a:rPr sz="1100" b="1">
+                          <a:solidFill>
+                            <a:srgbClr val="1E7F3E"/>
+                          </a:solidFill>
+                          <a:latin typeface="Calibri"/>
+                        </a:rPr>
+                        <a:t>2.12×</a:t>
                       </a:r>
                     </a:p>
                   </a:txBody>
@@ -6629,7 +6627,7 @@
                           </a:solidFill>
                           <a:latin typeface="Calibri"/>
                         </a:rPr>
-                        <a:t>+25%</a:t>
+                        <a:t>+25 pts</a:t>
                       </a:r>
                     </a:p>
                   </a:txBody>
@@ -6652,7 +6650,7 @@
                           </a:solidFill>
                           <a:latin typeface="Calibri"/>
                         </a:rPr>
-                        <a:t>31.3%</a:t>
+                        <a:t>50%</a:t>
                       </a:r>
                     </a:p>
                   </a:txBody>
@@ -6675,7 +6673,7 @@
                           </a:solidFill>
                           <a:latin typeface="Calibri"/>
                         </a:rPr>
-                        <a:t>173</a:t>
+                        <a:t>432</a:t>
                       </a:r>
                     </a:p>
                   </a:txBody>
@@ -6698,30 +6696,7 @@
                           </a:solidFill>
                           <a:latin typeface="Calibri"/>
                         </a:rPr>
-                        <a:t>3.4 h</a:t>
-                      </a:r>
-                    </a:p>
-                  </a:txBody>
-                  <a:tcPr anchor="ctr" marL="54864" marR="54864" marT="27432" marB="27432">
-                    <a:solidFill>
-                      <a:srgbClr val="F2F5F9"/>
-                    </a:solidFill>
-                  </a:tcPr>
-                </a:tc>
-                <a:tc>
-                  <a:txBody>
-                    <a:bodyPr/>
-                    <a:lstStyle/>
-                    <a:p>
-                      <a:pPr algn="ctr"/>
-                      <a:r>
-                        <a:rPr sz="1100" b="1">
-                          <a:solidFill>
-                            <a:srgbClr val="B0392B"/>
-                          </a:solidFill>
-                          <a:latin typeface="Calibri"/>
-                        </a:rPr>
-                        <a:t>1.12×</a:t>
+                        <a:t>8.4 h</a:t>
                       </a:r>
                     </a:p>
                   </a:txBody>
@@ -6744,7 +6719,30 @@
                           </a:solidFill>
                           <a:latin typeface="Calibri"/>
                         </a:rPr>
-                        <a:t>1.52×</a:t>
+                        <a:t>1.33×</a:t>
+                      </a:r>
+                    </a:p>
+                  </a:txBody>
+                  <a:tcPr anchor="ctr" marL="54864" marR="54864" marT="27432" marB="27432">
+                    <a:solidFill>
+                      <a:srgbClr val="F2F5F9"/>
+                    </a:solidFill>
+                  </a:tcPr>
+                </a:tc>
+                <a:tc>
+                  <a:txBody>
+                    <a:bodyPr/>
+                    <a:lstStyle/>
+                    <a:p>
+                      <a:pPr algn="ctr"/>
+                      <a:r>
+                        <a:rPr sz="1100" b="1">
+                          <a:solidFill>
+                            <a:srgbClr val="1E7F3E"/>
+                          </a:solidFill>
+                          <a:latin typeface="Calibri"/>
+                        </a:rPr>
+                        <a:t>2.33×</a:t>
                       </a:r>
                     </a:p>
                   </a:txBody>
@@ -6768,7 +6766,7 @@
         <p:spPr>
           <a:xfrm>
             <a:off x="1188720" y="4617720"/>
-            <a:ext cx="9811512" cy="548640"/>
+            <a:ext cx="9811512" cy="640080"/>
           </a:xfrm>
           <a:prstGeom prst="rect">
             <a:avLst/>
@@ -6781,7 +6779,6 @@
           </a:bodyPr>
           <a:lstStyle/>
           <a:p>
-            <a:pPr algn="l"/>
             <a:r>
               <a:rPr sz="1100" b="1">
                 <a:solidFill>
@@ -6798,7 +6795,7 @@
                 </a:solidFill>
                 <a:latin typeface="Calibri"/>
               </a:rPr>
-              <a:t>pigs clear the 125% target by +5%, but labor — the binding constraint at Martins — reaches only 1.12× even at +25%. Yield helps materially, yet labor still needs re-balancing off Martins (Milestone 3).</a:t>
+              <a:t>pigs clear the 125% target immediately, but labor — the binding constraint at Martins — needs about +20 points (yield to 45%) to cross 1.25×. Yield is the lever, yet a sizeable lift is required, so pair it with re-balancing labor off Martins (Milestone 3).</a:t>
             </a:r>
           </a:p>
         </p:txBody>
@@ -6825,7 +6822,6 @@
           </a:bodyPr>
           <a:lstStyle/>
           <a:p>
-            <a:pPr algn="l"/>
             <a:r>
               <a:rPr sz="850" b="0">
                 <a:solidFill>

</xml_diff>

<commit_message>
Adopt user's revised deck as canonical baseline
Replace the deliverable deck with the user's uploaded revision
(Tissue_Capacity_2026_2027_2.pptx): keeps the prior content (flat-250
chart with zeros excluded, slide-1 finding, slide-3 sensitivity in
percentage points) and adds their manual edits — milestone progress
notes, slide-1 table legend labels, and "Seasonality" added to the
slide-2 culprits. Future deck edits build on this file.

Co-Authored-By: Claude Opus 4.8 <noreply@anthropic.com>
Claude-Session: https://claude.ai/code/session_01LKMb7stbjGviiyFb298aFR
</commit_message>
<xml_diff>
--- a/tissue-capacity-model/deliverables/Tissue_Capacity_2026_2027.pptx
+++ b/tissue-capacity-model/deliverables/Tissue_Capacity_2026_2027.pptx
@@ -5,12 +5,12 @@
     <p:sldMasterId id="2147483648" r:id="rId1"/>
   </p:sldMasterIdLst>
   <p:notesMasterIdLst>
-    <p:notesMasterId r:id="rId4"/>
+    <p:notesMasterId r:id="rId5"/>
   </p:notesMasterIdLst>
   <p:sldIdLst>
     <p:sldId id="256" r:id="rId2"/>
     <p:sldId id="257" r:id="rId3"/>
-    <p:sldId id="258" r:id="rId9"/>
+    <p:sldId id="258" r:id="rId4"/>
   </p:sldIdLst>
   <p:sldSz cx="12192000" cy="6858000"/>
   <p:notesSz cx="6858000" cy="12192000"/>
@@ -232,10 +232,10 @@
                   <c:v>85.6</c:v>
                 </c:pt>
                 <c:pt idx="9">
-                  <c:v>69.4</c:v>
+                  <c:v>69.400000000000006</c:v>
                 </c:pt>
                 <c:pt idx="10">
-                  <c:v>78.6</c:v>
+                  <c:v>78.599999999999994</c:v>
                 </c:pt>
                 <c:pt idx="11">
                   <c:v>49.4</c:v>
@@ -1401,7 +1401,7 @@
         </p:nvSpPr>
         <p:spPr>
           <a:xfrm>
-            <a:off x="457200" y="1298448"/>
+            <a:off x="489463" y="1133856"/>
             <a:ext cx="11274552" cy="676656"/>
           </a:xfrm>
           <a:prstGeom prst="roundRect">
@@ -1442,7 +1442,7 @@
         </p:nvSpPr>
         <p:spPr>
           <a:xfrm>
-            <a:off x="713232" y="1545336"/>
+            <a:off x="551688" y="1472183"/>
             <a:ext cx="182880" cy="182880"/>
           </a:xfrm>
           <a:prstGeom prst="ellipse">
@@ -1469,7 +1469,7 @@
         </p:nvSpPr>
         <p:spPr>
           <a:xfrm>
-            <a:off x="1024128" y="1298448"/>
+            <a:off x="896112" y="1134287"/>
             <a:ext cx="10561320" cy="676656"/>
           </a:xfrm>
           <a:prstGeom prst="rect">
@@ -1541,13 +1541,49 @@
               <a:t>, so it cannot cover 125% of 2027 demand. Every other site clears 125%.</a:t>
             </a:r>
             <a:r>
-              <a:rPr sz="1100" b="1" i="1">
+              <a:rPr sz="1100" b="1" i="1" dirty="0">
                 <a:solidFill>
                   <a:srgbClr val="12345B"/>
                 </a:solidFill>
                 <a:latin typeface="Calibri"/>
               </a:rPr>
-              <a:t>   ▸ Lifting pelvic harvest yield pays back hard: +10 pts (25%→35%) frees ~246 pigs &amp; ~4.8 labor-hrs/wk at Martins, and ~+20 pts (→45%) finally clears 125% on labor — see slide 3.</a:t>
+              <a:t>   ▸ Lifting pelvic harvest yield pays back hard: +10 pts (25%→35%) frees ~246 pigs &amp; ~4.8 labor-</a:t>
+            </a:r>
+            <a:r>
+              <a:rPr sz="1100" b="1" i="1" dirty="0" err="1">
+                <a:solidFill>
+                  <a:srgbClr val="12345B"/>
+                </a:solidFill>
+                <a:latin typeface="Calibri"/>
+              </a:rPr>
+              <a:t>hrs</a:t>
+            </a:r>
+            <a:r>
+              <a:rPr sz="1100" b="1" i="1" dirty="0">
+                <a:solidFill>
+                  <a:srgbClr val="12345B"/>
+                </a:solidFill>
+                <a:latin typeface="Calibri"/>
+              </a:rPr>
+              <a:t>/</a:t>
+            </a:r>
+            <a:r>
+              <a:rPr sz="1100" b="1" i="1" dirty="0" err="1">
+                <a:solidFill>
+                  <a:srgbClr val="12345B"/>
+                </a:solidFill>
+                <a:latin typeface="Calibri"/>
+              </a:rPr>
+              <a:t>wk</a:t>
+            </a:r>
+            <a:r>
+              <a:rPr sz="1100" b="1" i="1" dirty="0">
+                <a:solidFill>
+                  <a:srgbClr val="12345B"/>
+                </a:solidFill>
+                <a:latin typeface="Calibri"/>
+              </a:rPr>
+              <a:t> at Martins, and ~+20 pts (→45%) finally clears 125% on labor — see slide 3.</a:t>
             </a:r>
             <a:endParaRPr lang="en-US" sz="1450" dirty="0"/>
           </a:p>
@@ -1591,7 +1627,7 @@
         </p:nvSpPr>
         <p:spPr>
           <a:xfrm>
-            <a:off x="457200" y="2249424"/>
+            <a:off x="451104" y="2098436"/>
             <a:ext cx="6400800" cy="237744"/>
           </a:xfrm>
           <a:prstGeom prst="rect">
@@ -1630,7 +1666,7 @@
         </p:nvSpPr>
         <p:spPr>
           <a:xfrm>
-            <a:off x="457200" y="2596896"/>
+            <a:off x="457200" y="2299396"/>
             <a:ext cx="1097280" cy="365760"/>
           </a:xfrm>
           <a:prstGeom prst="rect">
@@ -1669,7 +1705,7 @@
         </p:nvSpPr>
         <p:spPr>
           <a:xfrm>
-            <a:off x="1627632" y="2596896"/>
+            <a:off x="1627632" y="2299396"/>
             <a:ext cx="731520" cy="365760"/>
           </a:xfrm>
           <a:prstGeom prst="rect">
@@ -1708,7 +1744,7 @@
         </p:nvSpPr>
         <p:spPr>
           <a:xfrm>
-            <a:off x="2359152" y="2596896"/>
+            <a:off x="2359152" y="2299396"/>
             <a:ext cx="731520" cy="365760"/>
           </a:xfrm>
           <a:prstGeom prst="rect">
@@ -1747,7 +1783,7 @@
         </p:nvSpPr>
         <p:spPr>
           <a:xfrm>
-            <a:off x="3090672" y="2596896"/>
+            <a:off x="3090672" y="2299396"/>
             <a:ext cx="731520" cy="365760"/>
           </a:xfrm>
           <a:prstGeom prst="rect">
@@ -1786,7 +1822,7 @@
         </p:nvSpPr>
         <p:spPr>
           <a:xfrm>
-            <a:off x="3968496" y="2596896"/>
+            <a:off x="3968496" y="2299396"/>
             <a:ext cx="1737360" cy="365760"/>
           </a:xfrm>
           <a:prstGeom prst="rect">
@@ -1825,7 +1861,7 @@
         </p:nvSpPr>
         <p:spPr>
           <a:xfrm>
-            <a:off x="5907024" y="2596896"/>
+            <a:off x="5907024" y="2299396"/>
             <a:ext cx="1088136" cy="365760"/>
           </a:xfrm>
           <a:prstGeom prst="rect">
@@ -1864,7 +1900,7 @@
         </p:nvSpPr>
         <p:spPr>
           <a:xfrm>
-            <a:off x="457200" y="2962656"/>
+            <a:off x="457200" y="2665156"/>
             <a:ext cx="6537960" cy="0"/>
           </a:xfrm>
           <a:prstGeom prst="line">
@@ -1894,7 +1930,7 @@
         </p:nvSpPr>
         <p:spPr>
           <a:xfrm>
-            <a:off x="457200" y="3081528"/>
+            <a:off x="457200" y="2784028"/>
             <a:ext cx="1143000" cy="274320"/>
           </a:xfrm>
           <a:prstGeom prst="rect">
@@ -1933,7 +1969,7 @@
         </p:nvSpPr>
         <p:spPr>
           <a:xfrm>
-            <a:off x="457200" y="3355848"/>
+            <a:off x="457200" y="3058348"/>
             <a:ext cx="1188720" cy="237744"/>
           </a:xfrm>
           <a:prstGeom prst="rect">
@@ -1972,7 +2008,7 @@
         </p:nvSpPr>
         <p:spPr>
           <a:xfrm>
-            <a:off x="1682496" y="3172968"/>
+            <a:off x="1682496" y="2875468"/>
             <a:ext cx="621792" cy="329184"/>
           </a:xfrm>
           <a:prstGeom prst="roundRect">
@@ -2001,7 +2037,7 @@
         </p:nvSpPr>
         <p:spPr>
           <a:xfrm>
-            <a:off x="1627632" y="3154680"/>
+            <a:off x="1627632" y="2857180"/>
             <a:ext cx="731520" cy="365760"/>
           </a:xfrm>
           <a:prstGeom prst="rect">
@@ -2040,7 +2076,7 @@
         </p:nvSpPr>
         <p:spPr>
           <a:xfrm>
-            <a:off x="2414016" y="3172968"/>
+            <a:off x="2414016" y="2875468"/>
             <a:ext cx="621792" cy="329184"/>
           </a:xfrm>
           <a:prstGeom prst="roundRect">
@@ -2069,7 +2105,7 @@
         </p:nvSpPr>
         <p:spPr>
           <a:xfrm>
-            <a:off x="2359152" y="3154680"/>
+            <a:off x="2359152" y="2857180"/>
             <a:ext cx="731520" cy="365760"/>
           </a:xfrm>
           <a:prstGeom prst="rect">
@@ -2108,7 +2144,7 @@
         </p:nvSpPr>
         <p:spPr>
           <a:xfrm>
-            <a:off x="3145536" y="3172968"/>
+            <a:off x="3145536" y="2875468"/>
             <a:ext cx="621792" cy="329184"/>
           </a:xfrm>
           <a:prstGeom prst="roundRect">
@@ -2137,7 +2173,7 @@
         </p:nvSpPr>
         <p:spPr>
           <a:xfrm>
-            <a:off x="3090672" y="3154680"/>
+            <a:off x="3090672" y="2857180"/>
             <a:ext cx="731520" cy="365760"/>
           </a:xfrm>
           <a:prstGeom prst="rect">
@@ -2176,7 +2212,7 @@
         </p:nvSpPr>
         <p:spPr>
           <a:xfrm>
-            <a:off x="3968496" y="3259836"/>
+            <a:off x="3968496" y="2962336"/>
             <a:ext cx="1188720" cy="155448"/>
           </a:xfrm>
           <a:prstGeom prst="roundRect">
@@ -2205,7 +2241,7 @@
         </p:nvSpPr>
         <p:spPr>
           <a:xfrm>
-            <a:off x="3968496" y="3259836"/>
+            <a:off x="3968496" y="2962336"/>
             <a:ext cx="571718" cy="155448"/>
           </a:xfrm>
           <a:prstGeom prst="roundRect">
@@ -2234,7 +2270,7 @@
         </p:nvSpPr>
         <p:spPr>
           <a:xfrm>
-            <a:off x="5230368" y="3154680"/>
+            <a:off x="5230368" y="2857180"/>
             <a:ext cx="603504" cy="365760"/>
           </a:xfrm>
           <a:prstGeom prst="rect">
@@ -2273,7 +2309,7 @@
         </p:nvSpPr>
         <p:spPr>
           <a:xfrm>
-            <a:off x="5907024" y="3191256"/>
+            <a:off x="5907024" y="2893756"/>
             <a:ext cx="1088136" cy="292608"/>
           </a:xfrm>
           <a:prstGeom prst="roundRect">
@@ -2302,7 +2338,7 @@
         </p:nvSpPr>
         <p:spPr>
           <a:xfrm>
-            <a:off x="5907024" y="3182112"/>
+            <a:off x="5907024" y="2884612"/>
             <a:ext cx="1088136" cy="310896"/>
           </a:xfrm>
           <a:prstGeom prst="rect">
@@ -2341,7 +2377,7 @@
         </p:nvSpPr>
         <p:spPr>
           <a:xfrm>
-            <a:off x="457200" y="3657600"/>
+            <a:off x="457200" y="3360100"/>
             <a:ext cx="6537960" cy="0"/>
           </a:xfrm>
           <a:prstGeom prst="line">
@@ -2371,7 +2407,7 @@
         </p:nvSpPr>
         <p:spPr>
           <a:xfrm>
-            <a:off x="457200" y="3721608"/>
+            <a:off x="457200" y="3424108"/>
             <a:ext cx="1143000" cy="274320"/>
           </a:xfrm>
           <a:prstGeom prst="rect">
@@ -2410,7 +2446,7 @@
         </p:nvSpPr>
         <p:spPr>
           <a:xfrm>
-            <a:off x="457200" y="3995928"/>
+            <a:off x="457200" y="3698428"/>
             <a:ext cx="1188720" cy="237744"/>
           </a:xfrm>
           <a:prstGeom prst="rect">
@@ -2449,7 +2485,7 @@
         </p:nvSpPr>
         <p:spPr>
           <a:xfrm>
-            <a:off x="1682496" y="3813048"/>
+            <a:off x="1682496" y="3515548"/>
             <a:ext cx="621792" cy="329184"/>
           </a:xfrm>
           <a:prstGeom prst="roundRect">
@@ -2478,7 +2514,7 @@
         </p:nvSpPr>
         <p:spPr>
           <a:xfrm>
-            <a:off x="1627632" y="3794760"/>
+            <a:off x="1627632" y="3497260"/>
             <a:ext cx="731520" cy="365760"/>
           </a:xfrm>
           <a:prstGeom prst="rect">
@@ -2517,7 +2553,7 @@
         </p:nvSpPr>
         <p:spPr>
           <a:xfrm>
-            <a:off x="2414016" y="3813048"/>
+            <a:off x="2414016" y="3515548"/>
             <a:ext cx="621792" cy="329184"/>
           </a:xfrm>
           <a:prstGeom prst="roundRect">
@@ -2546,7 +2582,7 @@
         </p:nvSpPr>
         <p:spPr>
           <a:xfrm>
-            <a:off x="2359152" y="3794760"/>
+            <a:off x="2359152" y="3497260"/>
             <a:ext cx="731520" cy="365760"/>
           </a:xfrm>
           <a:prstGeom prst="rect">
@@ -2585,7 +2621,7 @@
         </p:nvSpPr>
         <p:spPr>
           <a:xfrm>
-            <a:off x="3145536" y="3813048"/>
+            <a:off x="3145536" y="3515548"/>
             <a:ext cx="621792" cy="329184"/>
           </a:xfrm>
           <a:prstGeom prst="roundRect">
@@ -2614,7 +2650,7 @@
         </p:nvSpPr>
         <p:spPr>
           <a:xfrm>
-            <a:off x="3090672" y="3794760"/>
+            <a:off x="3090672" y="3497260"/>
             <a:ext cx="731520" cy="365760"/>
           </a:xfrm>
           <a:prstGeom prst="rect">
@@ -2653,7 +2689,7 @@
         </p:nvSpPr>
         <p:spPr>
           <a:xfrm>
-            <a:off x="3968496" y="3899916"/>
+            <a:off x="3968496" y="3602416"/>
             <a:ext cx="1188720" cy="155448"/>
           </a:xfrm>
           <a:prstGeom prst="roundRect">
@@ -2682,7 +2718,7 @@
         </p:nvSpPr>
         <p:spPr>
           <a:xfrm>
-            <a:off x="3968496" y="3899916"/>
+            <a:off x="3968496" y="3602416"/>
             <a:ext cx="718893" cy="155448"/>
           </a:xfrm>
           <a:prstGeom prst="roundRect">
@@ -2711,7 +2747,7 @@
         </p:nvSpPr>
         <p:spPr>
           <a:xfrm>
-            <a:off x="5230368" y="3794760"/>
+            <a:off x="5230368" y="3497260"/>
             <a:ext cx="603504" cy="365760"/>
           </a:xfrm>
           <a:prstGeom prst="rect">
@@ -2750,7 +2786,7 @@
         </p:nvSpPr>
         <p:spPr>
           <a:xfrm>
-            <a:off x="5907024" y="3831336"/>
+            <a:off x="5907024" y="3533836"/>
             <a:ext cx="1088136" cy="292608"/>
           </a:xfrm>
           <a:prstGeom prst="roundRect">
@@ -2779,7 +2815,7 @@
         </p:nvSpPr>
         <p:spPr>
           <a:xfrm>
-            <a:off x="5907024" y="3822192"/>
+            <a:off x="5907024" y="3524692"/>
             <a:ext cx="1088136" cy="310896"/>
           </a:xfrm>
           <a:prstGeom prst="rect">
@@ -2818,7 +2854,7 @@
         </p:nvSpPr>
         <p:spPr>
           <a:xfrm>
-            <a:off x="457200" y="4297680"/>
+            <a:off x="457200" y="4000180"/>
             <a:ext cx="6537960" cy="0"/>
           </a:xfrm>
           <a:prstGeom prst="line">
@@ -2848,7 +2884,7 @@
         </p:nvSpPr>
         <p:spPr>
           <a:xfrm>
-            <a:off x="457200" y="4361688"/>
+            <a:off x="457200" y="4064188"/>
             <a:ext cx="1143000" cy="274320"/>
           </a:xfrm>
           <a:prstGeom prst="rect">
@@ -2887,7 +2923,7 @@
         </p:nvSpPr>
         <p:spPr>
           <a:xfrm>
-            <a:off x="457200" y="4636008"/>
+            <a:off x="457200" y="4338508"/>
             <a:ext cx="1188720" cy="237744"/>
           </a:xfrm>
           <a:prstGeom prst="rect">
@@ -2926,7 +2962,7 @@
         </p:nvSpPr>
         <p:spPr>
           <a:xfrm>
-            <a:off x="1682496" y="4453128"/>
+            <a:off x="1682496" y="4155628"/>
             <a:ext cx="621792" cy="329184"/>
           </a:xfrm>
           <a:prstGeom prst="roundRect">
@@ -2955,7 +2991,7 @@
         </p:nvSpPr>
         <p:spPr>
           <a:xfrm>
-            <a:off x="1627632" y="4434840"/>
+            <a:off x="1627632" y="4137340"/>
             <a:ext cx="731520" cy="365760"/>
           </a:xfrm>
           <a:prstGeom prst="rect">
@@ -2994,7 +3030,7 @@
         </p:nvSpPr>
         <p:spPr>
           <a:xfrm>
-            <a:off x="2414016" y="4453128"/>
+            <a:off x="2414016" y="4155628"/>
             <a:ext cx="621792" cy="329184"/>
           </a:xfrm>
           <a:prstGeom prst="roundRect">
@@ -3023,7 +3059,7 @@
         </p:nvSpPr>
         <p:spPr>
           <a:xfrm>
-            <a:off x="2359152" y="4434840"/>
+            <a:off x="2359152" y="4137340"/>
             <a:ext cx="731520" cy="365760"/>
           </a:xfrm>
           <a:prstGeom prst="rect">
@@ -3062,7 +3098,7 @@
         </p:nvSpPr>
         <p:spPr>
           <a:xfrm>
-            <a:off x="3145536" y="4453128"/>
+            <a:off x="3145536" y="4155628"/>
             <a:ext cx="621792" cy="329184"/>
           </a:xfrm>
           <a:prstGeom prst="roundRect">
@@ -3091,7 +3127,7 @@
         </p:nvSpPr>
         <p:spPr>
           <a:xfrm>
-            <a:off x="3090672" y="4434840"/>
+            <a:off x="3090672" y="4137340"/>
             <a:ext cx="731520" cy="365760"/>
           </a:xfrm>
           <a:prstGeom prst="rect">
@@ -3130,7 +3166,7 @@
         </p:nvSpPr>
         <p:spPr>
           <a:xfrm>
-            <a:off x="3968496" y="4539996"/>
+            <a:off x="3968496" y="4242496"/>
             <a:ext cx="1188720" cy="155448"/>
           </a:xfrm>
           <a:prstGeom prst="roundRect">
@@ -3159,7 +3195,7 @@
         </p:nvSpPr>
         <p:spPr>
           <a:xfrm>
-            <a:off x="3968496" y="4539996"/>
+            <a:off x="3968496" y="4242496"/>
             <a:ext cx="781159" cy="155448"/>
           </a:xfrm>
           <a:prstGeom prst="roundRect">
@@ -3188,7 +3224,7 @@
         </p:nvSpPr>
         <p:spPr>
           <a:xfrm>
-            <a:off x="5230368" y="4434840"/>
+            <a:off x="5230368" y="4137340"/>
             <a:ext cx="603504" cy="365760"/>
           </a:xfrm>
           <a:prstGeom prst="rect">
@@ -3227,7 +3263,7 @@
         </p:nvSpPr>
         <p:spPr>
           <a:xfrm>
-            <a:off x="5907024" y="4471416"/>
+            <a:off x="5907024" y="4173916"/>
             <a:ext cx="1088136" cy="292608"/>
           </a:xfrm>
           <a:prstGeom prst="roundRect">
@@ -3256,7 +3292,7 @@
         </p:nvSpPr>
         <p:spPr>
           <a:xfrm>
-            <a:off x="5907024" y="4462272"/>
+            <a:off x="5907024" y="4164772"/>
             <a:ext cx="1088136" cy="310896"/>
           </a:xfrm>
           <a:prstGeom prst="rect">
@@ -3295,7 +3331,7 @@
         </p:nvSpPr>
         <p:spPr>
           <a:xfrm>
-            <a:off x="457200" y="4937760"/>
+            <a:off x="457200" y="4640260"/>
             <a:ext cx="6537960" cy="0"/>
           </a:xfrm>
           <a:prstGeom prst="line">
@@ -3325,7 +3361,7 @@
         </p:nvSpPr>
         <p:spPr>
           <a:xfrm>
-            <a:off x="457200" y="5001768"/>
+            <a:off x="457200" y="4704268"/>
             <a:ext cx="1143000" cy="274320"/>
           </a:xfrm>
           <a:prstGeom prst="rect">
@@ -3364,7 +3400,7 @@
         </p:nvSpPr>
         <p:spPr>
           <a:xfrm>
-            <a:off x="457200" y="5276088"/>
+            <a:off x="457200" y="4978588"/>
             <a:ext cx="1188720" cy="237744"/>
           </a:xfrm>
           <a:prstGeom prst="rect">
@@ -3403,7 +3439,7 @@
         </p:nvSpPr>
         <p:spPr>
           <a:xfrm>
-            <a:off x="1682496" y="5093208"/>
+            <a:off x="1682496" y="4795708"/>
             <a:ext cx="621792" cy="329184"/>
           </a:xfrm>
           <a:prstGeom prst="roundRect">
@@ -3432,7 +3468,7 @@
         </p:nvSpPr>
         <p:spPr>
           <a:xfrm>
-            <a:off x="1627632" y="5074920"/>
+            <a:off x="1627632" y="4777420"/>
             <a:ext cx="731520" cy="365760"/>
           </a:xfrm>
           <a:prstGeom prst="rect">
@@ -3471,7 +3507,7 @@
         </p:nvSpPr>
         <p:spPr>
           <a:xfrm>
-            <a:off x="2414016" y="5093208"/>
+            <a:off x="2414016" y="4795708"/>
             <a:ext cx="621792" cy="329184"/>
           </a:xfrm>
           <a:prstGeom prst="roundRect">
@@ -3500,7 +3536,7 @@
         </p:nvSpPr>
         <p:spPr>
           <a:xfrm>
-            <a:off x="2359152" y="5074920"/>
+            <a:off x="2359152" y="4777420"/>
             <a:ext cx="731520" cy="365760"/>
           </a:xfrm>
           <a:prstGeom prst="rect">
@@ -3539,7 +3575,7 @@
         </p:nvSpPr>
         <p:spPr>
           <a:xfrm>
-            <a:off x="3145536" y="5093208"/>
+            <a:off x="3145536" y="4795708"/>
             <a:ext cx="621792" cy="329184"/>
           </a:xfrm>
           <a:prstGeom prst="roundRect">
@@ -3568,7 +3604,7 @@
         </p:nvSpPr>
         <p:spPr>
           <a:xfrm>
-            <a:off x="3090672" y="5074920"/>
+            <a:off x="3090672" y="4777420"/>
             <a:ext cx="731520" cy="365760"/>
           </a:xfrm>
           <a:prstGeom prst="rect">
@@ -3607,7 +3643,7 @@
         </p:nvSpPr>
         <p:spPr>
           <a:xfrm>
-            <a:off x="3968496" y="5180076"/>
+            <a:off x="3968496" y="4882576"/>
             <a:ext cx="1188720" cy="155448"/>
           </a:xfrm>
           <a:prstGeom prst="roundRect">
@@ -3636,7 +3672,7 @@
         </p:nvSpPr>
         <p:spPr>
           <a:xfrm>
-            <a:off x="3968496" y="5180076"/>
+            <a:off x="3968496" y="4882576"/>
             <a:ext cx="1132114" cy="155448"/>
           </a:xfrm>
           <a:prstGeom prst="roundRect">
@@ -3665,7 +3701,7 @@
         </p:nvSpPr>
         <p:spPr>
           <a:xfrm>
-            <a:off x="5230368" y="5074920"/>
+            <a:off x="5230368" y="4777420"/>
             <a:ext cx="603504" cy="365760"/>
           </a:xfrm>
           <a:prstGeom prst="rect">
@@ -3704,7 +3740,7 @@
         </p:nvSpPr>
         <p:spPr>
           <a:xfrm>
-            <a:off x="5907024" y="5111496"/>
+            <a:off x="5907024" y="4813996"/>
             <a:ext cx="1088136" cy="292608"/>
           </a:xfrm>
           <a:prstGeom prst="roundRect">
@@ -3733,7 +3769,7 @@
         </p:nvSpPr>
         <p:spPr>
           <a:xfrm>
-            <a:off x="5907024" y="5102352"/>
+            <a:off x="5907024" y="4804852"/>
             <a:ext cx="1088136" cy="310896"/>
           </a:xfrm>
           <a:prstGeom prst="rect">
@@ -3772,7 +3808,7 @@
         </p:nvSpPr>
         <p:spPr>
           <a:xfrm>
-            <a:off x="4676067" y="3113532"/>
+            <a:off x="4676067" y="2816032"/>
             <a:ext cx="0" cy="2368296"/>
           </a:xfrm>
           <a:prstGeom prst="line">
@@ -3802,7 +3838,7 @@
         </p:nvSpPr>
         <p:spPr>
           <a:xfrm>
-            <a:off x="4264587" y="2875788"/>
+            <a:off x="4264587" y="2578288"/>
             <a:ext cx="822960" cy="219456"/>
           </a:xfrm>
           <a:prstGeom prst="rect">
@@ -3841,7 +3877,7 @@
         </p:nvSpPr>
         <p:spPr>
           <a:xfrm>
-            <a:off x="457200" y="5742432"/>
+            <a:off x="457200" y="5980176"/>
             <a:ext cx="6583680" cy="457200"/>
           </a:xfrm>
           <a:prstGeom prst="rect">
@@ -4131,21 +4167,7 @@
                 <a:ea typeface="Calibri" pitchFamily="34" charset="-122"/>
                 <a:cs typeface="Calibri" pitchFamily="34" charset="-120"/>
               </a:rPr>
-              <a:t>Run the Martins pelvic-block yield study — pull bad pelvics and root-cause the harvest loss. </a:t>
-            </a:r>
-            <a:r>
-              <a:rPr lang="en-US" sz="1150" dirty="0">
-                <a:solidFill>
-                  <a:srgbClr val="20303D"/>
-                </a:solidFill>
-                <a:highlight>
-                  <a:srgbClr val="FFFF00"/>
-                </a:highlight>
-                <a:latin typeface="Calibri" pitchFamily="34" charset="0"/>
-                <a:ea typeface="Calibri" pitchFamily="34" charset="-122"/>
-                <a:cs typeface="Calibri" pitchFamily="34" charset="-120"/>
-              </a:rPr>
-              <a:t>10% + on harvesting yield, should mean headroom improvement or capacity improvement of such % on pigs and such % on labor</a:t>
+              <a:t>Run the Martins pelvic-block yield study — pull bad pelvics and root-cause the harvest loss: Started, on route to complete 30 samples a week for 4 weeks. </a:t>
             </a:r>
             <a:endParaRPr lang="en-US" sz="1150" dirty="0">
               <a:highlight>
@@ -4254,7 +4276,7 @@
                 <a:ea typeface="Calibri" pitchFamily="34" charset="-122"/>
                 <a:cs typeface="Calibri" pitchFamily="34" charset="-120"/>
               </a:rPr>
-              <a:t>Ramp Parks as a 2nd pelvic source once its upstream yield root-cause lands.</a:t>
+              <a:t>Ramp Parks as a 2nd pelvic source: Already working on root causing harvesting yield specs fails.</a:t>
             </a:r>
             <a:endParaRPr lang="en-US" sz="1150" dirty="0"/>
           </a:p>
@@ -4487,7 +4509,7 @@
         </p:nvSpPr>
         <p:spPr>
           <a:xfrm>
-            <a:off x="381963" y="2005103"/>
+            <a:off x="457200" y="5327945"/>
             <a:ext cx="1143000" cy="274320"/>
           </a:xfrm>
           <a:prstGeom prst="rect">
@@ -4504,7 +4526,7 @@
               <a:buNone/>
             </a:pPr>
             <a:r>
-              <a:rPr lang="en-US" sz="1450" b="1" dirty="0">
+              <a:rPr lang="en-US" sz="1200" b="1" dirty="0">
                 <a:solidFill>
                   <a:srgbClr val="20303D"/>
                 </a:solidFill>
@@ -4512,9 +4534,9 @@
                 <a:ea typeface="Calibri" pitchFamily="34" charset="-122"/>
                 <a:cs typeface="Calibri" pitchFamily="34" charset="-120"/>
               </a:rPr>
-              <a:t>SH</a:t>
-            </a:r>
-            <a:endParaRPr lang="en-US" sz="1450" dirty="0"/>
+              <a:t>Slaughter House</a:t>
+            </a:r>
+            <a:endParaRPr lang="en-US" sz="1200" dirty="0"/>
           </a:p>
         </p:txBody>
       </p:sp>
@@ -4532,7 +4554,7 @@
         </p:nvSpPr>
         <p:spPr>
           <a:xfrm>
-            <a:off x="381963" y="2279423"/>
+            <a:off x="457200" y="5532327"/>
             <a:ext cx="1188720" cy="237744"/>
           </a:xfrm>
           <a:prstGeom prst="rect">
@@ -4557,9 +4579,60 @@
                 <a:ea typeface="Calibri" pitchFamily="34" charset="-122"/>
                 <a:cs typeface="Calibri" pitchFamily="34" charset="-120"/>
               </a:rPr>
-              <a:t>Labor · Pelvic block</a:t>
+              <a:t>Cap type – Tissue family</a:t>
             </a:r>
             <a:endParaRPr lang="en-US" sz="950" dirty="0"/>
+          </a:p>
+        </p:txBody>
+      </p:sp>
+      <p:sp>
+        <p:nvSpPr>
+          <p:cNvPr id="89" name="Rectangle 88">
+            <a:extLst>
+              <a:ext uri="{FF2B5EF4-FFF2-40B4-BE49-F238E27FC236}">
+                <a16:creationId xmlns:a16="http://schemas.microsoft.com/office/drawing/2014/main" id="{96D79C75-517A-0410-D7DB-DE0EF0FE9E02}"/>
+              </a:ext>
+            </a:extLst>
+          </p:cNvPr>
+          <p:cNvSpPr/>
+          <p:nvPr/>
+        </p:nvSpPr>
+        <p:spPr>
+          <a:xfrm>
+            <a:off x="322786" y="5363162"/>
+            <a:ext cx="1407831" cy="365761"/>
+          </a:xfrm>
+          <a:prstGeom prst="rect">
+            <a:avLst/>
+          </a:prstGeom>
+          <a:solidFill>
+            <a:schemeClr val="tx1">
+              <a:alpha val="0"/>
+            </a:schemeClr>
+          </a:solidFill>
+        </p:spPr>
+        <p:style>
+          <a:lnRef idx="2">
+            <a:schemeClr val="accent1">
+              <a:shade val="15000"/>
+            </a:schemeClr>
+          </a:lnRef>
+          <a:fillRef idx="1">
+            <a:schemeClr val="accent1"/>
+          </a:fillRef>
+          <a:effectRef idx="0">
+            <a:schemeClr val="accent1"/>
+          </a:effectRef>
+          <a:fontRef idx="minor">
+            <a:schemeClr val="lt1"/>
+          </a:fontRef>
+        </p:style>
+        <p:txBody>
+          <a:bodyPr rtlCol="0" anchor="ctr"/>
+          <a:lstStyle/>
+          <a:p>
+            <a:pPr algn="ctr"/>
+            <a:endParaRPr lang="en-US"/>
           </a:p>
         </p:txBody>
       </p:sp>
@@ -5616,8 +5689,8 @@
         </p:nvSpPr>
         <p:spPr>
           <a:xfrm>
-            <a:off x="5095104" y="5964782"/>
-            <a:ext cx="6979796" cy="646331"/>
+            <a:off x="3268980" y="6071616"/>
+            <a:ext cx="8181599" cy="646331"/>
           </a:xfrm>
           <a:prstGeom prst="rect">
             <a:avLst/>
@@ -5638,7 +5711,7 @@
           <a:p>
             <a:r>
               <a:rPr lang="en-US" dirty="0"/>
-              <a:t>Why is the attainment dropping: Possible culprits: harvesting yield, labor</a:t>
+              <a:t>Why is the attainment dropping? Possible culprits: Seasonality, harvesting yield, labor</a:t>
             </a:r>
           </a:p>
         </p:txBody>
@@ -5652,7 +5725,7 @@
 </file>
 
 <file path=ppt/slides/slide3.xml><?xml version="1.0" encoding="utf-8"?>
-<p:sld xmlns:a="http://schemas.openxmlformats.org/drawingml/2006/main" xmlns:p="http://schemas.openxmlformats.org/presentationml/2006/main" xmlns:r="http://schemas.openxmlformats.org/officeDocument/2006/relationships">
+<p:sld xmlns:a="http://schemas.openxmlformats.org/drawingml/2006/main" xmlns:r="http://schemas.openxmlformats.org/officeDocument/2006/relationships" xmlns:p="http://schemas.openxmlformats.org/presentationml/2006/main">
   <p:cSld>
     <p:spTree>
       <p:nvGrpSpPr>
@@ -5660,7 +5733,14 @@
         <p:cNvGrpSpPr/>
         <p:nvPr/>
       </p:nvGrpSpPr>
-      <p:grpSpPr/>
+      <p:grpSpPr>
+        <a:xfrm>
+          <a:off x="0" y="0"/>
+          <a:ext cx="0" cy="0"/>
+          <a:chOff x="0" y="0"/>
+          <a:chExt cx="0" cy="0"/>
+        </a:xfrm>
+      </p:grpSpPr>
       <p:sp>
         <p:nvSpPr>
           <p:cNvPr id="2" name="TextBox 1"/>
@@ -5766,12 +5846,48 @@
                 <a:tableStyleId>{5C22544A-7EE6-4342-B048-85BDC9FD1C3A}</a:tableStyleId>
               </a:tblPr>
               <a:tblGrid>
-                <a:gridCol w="1490472"/>
-                <a:gridCol w="1600200"/>
-                <a:gridCol w="1691640"/>
-                <a:gridCol w="1691640"/>
-                <a:gridCol w="1691640"/>
-                <a:gridCol w="1645920"/>
+                <a:gridCol w="1490472">
+                  <a:extLst>
+                    <a:ext uri="{9D8B030D-6E8A-4147-A177-3AD203B41FA5}">
+                      <a16:colId xmlns:a16="http://schemas.microsoft.com/office/drawing/2014/main" val="20000"/>
+                    </a:ext>
+                  </a:extLst>
+                </a:gridCol>
+                <a:gridCol w="1600200">
+                  <a:extLst>
+                    <a:ext uri="{9D8B030D-6E8A-4147-A177-3AD203B41FA5}">
+                      <a16:colId xmlns:a16="http://schemas.microsoft.com/office/drawing/2014/main" val="20001"/>
+                    </a:ext>
+                  </a:extLst>
+                </a:gridCol>
+                <a:gridCol w="1691640">
+                  <a:extLst>
+                    <a:ext uri="{9D8B030D-6E8A-4147-A177-3AD203B41FA5}">
+                      <a16:colId xmlns:a16="http://schemas.microsoft.com/office/drawing/2014/main" val="20002"/>
+                    </a:ext>
+                  </a:extLst>
+                </a:gridCol>
+                <a:gridCol w="1691640">
+                  <a:extLst>
+                    <a:ext uri="{9D8B030D-6E8A-4147-A177-3AD203B41FA5}">
+                      <a16:colId xmlns:a16="http://schemas.microsoft.com/office/drawing/2014/main" val="20003"/>
+                    </a:ext>
+                  </a:extLst>
+                </a:gridCol>
+                <a:gridCol w="1691640">
+                  <a:extLst>
+                    <a:ext uri="{9D8B030D-6E8A-4147-A177-3AD203B41FA5}">
+                      <a16:colId xmlns:a16="http://schemas.microsoft.com/office/drawing/2014/main" val="20004"/>
+                    </a:ext>
+                  </a:extLst>
+                </a:gridCol>
+                <a:gridCol w="1645920">
+                  <a:extLst>
+                    <a:ext uri="{9D8B030D-6E8A-4147-A177-3AD203B41FA5}">
+                      <a16:colId xmlns:a16="http://schemas.microsoft.com/office/drawing/2014/main" val="20005"/>
+                    </a:ext>
+                  </a:extLst>
+                </a:gridCol>
               </a:tblGrid>
               <a:tr h="372291">
                 <a:tc>
@@ -5791,7 +5907,7 @@
                       </a:r>
                     </a:p>
                   </a:txBody>
-                  <a:tcPr anchor="ctr" marL="54864" marR="54864" marT="27432" marB="27432">
+                  <a:tcPr marL="54864" marR="54864" marT="27432" marB="27432" anchor="ctr">
                     <a:solidFill>
                       <a:srgbClr val="12345B"/>
                     </a:solidFill>
@@ -5814,7 +5930,7 @@
                       </a:r>
                     </a:p>
                   </a:txBody>
-                  <a:tcPr anchor="ctr" marL="54864" marR="54864" marT="27432" marB="27432">
+                  <a:tcPr marL="54864" marR="54864" marT="27432" marB="27432" anchor="ctr">
                     <a:solidFill>
                       <a:srgbClr val="12345B"/>
                     </a:solidFill>
@@ -5837,7 +5953,7 @@
                       </a:r>
                     </a:p>
                   </a:txBody>
-                  <a:tcPr anchor="ctr" marL="54864" marR="54864" marT="27432" marB="27432">
+                  <a:tcPr marL="54864" marR="54864" marT="27432" marB="27432" anchor="ctr">
                     <a:solidFill>
                       <a:srgbClr val="12345B"/>
                     </a:solidFill>
@@ -5860,7 +5976,7 @@
                       </a:r>
                     </a:p>
                   </a:txBody>
-                  <a:tcPr anchor="ctr" marL="54864" marR="54864" marT="27432" marB="27432">
+                  <a:tcPr marL="54864" marR="54864" marT="27432" marB="27432" anchor="ctr">
                     <a:solidFill>
                       <a:srgbClr val="12345B"/>
                     </a:solidFill>
@@ -5883,7 +5999,7 @@
                       </a:r>
                     </a:p>
                   </a:txBody>
-                  <a:tcPr anchor="ctr" marL="54864" marR="54864" marT="27432" marB="27432">
+                  <a:tcPr marL="54864" marR="54864" marT="27432" marB="27432" anchor="ctr">
                     <a:solidFill>
                       <a:srgbClr val="12345B"/>
                     </a:solidFill>
@@ -5906,12 +6022,17 @@
                       </a:r>
                     </a:p>
                   </a:txBody>
-                  <a:tcPr anchor="ctr" marL="54864" marR="54864" marT="27432" marB="27432">
+                  <a:tcPr marL="54864" marR="54864" marT="27432" marB="27432" anchor="ctr">
                     <a:solidFill>
                       <a:srgbClr val="12345B"/>
                     </a:solidFill>
                   </a:tcPr>
                 </a:tc>
+                <a:extLst>
+                  <a:ext uri="{0D108BD9-81ED-4DB2-BD59-A6C34878D82A}">
+                    <a16:rowId xmlns:a16="http://schemas.microsoft.com/office/drawing/2014/main" val="10000"/>
+                  </a:ext>
+                </a:extLst>
               </a:tr>
               <a:tr h="372291">
                 <a:tc>
@@ -5931,7 +6052,7 @@
                       </a:r>
                     </a:p>
                   </a:txBody>
-                  <a:tcPr anchor="ctr" marL="54864" marR="54864" marT="27432" marB="27432">
+                  <a:tcPr marL="54864" marR="54864" marT="27432" marB="27432" anchor="ctr">
                     <a:solidFill>
                       <a:srgbClr val="E3E9F1"/>
                     </a:solidFill>
@@ -5954,7 +6075,7 @@
                       </a:r>
                     </a:p>
                   </a:txBody>
-                  <a:tcPr anchor="ctr" marL="54864" marR="54864" marT="27432" marB="27432">
+                  <a:tcPr marL="54864" marR="54864" marT="27432" marB="27432" anchor="ctr">
                     <a:solidFill>
                       <a:srgbClr val="E3E9F1"/>
                     </a:solidFill>
@@ -5977,7 +6098,7 @@
                       </a:r>
                     </a:p>
                   </a:txBody>
-                  <a:tcPr anchor="ctr" marL="54864" marR="54864" marT="27432" marB="27432">
+                  <a:tcPr marL="54864" marR="54864" marT="27432" marB="27432" anchor="ctr">
                     <a:solidFill>
                       <a:srgbClr val="E3E9F1"/>
                     </a:solidFill>
@@ -6000,7 +6121,7 @@
                       </a:r>
                     </a:p>
                   </a:txBody>
-                  <a:tcPr anchor="ctr" marL="54864" marR="54864" marT="27432" marB="27432">
+                  <a:tcPr marL="54864" marR="54864" marT="27432" marB="27432" anchor="ctr">
                     <a:solidFill>
                       <a:srgbClr val="E3E9F1"/>
                     </a:solidFill>
@@ -6023,7 +6144,7 @@
                       </a:r>
                     </a:p>
                   </a:txBody>
-                  <a:tcPr anchor="ctr" marL="54864" marR="54864" marT="27432" marB="27432">
+                  <a:tcPr marL="54864" marR="54864" marT="27432" marB="27432" anchor="ctr">
                     <a:solidFill>
                       <a:srgbClr val="E3E9F1"/>
                     </a:solidFill>
@@ -6046,12 +6167,17 @@
                       </a:r>
                     </a:p>
                   </a:txBody>
-                  <a:tcPr anchor="ctr" marL="54864" marR="54864" marT="27432" marB="27432">
+                  <a:tcPr marL="54864" marR="54864" marT="27432" marB="27432" anchor="ctr">
                     <a:solidFill>
                       <a:srgbClr val="E3E9F1"/>
                     </a:solidFill>
                   </a:tcPr>
                 </a:tc>
+                <a:extLst>
+                  <a:ext uri="{0D108BD9-81ED-4DB2-BD59-A6C34878D82A}">
+                    <a16:rowId xmlns:a16="http://schemas.microsoft.com/office/drawing/2014/main" val="10001"/>
+                  </a:ext>
+                </a:extLst>
               </a:tr>
               <a:tr h="372291">
                 <a:tc>
@@ -6071,7 +6197,7 @@
                       </a:r>
                     </a:p>
                   </a:txBody>
-                  <a:tcPr anchor="ctr" marL="54864" marR="54864" marT="27432" marB="27432">
+                  <a:tcPr marL="54864" marR="54864" marT="27432" marB="27432" anchor="ctr">
                     <a:solidFill>
                       <a:srgbClr val="F2F5F9"/>
                     </a:solidFill>
@@ -6094,7 +6220,7 @@
                       </a:r>
                     </a:p>
                   </a:txBody>
-                  <a:tcPr anchor="ctr" marL="54864" marR="54864" marT="27432" marB="27432">
+                  <a:tcPr marL="54864" marR="54864" marT="27432" marB="27432" anchor="ctr">
                     <a:solidFill>
                       <a:srgbClr val="F2F5F9"/>
                     </a:solidFill>
@@ -6117,7 +6243,7 @@
                       </a:r>
                     </a:p>
                   </a:txBody>
-                  <a:tcPr anchor="ctr" marL="54864" marR="54864" marT="27432" marB="27432">
+                  <a:tcPr marL="54864" marR="54864" marT="27432" marB="27432" anchor="ctr">
                     <a:solidFill>
                       <a:srgbClr val="F2F5F9"/>
                     </a:solidFill>
@@ -6140,7 +6266,7 @@
                       </a:r>
                     </a:p>
                   </a:txBody>
-                  <a:tcPr anchor="ctr" marL="54864" marR="54864" marT="27432" marB="27432">
+                  <a:tcPr marL="54864" marR="54864" marT="27432" marB="27432" anchor="ctr">
                     <a:solidFill>
                       <a:srgbClr val="F2F5F9"/>
                     </a:solidFill>
@@ -6163,7 +6289,7 @@
                       </a:r>
                     </a:p>
                   </a:txBody>
-                  <a:tcPr anchor="ctr" marL="54864" marR="54864" marT="27432" marB="27432">
+                  <a:tcPr marL="54864" marR="54864" marT="27432" marB="27432" anchor="ctr">
                     <a:solidFill>
                       <a:srgbClr val="F2F5F9"/>
                     </a:solidFill>
@@ -6186,12 +6312,17 @@
                       </a:r>
                     </a:p>
                   </a:txBody>
-                  <a:tcPr anchor="ctr" marL="54864" marR="54864" marT="27432" marB="27432">
+                  <a:tcPr marL="54864" marR="54864" marT="27432" marB="27432" anchor="ctr">
                     <a:solidFill>
                       <a:srgbClr val="F2F5F9"/>
                     </a:solidFill>
                   </a:tcPr>
                 </a:tc>
+                <a:extLst>
+                  <a:ext uri="{0D108BD9-81ED-4DB2-BD59-A6C34878D82A}">
+                    <a16:rowId xmlns:a16="http://schemas.microsoft.com/office/drawing/2014/main" val="10002"/>
+                  </a:ext>
+                </a:extLst>
               </a:tr>
               <a:tr h="372291">
                 <a:tc>
@@ -6211,7 +6342,7 @@
                       </a:r>
                     </a:p>
                   </a:txBody>
-                  <a:tcPr anchor="ctr" marL="54864" marR="54864" marT="27432" marB="27432">
+                  <a:tcPr marL="54864" marR="54864" marT="27432" marB="27432" anchor="ctr">
                     <a:solidFill>
                       <a:srgbClr val="FFFFFF"/>
                     </a:solidFill>
@@ -6234,7 +6365,7 @@
                       </a:r>
                     </a:p>
                   </a:txBody>
-                  <a:tcPr anchor="ctr" marL="54864" marR="54864" marT="27432" marB="27432">
+                  <a:tcPr marL="54864" marR="54864" marT="27432" marB="27432" anchor="ctr">
                     <a:solidFill>
                       <a:srgbClr val="FFFFFF"/>
                     </a:solidFill>
@@ -6257,7 +6388,7 @@
                       </a:r>
                     </a:p>
                   </a:txBody>
-                  <a:tcPr anchor="ctr" marL="54864" marR="54864" marT="27432" marB="27432">
+                  <a:tcPr marL="54864" marR="54864" marT="27432" marB="27432" anchor="ctr">
                     <a:solidFill>
                       <a:srgbClr val="FFFFFF"/>
                     </a:solidFill>
@@ -6280,7 +6411,7 @@
                       </a:r>
                     </a:p>
                   </a:txBody>
-                  <a:tcPr anchor="ctr" marL="54864" marR="54864" marT="27432" marB="27432">
+                  <a:tcPr marL="54864" marR="54864" marT="27432" marB="27432" anchor="ctr">
                     <a:solidFill>
                       <a:srgbClr val="FFFFFF"/>
                     </a:solidFill>
@@ -6303,7 +6434,7 @@
                       </a:r>
                     </a:p>
                   </a:txBody>
-                  <a:tcPr anchor="ctr" marL="54864" marR="54864" marT="27432" marB="27432">
+                  <a:tcPr marL="54864" marR="54864" marT="27432" marB="27432" anchor="ctr">
                     <a:solidFill>
                       <a:srgbClr val="FFFFFF"/>
                     </a:solidFill>
@@ -6326,12 +6457,17 @@
                       </a:r>
                     </a:p>
                   </a:txBody>
-                  <a:tcPr anchor="ctr" marL="54864" marR="54864" marT="27432" marB="27432">
+                  <a:tcPr marL="54864" marR="54864" marT="27432" marB="27432" anchor="ctr">
                     <a:solidFill>
                       <a:srgbClr val="FFFFFF"/>
                     </a:solidFill>
                   </a:tcPr>
                 </a:tc>
+                <a:extLst>
+                  <a:ext uri="{0D108BD9-81ED-4DB2-BD59-A6C34878D82A}">
+                    <a16:rowId xmlns:a16="http://schemas.microsoft.com/office/drawing/2014/main" val="10003"/>
+                  </a:ext>
+                </a:extLst>
               </a:tr>
               <a:tr h="372291">
                 <a:tc>
@@ -6351,7 +6487,7 @@
                       </a:r>
                     </a:p>
                   </a:txBody>
-                  <a:tcPr anchor="ctr" marL="54864" marR="54864" marT="27432" marB="27432">
+                  <a:tcPr marL="54864" marR="54864" marT="27432" marB="27432" anchor="ctr">
                     <a:solidFill>
                       <a:srgbClr val="F2F5F9"/>
                     </a:solidFill>
@@ -6374,7 +6510,7 @@
                       </a:r>
                     </a:p>
                   </a:txBody>
-                  <a:tcPr anchor="ctr" marL="54864" marR="54864" marT="27432" marB="27432">
+                  <a:tcPr marL="54864" marR="54864" marT="27432" marB="27432" anchor="ctr">
                     <a:solidFill>
                       <a:srgbClr val="F2F5F9"/>
                     </a:solidFill>
@@ -6397,7 +6533,7 @@
                       </a:r>
                     </a:p>
                   </a:txBody>
-                  <a:tcPr anchor="ctr" marL="54864" marR="54864" marT="27432" marB="27432">
+                  <a:tcPr marL="54864" marR="54864" marT="27432" marB="27432" anchor="ctr">
                     <a:solidFill>
                       <a:srgbClr val="F2F5F9"/>
                     </a:solidFill>
@@ -6420,7 +6556,7 @@
                       </a:r>
                     </a:p>
                   </a:txBody>
-                  <a:tcPr anchor="ctr" marL="54864" marR="54864" marT="27432" marB="27432">
+                  <a:tcPr marL="54864" marR="54864" marT="27432" marB="27432" anchor="ctr">
                     <a:solidFill>
                       <a:srgbClr val="F2F5F9"/>
                     </a:solidFill>
@@ -6443,7 +6579,7 @@
                       </a:r>
                     </a:p>
                   </a:txBody>
-                  <a:tcPr anchor="ctr" marL="54864" marR="54864" marT="27432" marB="27432">
+                  <a:tcPr marL="54864" marR="54864" marT="27432" marB="27432" anchor="ctr">
                     <a:solidFill>
                       <a:srgbClr val="F2F5F9"/>
                     </a:solidFill>
@@ -6466,12 +6602,17 @@
                       </a:r>
                     </a:p>
                   </a:txBody>
-                  <a:tcPr anchor="ctr" marL="54864" marR="54864" marT="27432" marB="27432">
+                  <a:tcPr marL="54864" marR="54864" marT="27432" marB="27432" anchor="ctr">
                     <a:solidFill>
                       <a:srgbClr val="F2F5F9"/>
                     </a:solidFill>
                   </a:tcPr>
                 </a:tc>
+                <a:extLst>
+                  <a:ext uri="{0D108BD9-81ED-4DB2-BD59-A6C34878D82A}">
+                    <a16:rowId xmlns:a16="http://schemas.microsoft.com/office/drawing/2014/main" val="10004"/>
+                  </a:ext>
+                </a:extLst>
               </a:tr>
               <a:tr h="372291">
                 <a:tc>
@@ -6491,7 +6632,7 @@
                       </a:r>
                     </a:p>
                   </a:txBody>
-                  <a:tcPr anchor="ctr" marL="54864" marR="54864" marT="27432" marB="27432">
+                  <a:tcPr marL="54864" marR="54864" marT="27432" marB="27432" anchor="ctr">
                     <a:solidFill>
                       <a:srgbClr val="FFFFFF"/>
                     </a:solidFill>
@@ -6514,7 +6655,7 @@
                       </a:r>
                     </a:p>
                   </a:txBody>
-                  <a:tcPr anchor="ctr" marL="54864" marR="54864" marT="27432" marB="27432">
+                  <a:tcPr marL="54864" marR="54864" marT="27432" marB="27432" anchor="ctr">
                     <a:solidFill>
                       <a:srgbClr val="FFFFFF"/>
                     </a:solidFill>
@@ -6537,7 +6678,7 @@
                       </a:r>
                     </a:p>
                   </a:txBody>
-                  <a:tcPr anchor="ctr" marL="54864" marR="54864" marT="27432" marB="27432">
+                  <a:tcPr marL="54864" marR="54864" marT="27432" marB="27432" anchor="ctr">
                     <a:solidFill>
                       <a:srgbClr val="FFFFFF"/>
                     </a:solidFill>
@@ -6560,7 +6701,7 @@
                       </a:r>
                     </a:p>
                   </a:txBody>
-                  <a:tcPr anchor="ctr" marL="54864" marR="54864" marT="27432" marB="27432">
+                  <a:tcPr marL="54864" marR="54864" marT="27432" marB="27432" anchor="ctr">
                     <a:solidFill>
                       <a:srgbClr val="FFFFFF"/>
                     </a:solidFill>
@@ -6583,7 +6724,7 @@
                       </a:r>
                     </a:p>
                   </a:txBody>
-                  <a:tcPr anchor="ctr" marL="54864" marR="54864" marT="27432" marB="27432">
+                  <a:tcPr marL="54864" marR="54864" marT="27432" marB="27432" anchor="ctr">
                     <a:solidFill>
                       <a:srgbClr val="FFFFFF"/>
                     </a:solidFill>
@@ -6606,12 +6747,17 @@
                       </a:r>
                     </a:p>
                   </a:txBody>
-                  <a:tcPr anchor="ctr" marL="54864" marR="54864" marT="27432" marB="27432">
+                  <a:tcPr marL="54864" marR="54864" marT="27432" marB="27432" anchor="ctr">
                     <a:solidFill>
                       <a:srgbClr val="FFFFFF"/>
                     </a:solidFill>
                   </a:tcPr>
                 </a:tc>
+                <a:extLst>
+                  <a:ext uri="{0D108BD9-81ED-4DB2-BD59-A6C34878D82A}">
+                    <a16:rowId xmlns:a16="http://schemas.microsoft.com/office/drawing/2014/main" val="10005"/>
+                  </a:ext>
+                </a:extLst>
               </a:tr>
               <a:tr h="372294">
                 <a:tc>
@@ -6631,7 +6777,7 @@
                       </a:r>
                     </a:p>
                   </a:txBody>
-                  <a:tcPr anchor="ctr" marL="54864" marR="54864" marT="27432" marB="27432">
+                  <a:tcPr marL="54864" marR="54864" marT="27432" marB="27432" anchor="ctr">
                     <a:solidFill>
                       <a:srgbClr val="F2F5F9"/>
                     </a:solidFill>
@@ -6654,7 +6800,7 @@
                       </a:r>
                     </a:p>
                   </a:txBody>
-                  <a:tcPr anchor="ctr" marL="54864" marR="54864" marT="27432" marB="27432">
+                  <a:tcPr marL="54864" marR="54864" marT="27432" marB="27432" anchor="ctr">
                     <a:solidFill>
                       <a:srgbClr val="F2F5F9"/>
                     </a:solidFill>
@@ -6677,7 +6823,7 @@
                       </a:r>
                     </a:p>
                   </a:txBody>
-                  <a:tcPr anchor="ctr" marL="54864" marR="54864" marT="27432" marB="27432">
+                  <a:tcPr marL="54864" marR="54864" marT="27432" marB="27432" anchor="ctr">
                     <a:solidFill>
                       <a:srgbClr val="F2F5F9"/>
                     </a:solidFill>
@@ -6700,7 +6846,7 @@
                       </a:r>
                     </a:p>
                   </a:txBody>
-                  <a:tcPr anchor="ctr" marL="54864" marR="54864" marT="27432" marB="27432">
+                  <a:tcPr marL="54864" marR="54864" marT="27432" marB="27432" anchor="ctr">
                     <a:solidFill>
                       <a:srgbClr val="F2F5F9"/>
                     </a:solidFill>
@@ -6723,7 +6869,7 @@
                       </a:r>
                     </a:p>
                   </a:txBody>
-                  <a:tcPr anchor="ctr" marL="54864" marR="54864" marT="27432" marB="27432">
+                  <a:tcPr marL="54864" marR="54864" marT="27432" marB="27432" anchor="ctr">
                     <a:solidFill>
                       <a:srgbClr val="F2F5F9"/>
                     </a:solidFill>
@@ -6746,12 +6892,17 @@
                       </a:r>
                     </a:p>
                   </a:txBody>
-                  <a:tcPr anchor="ctr" marL="54864" marR="54864" marT="27432" marB="27432">
+                  <a:tcPr marL="54864" marR="54864" marT="27432" marB="27432" anchor="ctr">
                     <a:solidFill>
                       <a:srgbClr val="F2F5F9"/>
                     </a:solidFill>
                   </a:tcPr>
                 </a:tc>
+                <a:extLst>
+                  <a:ext uri="{0D108BD9-81ED-4DB2-BD59-A6C34878D82A}">
+                    <a16:rowId xmlns:a16="http://schemas.microsoft.com/office/drawing/2014/main" val="10006"/>
+                  </a:ext>
+                </a:extLst>
               </a:tr>
             </a:tbl>
           </a:graphicData>

</xml_diff>

<commit_message>
Apply Martins labor reallocation + combine pelvic line
Adopt user's revised model (Martins labor cap 36 -> 40.5 h). Recompute
downstream per Tissue_Model: labor util 99->88%, labor headroom 1.01->1.14x.
Freezer is now co-binding at ~88%, so Martins is labor/freezer-limited at
~1.14x and yield no longer moves the binding constraint. Updated slide 1
(table/headline/what-we're-seeing), slide 2 (Martins card), slide 3
sensitivity (labor-headroom column + how-to-read), and the model's
re-added Pelvic Yield Sensitivity sheet (cap 40.5).

Slide-2 chart: combined the two pelvics into one line, (541+506)/250/wk.

source-files keeps the raw uploaded revision for provenance.

Co-Authored-By: Claude Opus 4.8 <noreply@anthropic.com>
Claude-Session: https://claude.ai/code/session_01LKMb7stbjGviiyFb298aFR
</commit_message>
<xml_diff>
--- a/tissue-capacity-model/deliverables/Tissue_Capacity_2026_2027.pptx
+++ b/tissue-capacity-model/deliverables/Tissue_Capacity_2026_2027.pptx
@@ -136,7 +136,7 @@
               <c:strCache>
                 <c:ptCount val="1"/>
                 <c:pt idx="0">
-                  <c:v>Female Pelvic (541's)</c:v>
+                  <c:v>Pelvic Attainment (541+506)</c:v>
                 </c:pt>
               </c:strCache>
             </c:strRef>
@@ -205,40 +205,40 @@
                 <c:formatCode>General</c:formatCode>
                 <c:ptCount val="12"/>
                 <c:pt idx="0">
-                  <c:v>48</c:v>
+                  <c:v>88</c:v>
                 </c:pt>
                 <c:pt idx="1">
-                  <c:v>55.8</c:v>
+                  <c:v>62.8</c:v>
                 </c:pt>
                 <c:pt idx="2">
-                  <c:v>52</c:v>
+                  <c:v>84</c:v>
                 </c:pt>
                 <c:pt idx="3">
-                  <c:v>53.6</c:v>
+                  <c:v>66.6</c:v>
                 </c:pt>
                 <c:pt idx="4">
-                  <c:v>87</c:v>
+                  <c:v>127</c:v>
                 </c:pt>
                 <c:pt idx="5">
-                  <c:v>114.6</c:v>
+                  <c:v>130</c:v>
                 </c:pt>
                 <c:pt idx="6">
-                  <c:v>61.6</c:v>
+                  <c:v>65.4</c:v>
                 </c:pt>
                 <c:pt idx="7">
-                  <c:v>108.4</c:v>
+                  <c:v>125.4</c:v>
                 </c:pt>
                 <c:pt idx="8">
-                  <c:v>85.6</c:v>
+                  <c:v>141</c:v>
                 </c:pt>
                 <c:pt idx="9">
-                  <c:v>69.400000000000006</c:v>
+                  <c:v>123</c:v>
                 </c:pt>
                 <c:pt idx="10">
-                  <c:v>78.599999999999994</c:v>
+                  <c:v>119.2</c:v>
                 </c:pt>
                 <c:pt idx="11">
-                  <c:v>49.4</c:v>
+                  <c:v>78.2</c:v>
                 </c:pt>
               </c:numCache>
             </c:numRef>
@@ -253,129 +253,6 @@
         <c:ser>
           <c:idx val="1"/>
           <c:order val="1"/>
-          <c:tx>
-            <c:strRef>
-              <c:f>Sheet1!$C$1</c:f>
-              <c:strCache>
-                <c:ptCount val="1"/>
-                <c:pt idx="0">
-                  <c:v>Pelvic Block (506's)</c:v>
-                </c:pt>
-              </c:strCache>
-            </c:strRef>
-          </c:tx>
-          <c:spPr>
-            <a:ln w="31750" cap="flat">
-              <a:solidFill>
-                <a:srgbClr val="12345B"/>
-              </a:solidFill>
-              <a:prstDash val="solid"/>
-              <a:round/>
-            </a:ln>
-            <a:effectLst/>
-          </c:spPr>
-          <c:marker>
-            <c:symbol val="none"/>
-          </c:marker>
-          <c:cat>
-            <c:strRef>
-              <c:f>Sheet1!$A$2:$A$13</c:f>
-              <c:strCache>
-                <c:ptCount val="12"/>
-                <c:pt idx="0">
-                  <c:v>12/29</c:v>
-                </c:pt>
-                <c:pt idx="1">
-                  <c:v>01/12</c:v>
-                </c:pt>
-                <c:pt idx="2">
-                  <c:v>01/26</c:v>
-                </c:pt>
-                <c:pt idx="3">
-                  <c:v>02/09</c:v>
-                </c:pt>
-                <c:pt idx="4">
-                  <c:v>02/23</c:v>
-                </c:pt>
-                <c:pt idx="5">
-                  <c:v>03/09</c:v>
-                </c:pt>
-                <c:pt idx="6">
-                  <c:v>03/23</c:v>
-                </c:pt>
-                <c:pt idx="7">
-                  <c:v>04/06</c:v>
-                </c:pt>
-                <c:pt idx="8">
-                  <c:v>04/20</c:v>
-                </c:pt>
-                <c:pt idx="9">
-                  <c:v>05/04</c:v>
-                </c:pt>
-                <c:pt idx="10">
-                  <c:v>05/18</c:v>
-                </c:pt>
-                <c:pt idx="11">
-                  <c:v>06/01</c:v>
-                </c:pt>
-              </c:strCache>
-            </c:strRef>
-          </c:cat>
-          <c:val>
-            <c:numRef>
-              <c:f>Sheet1!$C$2:$C$13</c:f>
-              <c:numCache>
-                <c:formatCode>General</c:formatCode>
-                <c:ptCount val="12"/>
-                <c:pt idx="0">
-                  <c:v>80</c:v>
-                </c:pt>
-                <c:pt idx="1">
-                  <c:v>7</c:v>
-                </c:pt>
-                <c:pt idx="2">
-                  <c:v>32</c:v>
-                </c:pt>
-                <c:pt idx="3">
-                  <c:v>13</c:v>
-                </c:pt>
-                <c:pt idx="4">
-                  <c:v>40</c:v>
-                </c:pt>
-                <c:pt idx="5">
-                  <c:v>15.4</c:v>
-                </c:pt>
-                <c:pt idx="6">
-                  <c:v>3.8</c:v>
-                </c:pt>
-                <c:pt idx="7">
-                  <c:v>17</c:v>
-                </c:pt>
-                <c:pt idx="8">
-                  <c:v>55.4</c:v>
-                </c:pt>
-                <c:pt idx="9">
-                  <c:v>53.6</c:v>
-                </c:pt>
-                <c:pt idx="10">
-                  <c:v>81.2</c:v>
-                </c:pt>
-                <c:pt idx="11">
-                  <c:v>28.8</c:v>
-                </c:pt>
-              </c:numCache>
-            </c:numRef>
-          </c:val>
-          <c:smooth val="0"/>
-          <c:extLst>
-            <c:ext xmlns:c16="http://schemas.microsoft.com/office/drawing/2014/chart" uri="{C3380CC4-5D6E-409C-BE32-E72D297353CC}">
-              <c16:uniqueId val="{00000001-AB4F-47DF-96E3-C4C373BE84C4}"/>
-            </c:ext>
-          </c:extLst>
-        </c:ser>
-        <c:ser>
-          <c:idx val="2"/>
-          <c:order val="2"/>
           <c:tx>
             <c:strRef>
               <c:f>Sheet1!$D$1</c:f>
@@ -1527,7 +1404,7 @@
                 <a:ea typeface="Calibri" pitchFamily="34" charset="-122"/>
                 <a:cs typeface="Calibri" pitchFamily="34" charset="-120"/>
               </a:rPr>
-              <a:t>1.0× headroom (labor-bound)</a:t>
+              <a:t>1.14× headroom (labor/freezer-bound after the reallocation)</a:t>
             </a:r>
             <a:r>
               <a:rPr lang="en-US" sz="1450" dirty="0">
@@ -1547,7 +1424,7 @@
                 </a:solidFill>
                 <a:latin typeface="Calibri"/>
               </a:rPr>
-              <a:t>   ▸ Lifting pelvic harvest yield pays back hard: +10 pts (25%→35%) frees ~246 pigs &amp; ~4.8 labor-</a:t>
+              <a:t>   ▸ The labor reallocation lifted Martins to 1.14× — now freezer-/labor-bound. Pelvic-yield gains free pigs &amp; labor but don't move freezer, so Martins stays ~1.14× until freezer is addressed too — see slide 3.</a:t>
             </a:r>
             <a:r>
               <a:rPr sz="1100" b="1" i="1" dirty="0" err="1">
@@ -1556,7 +1433,7 @@
                 </a:solidFill>
                 <a:latin typeface="Calibri"/>
               </a:rPr>
-              <a:t>hrs</a:t>
+              <a:t/>
             </a:r>
             <a:r>
               <a:rPr sz="1100" b="1" i="1" dirty="0">
@@ -1565,7 +1442,7 @@
                 </a:solidFill>
                 <a:latin typeface="Calibri"/>
               </a:rPr>
-              <a:t>/</a:t>
+              <a:t/>
             </a:r>
             <a:r>
               <a:rPr sz="1100" b="1" i="1" dirty="0" err="1">
@@ -1574,7 +1451,7 @@
                 </a:solidFill>
                 <a:latin typeface="Calibri"/>
               </a:rPr>
-              <a:t>wk</a:t>
+              <a:t/>
             </a:r>
             <a:r>
               <a:rPr sz="1100" b="1" i="1" dirty="0">
@@ -1583,7 +1460,7 @@
                 </a:solidFill>
                 <a:latin typeface="Calibri"/>
               </a:rPr>
-              <a:t> at Martins, and ~+20 pts (→45%) finally clears 125% on labor — see slide 3.</a:t>
+              <a:t/>
             </a:r>
             <a:endParaRPr lang="en-US" sz="1450" dirty="0"/>
           </a:p>
@@ -1994,7 +1871,7 @@
                 <a:ea typeface="Calibri" pitchFamily="34" charset="-122"/>
                 <a:cs typeface="Calibri" pitchFamily="34" charset="-120"/>
               </a:rPr>
-              <a:t>Labor · Pelvic block</a:t>
+              <a:t>Labor/Freezer · Pelvic</a:t>
             </a:r>
             <a:endParaRPr lang="en-US" sz="950" dirty="0"/>
           </a:p>
@@ -2130,7 +2007,7 @@
                 <a:ea typeface="Calibri" pitchFamily="34" charset="-122"/>
                 <a:cs typeface="Calibri" pitchFamily="34" charset="-120"/>
               </a:rPr>
-              <a:t>99%</a:t>
+              <a:t>88%</a:t>
             </a:r>
             <a:endParaRPr lang="en-US" sz="1250" dirty="0"/>
           </a:p>
@@ -2295,7 +2172,7 @@
                 <a:ea typeface="Calibri" pitchFamily="34" charset="-122"/>
                 <a:cs typeface="Calibri" pitchFamily="34" charset="-120"/>
               </a:rPr>
-              <a:t>1.01×</a:t>
+              <a:t>1.14×</a:t>
             </a:r>
             <a:endParaRPr lang="en-US" sz="1250" dirty="0"/>
           </a:p>
@@ -3984,7 +3861,7 @@
                 <a:ea typeface="Calibri" pitchFamily="34" charset="-122"/>
                 <a:cs typeface="Calibri" pitchFamily="34" charset="-120"/>
               </a:rPr>
-              <a:t>Martins is labor-bound at 99% — only ~1.0× headroom, so it can't cover 125% of 2027 demand (tight even at 100%). </a:t>
+              <a:t>Martins eased to ~88% on labor after the reallocation, but freezer is now equally tight at ~88% — so headroom is ~1.14×, still short of 125%. </a:t>
             </a:r>
             <a:endParaRPr lang="en-US" sz="1250" dirty="0"/>
           </a:p>
@@ -4889,7 +4766,7 @@
                 <a:ea typeface="Calibri" pitchFamily="34" charset="-122"/>
                 <a:cs typeface="Calibri" pitchFamily="34" charset="-120"/>
               </a:rPr>
-              <a:t>LABOR  ·  99%  ·  1.01×</a:t>
+              <a:t>LABOR/FREEZER · 88% · 1.14×</a:t>
             </a:r>
             <a:endParaRPr lang="en-US" sz="850" dirty="0"/>
           </a:p>
@@ -5578,7 +5455,7 @@
                 <a:ea typeface="Calibri" pitchFamily="34" charset="-122"/>
                 <a:cs typeface="Calibri" pitchFamily="34" charset="-120"/>
               </a:rPr>
-              <a:t>PELVIC ATTAINMENT vs 250/WK STANDARD @Martin’s — BIWEEKLY, 2026 YTD – Harvesting Yield </a:t>
+              <a:t>PELVIC ATTAINMENT (541+506) vs 250/WK STANDARD @Martin’s — BIWEEKLY, 2026 YTD – Harvesting Yield </a:t>
             </a:r>
             <a:endParaRPr lang="en-US" sz="1100" dirty="0"/>
           </a:p>
@@ -5669,7 +5546,7 @@
                 <a:ea typeface="Calibri" pitchFamily="34" charset="-122"/>
                 <a:cs typeface="Calibri" pitchFamily="34" charset="-120"/>
               </a:rPr>
-              <a:t>Left: each site is independent; labor &amp; freezer are shared per site, kill capacity is set by tissues that can't come from one pig.  Right: attainment = harvested ÷ 250/wk flat ask (biweekly); Male Pelvic excluded (wound down); zero-harvest weeks excluded from each biweekly point.  Codes are Intuitive part numbers.</a:t>
+              <a:t>Left: each site is independent; labor &amp; freezer are shared per site, kill capacity is set by tissues that can't come from one pig.  Right: attainment = (Female Pelvic 541 + Pelvic Block 506) harvested ÷ 250/wk (biweekly); Male Pelvic excluded (wound down).  Codes are Intuitive part numbers.</a:t>
             </a:r>
             <a:endParaRPr lang="en-US" sz="850" dirty="0"/>
           </a:p>
@@ -6140,7 +6017,7 @@
                           </a:solidFill>
                           <a:latin typeface="Calibri"/>
                         </a:rPr>
-                        <a:t>1.01×</a:t>
+                        <a:t>1.14×</a:t>
                       </a:r>
                     </a:p>
                   </a:txBody>
@@ -6285,7 +6162,7 @@
                           </a:solidFill>
                           <a:latin typeface="Calibri"/>
                         </a:rPr>
-                        <a:t>1.10×</a:t>
+                        <a:t>1.24×</a:t>
                       </a:r>
                     </a:p>
                   </a:txBody>
@@ -6426,11 +6303,11 @@
                       <a:r>
                         <a:rPr sz="1100" b="1">
                           <a:solidFill>
-                            <a:srgbClr val="B0392B"/>
+                            <a:srgbClr val="1E7F3E"/>
                           </a:solidFill>
                           <a:latin typeface="Calibri"/>
                         </a:rPr>
-                        <a:t>1.17×</a:t>
+                        <a:t>1.32×</a:t>
                       </a:r>
                     </a:p>
                   </a:txBody>
@@ -6571,11 +6448,11 @@
                       <a:r>
                         <a:rPr sz="1100" b="1">
                           <a:solidFill>
-                            <a:srgbClr val="B0392B"/>
+                            <a:srgbClr val="1E7F3E"/>
                           </a:solidFill>
                           <a:latin typeface="Calibri"/>
                         </a:rPr>
-                        <a:t>1.23×</a:t>
+                        <a:t>1.39×</a:t>
                       </a:r>
                     </a:p>
                   </a:txBody>
@@ -6720,7 +6597,7 @@
                           </a:solidFill>
                           <a:latin typeface="Calibri"/>
                         </a:rPr>
-                        <a:t>1.28×</a:t>
+                        <a:t>1.44×</a:t>
                       </a:r>
                     </a:p>
                   </a:txBody>
@@ -6865,7 +6742,7 @@
                           </a:solidFill>
                           <a:latin typeface="Calibri"/>
                         </a:rPr>
-                        <a:t>1.33×</a:t>
+                        <a:t>1.49×</a:t>
                       </a:r>
                     </a:p>
                   </a:txBody>
@@ -6946,7 +6823,7 @@
                 </a:solidFill>
                 <a:latin typeface="Calibri"/>
               </a:rPr>
-              <a:t>pigs clear the 125% target immediately, but labor — the binding constraint at Martins — needs about +20 points (yield to 45%) to cross 1.25×. Yield is the lever, yet a sizeable lift is required, so pair it with re-balancing labor off Martins (Milestone 3).</a:t>
+              <a:t>after the labor reallocation Martins sits at 1.14× — now co-limited by labor and freezer (~88% each). Yield still lifts labor (clears 1.25× by ~+10 pts) and pigs, but freezer is unaffected, so Martins overall stays ~1.14× until freezer is also addressed.</a:t>
             </a:r>
           </a:p>
         </p:txBody>

</xml_diff>

<commit_message>
Slide-2 chart: weekly combined pelvic line (506+518+541)/250
Rebuild the slide-2 chart as a single WEEKLY line summing 666506 + 666518
+ 666541 harvested vs a flat 250/wk ask (25 points, switched from
biweekly). 666518 (Pelvic Block SM Intact) is currently all zeros, so it
is included in the formula but does not change the line. Title/footnote
updated to weekly + three codes.

Co-Authored-By: Claude Opus 4.8 <noreply@anthropic.com>
Claude-Session: https://claude.ai/code/session_01LKMb7stbjGviiyFb298aFR
</commit_message>
<xml_diff>
--- a/tissue-capacity-model/deliverables/Tissue_Capacity_2026_2027.pptx
+++ b/tissue-capacity-model/deliverables/Tissue_Capacity_2026_2027.pptx
@@ -136,7 +136,7 @@
               <c:strCache>
                 <c:ptCount val="1"/>
                 <c:pt idx="0">
-                  <c:v>Pelvic Attainment (541+506)</c:v>
+                  <c:v>Pelvic Attainment (506+518+541)</c:v>
                 </c:pt>
               </c:strCache>
             </c:strRef>
@@ -156,89 +156,167 @@
           </c:marker>
           <c:cat>
             <c:strRef>
-              <c:f>Sheet1!$A$2:$A$13</c:f>
+              <c:f>Sheet1!$A$2:$A$26</c:f>
               <c:strCache>
-                <c:ptCount val="12"/>
+                <c:ptCount val="25"/>
                 <c:pt idx="0">
                   <c:v>12/29</c:v>
                 </c:pt>
                 <c:pt idx="1">
+                  <c:v>01/05</c:v>
+                </c:pt>
+                <c:pt idx="2">
                   <c:v>01/12</c:v>
                 </c:pt>
-                <c:pt idx="2">
+                <c:pt idx="3">
+                  <c:v>01/19</c:v>
+                </c:pt>
+                <c:pt idx="4">
                   <c:v>01/26</c:v>
                 </c:pt>
-                <c:pt idx="3">
+                <c:pt idx="5">
+                  <c:v>02/02</c:v>
+                </c:pt>
+                <c:pt idx="6">
                   <c:v>02/09</c:v>
                 </c:pt>
-                <c:pt idx="4">
+                <c:pt idx="7">
+                  <c:v>02/16</c:v>
+                </c:pt>
+                <c:pt idx="8">
                   <c:v>02/23</c:v>
                 </c:pt>
-                <c:pt idx="5">
+                <c:pt idx="9">
+                  <c:v>03/02</c:v>
+                </c:pt>
+                <c:pt idx="10">
                   <c:v>03/09</c:v>
                 </c:pt>
-                <c:pt idx="6">
+                <c:pt idx="11">
+                  <c:v>03/16</c:v>
+                </c:pt>
+                <c:pt idx="12">
                   <c:v>03/23</c:v>
                 </c:pt>
-                <c:pt idx="7">
+                <c:pt idx="13">
+                  <c:v>03/30</c:v>
+                </c:pt>
+                <c:pt idx="14">
                   <c:v>04/06</c:v>
                 </c:pt>
-                <c:pt idx="8">
+                <c:pt idx="15">
+                  <c:v>04/13</c:v>
+                </c:pt>
+                <c:pt idx="16">
                   <c:v>04/20</c:v>
                 </c:pt>
-                <c:pt idx="9">
+                <c:pt idx="17">
+                  <c:v>04/27</c:v>
+                </c:pt>
+                <c:pt idx="18">
                   <c:v>05/04</c:v>
                 </c:pt>
-                <c:pt idx="10">
+                <c:pt idx="19">
+                  <c:v>05/11</c:v>
+                </c:pt>
+                <c:pt idx="20">
                   <c:v>05/18</c:v>
                 </c:pt>
-                <c:pt idx="11">
+                <c:pt idx="21">
+                  <c:v>05/25</c:v>
+                </c:pt>
+                <c:pt idx="22">
                   <c:v>06/01</c:v>
+                </c:pt>
+                <c:pt idx="23">
+                  <c:v>06/08</c:v>
+                </c:pt>
+                <c:pt idx="24">
+                  <c:v>06/15</c:v>
                 </c:pt>
               </c:strCache>
             </c:strRef>
           </c:cat>
           <c:val>
             <c:numRef>
-              <c:f>Sheet1!$B$2:$B$13</c:f>
+              <c:f>Sheet1!$B$2:$B$26</c:f>
               <c:numCache>
                 <c:formatCode>General</c:formatCode>
-                <c:ptCount val="12"/>
+                <c:ptCount val="25"/>
                 <c:pt idx="0">
-                  <c:v>88</c:v>
+                  <c:v>70</c:v>
                 </c:pt>
                 <c:pt idx="1">
-                  <c:v>62.8</c:v>
+                  <c:v>106</c:v>
                 </c:pt>
                 <c:pt idx="2">
-                  <c:v>84</c:v>
+                  <c:v>66.4</c:v>
                 </c:pt>
                 <c:pt idx="3">
-                  <c:v>66.6</c:v>
+                  <c:v>59.2</c:v>
                 </c:pt>
                 <c:pt idx="4">
-                  <c:v>127</c:v>
+                  <c:v>70.4</c:v>
                 </c:pt>
                 <c:pt idx="5">
-                  <c:v>130</c:v>
+                  <c:v>97.6</c:v>
                 </c:pt>
                 <c:pt idx="6">
-                  <c:v>65.4</c:v>
+                  <c:v>47.2</c:v>
                 </c:pt>
                 <c:pt idx="7">
-                  <c:v>125.4</c:v>
+                  <c:v>86</c:v>
                 </c:pt>
                 <c:pt idx="8">
-                  <c:v>141</c:v>
+                  <c:v>114.8</c:v>
                 </c:pt>
                 <c:pt idx="9">
-                  <c:v>123</c:v>
+                  <c:v>139.2</c:v>
                 </c:pt>
                 <c:pt idx="10">
-                  <c:v>119.2</c:v>
+                  <c:v>110</c:v>
                 </c:pt>
                 <c:pt idx="11">
-                  <c:v>78.2</c:v>
+                  <c:v>150</c:v>
+                </c:pt>
+                <c:pt idx="12">
+                  <c:v>65.2</c:v>
+                </c:pt>
+                <c:pt idx="13">
+                  <c:v>65.6</c:v>
+                </c:pt>
+                <c:pt idx="14">
+                  <c:v>97.6</c:v>
+                </c:pt>
+                <c:pt idx="15">
+                  <c:v>153.2</c:v>
+                </c:pt>
+                <c:pt idx="16">
+                  <c:v>157.6</c:v>
+                </c:pt>
+                <c:pt idx="17">
+                  <c:v>124.4</c:v>
+                </c:pt>
+                <c:pt idx="18">
+                  <c:v>121.2</c:v>
+                </c:pt>
+                <c:pt idx="19">
+                  <c:v>124.8</c:v>
+                </c:pt>
+                <c:pt idx="20">
+                  <c:v>162</c:v>
+                </c:pt>
+                <c:pt idx="21">
+                  <c:v>76.4</c:v>
+                </c:pt>
+                <c:pt idx="22">
+                  <c:v>107.6</c:v>
+                </c:pt>
+                <c:pt idx="23">
+                  <c:v>48.8</c:v>
+                </c:pt>
+                <c:pt idx="24">
+                  <c:v>96.8</c:v>
                 </c:pt>
               </c:numCache>
             </c:numRef>
@@ -279,54 +357,93 @@
           </c:marker>
           <c:cat>
             <c:strRef>
-              <c:f>Sheet1!$A$2:$A$13</c:f>
+              <c:f>Sheet1!$A$2:$A$26</c:f>
               <c:strCache>
-                <c:ptCount val="12"/>
+                <c:ptCount val="25"/>
                 <c:pt idx="0">
                   <c:v>12/29</c:v>
                 </c:pt>
                 <c:pt idx="1">
+                  <c:v>01/05</c:v>
+                </c:pt>
+                <c:pt idx="2">
                   <c:v>01/12</c:v>
                 </c:pt>
-                <c:pt idx="2">
+                <c:pt idx="3">
+                  <c:v>01/19</c:v>
+                </c:pt>
+                <c:pt idx="4">
                   <c:v>01/26</c:v>
                 </c:pt>
-                <c:pt idx="3">
+                <c:pt idx="5">
+                  <c:v>02/02</c:v>
+                </c:pt>
+                <c:pt idx="6">
                   <c:v>02/09</c:v>
                 </c:pt>
-                <c:pt idx="4">
+                <c:pt idx="7">
+                  <c:v>02/16</c:v>
+                </c:pt>
+                <c:pt idx="8">
                   <c:v>02/23</c:v>
                 </c:pt>
-                <c:pt idx="5">
+                <c:pt idx="9">
+                  <c:v>03/02</c:v>
+                </c:pt>
+                <c:pt idx="10">
                   <c:v>03/09</c:v>
                 </c:pt>
-                <c:pt idx="6">
+                <c:pt idx="11">
+                  <c:v>03/16</c:v>
+                </c:pt>
+                <c:pt idx="12">
                   <c:v>03/23</c:v>
                 </c:pt>
-                <c:pt idx="7">
+                <c:pt idx="13">
+                  <c:v>03/30</c:v>
+                </c:pt>
+                <c:pt idx="14">
                   <c:v>04/06</c:v>
                 </c:pt>
-                <c:pt idx="8">
+                <c:pt idx="15">
+                  <c:v>04/13</c:v>
+                </c:pt>
+                <c:pt idx="16">
                   <c:v>04/20</c:v>
                 </c:pt>
-                <c:pt idx="9">
+                <c:pt idx="17">
+                  <c:v>04/27</c:v>
+                </c:pt>
+                <c:pt idx="18">
                   <c:v>05/04</c:v>
                 </c:pt>
-                <c:pt idx="10">
+                <c:pt idx="19">
+                  <c:v>05/11</c:v>
+                </c:pt>
+                <c:pt idx="20">
                   <c:v>05/18</c:v>
                 </c:pt>
-                <c:pt idx="11">
+                <c:pt idx="21">
+                  <c:v>05/25</c:v>
+                </c:pt>
+                <c:pt idx="22">
                   <c:v>06/01</c:v>
+                </c:pt>
+                <c:pt idx="23">
+                  <c:v>06/08</c:v>
+                </c:pt>
+                <c:pt idx="24">
+                  <c:v>06/15</c:v>
                 </c:pt>
               </c:strCache>
             </c:strRef>
           </c:cat>
           <c:val>
             <c:numRef>
-              <c:f>Sheet1!$D$2:$D$13</c:f>
+              <c:f>Sheet1!$D$2:$D$26</c:f>
               <c:numCache>
                 <c:formatCode>General</c:formatCode>
-                <c:ptCount val="12"/>
+                <c:ptCount val="25"/>
                 <c:pt idx="0">
                   <c:v>100</c:v>
                 </c:pt>
@@ -361,6 +478,45 @@
                   <c:v>100</c:v>
                 </c:pt>
                 <c:pt idx="11">
+                  <c:v>100</c:v>
+                </c:pt>
+                <c:pt idx="12">
+                  <c:v>100</c:v>
+                </c:pt>
+                <c:pt idx="13">
+                  <c:v>100</c:v>
+                </c:pt>
+                <c:pt idx="14">
+                  <c:v>100</c:v>
+                </c:pt>
+                <c:pt idx="15">
+                  <c:v>100</c:v>
+                </c:pt>
+                <c:pt idx="16">
+                  <c:v>100</c:v>
+                </c:pt>
+                <c:pt idx="17">
+                  <c:v>100</c:v>
+                </c:pt>
+                <c:pt idx="18">
+                  <c:v>100</c:v>
+                </c:pt>
+                <c:pt idx="19">
+                  <c:v>100</c:v>
+                </c:pt>
+                <c:pt idx="20">
+                  <c:v>100</c:v>
+                </c:pt>
+                <c:pt idx="21">
+                  <c:v>100</c:v>
+                </c:pt>
+                <c:pt idx="22">
+                  <c:v>100</c:v>
+                </c:pt>
+                <c:pt idx="23">
+                  <c:v>100</c:v>
+                </c:pt>
+                <c:pt idx="24">
                   <c:v>100</c:v>
                 </c:pt>
               </c:numCache>
@@ -5455,7 +5611,7 @@
                 <a:ea typeface="Calibri" pitchFamily="34" charset="-122"/>
                 <a:cs typeface="Calibri" pitchFamily="34" charset="-120"/>
               </a:rPr>
-              <a:t>PELVIC ATTAINMENT (541+506) vs 250/WK STANDARD @Martin’s — BIWEEKLY, 2026 YTD – Harvesting Yield </a:t>
+              <a:t>PELVIC ATTAINMENT (506+518+541) vs 250/WK STANDARD @Martin’s — WEEKLY, 2026 YTD – Harvesting Yield </a:t>
             </a:r>
             <a:endParaRPr lang="en-US" sz="1100" dirty="0"/>
           </a:p>
@@ -5546,7 +5702,7 @@
                 <a:ea typeface="Calibri" pitchFamily="34" charset="-122"/>
                 <a:cs typeface="Calibri" pitchFamily="34" charset="-120"/>
               </a:rPr>
-              <a:t>Left: each site is independent; labor &amp; freezer are shared per site, kill capacity is set by tissues that can't come from one pig.  Right: attainment = (Female Pelvic 541 + Pelvic Block 506) harvested ÷ 250/wk (biweekly); Male Pelvic excluded (wound down).  Codes are Intuitive part numbers.</a:t>
+              <a:t>Left: each site is independent; labor &amp; freezer are shared per site, kill capacity is set by tissues that can't come from one pig.  Right: attainment = (Pelvic Block 506 + SM Intact 518 + Female Pelvic 541) harvested ÷ 250/wk (weekly); Male Pelvic excluded (wound down).  Codes are Intuitive part numbers.</a:t>
             </a:r>
             <a:endParaRPr lang="en-US" sz="850" dirty="0"/>
           </a:p>

</xml_diff>

<commit_message>
Revert slide 2 to single combined pelvic line vs 250 (Martins)
Drop the two per-tissue (170/60) graphs and restore the combined weekly
line: (666506 + 666518 + 666541) harvested / 250 per week, Martins only,
with the 100% ask reference. Slides 1 and 3 and the model are unchanged.

Weekly workbook: "Pelvic Attainment @250" tab now holds the combined
weekly calc (replaces the 170/60 tab); 18 charts preserved.

Co-Authored-By: Claude Opus 4.8 <noreply@anthropic.com>
Claude-Session: https://claude.ai/code/session_01LKMb7stbjGviiyFb298aFR
</commit_message>
<xml_diff>
--- a/tissue-capacity-model/deliverables/Tissue_Capacity_2026_2027.pptx
+++ b/tissue-capacity-model/deliverables/Tissue_Capacity_2026_2027.pptx
@@ -678,946 +678,6 @@
   <c:externalData r:id="rId1">
     <c:autoUpdate val="0"/>
   </c:externalData>
-</c:chartSpace>
-</file>
-
-<file path=ppt/charts/chart2.xml><?xml version="1.0" encoding="utf-8"?>
-<c:chartSpace xmlns:c="http://schemas.openxmlformats.org/drawingml/2006/chart" xmlns:a="http://schemas.openxmlformats.org/drawingml/2006/main" xmlns:r="http://schemas.openxmlformats.org/officeDocument/2006/relationships">
-  <c:date1904 val="0"/>
-  <c:chart>
-    <c:autoTitleDeleted val="1"/>
-    <c:plotArea>
-      <c:lineChart>
-        <c:grouping val="standard"/>
-        <c:varyColors val="0"/>
-        <c:ser>
-          <c:idx val="0"/>
-          <c:order val="0"/>
-          <c:tx>
-            <c:strRef>
-              <c:f>Sheet1!$B$1</c:f>
-              <c:strCache>
-                <c:ptCount val="1"/>
-                <c:pt idx="0">
-                  <c:v>Female Pelvic 541</c:v>
-                </c:pt>
-              </c:strCache>
-            </c:strRef>
-          </c:tx>
-          <c:spPr>
-            <a:ln w="25400">
-              <a:solidFill>
-                <a:srgbClr val="12345B"/>
-              </a:solidFill>
-            </a:ln>
-          </c:spPr>
-          <c:marker>
-            <c:symbol val="none"/>
-          </c:marker>
-          <c:cat>
-            <c:strRef>
-              <c:f>Sheet1!$A$2:$A$26</c:f>
-              <c:strCache>
-                <c:ptCount val="25"/>
-                <c:pt idx="0">
-                  <c:v>12/29</c:v>
-                </c:pt>
-                <c:pt idx="1">
-                  <c:v>01/05</c:v>
-                </c:pt>
-                <c:pt idx="2">
-                  <c:v>01/12</c:v>
-                </c:pt>
-                <c:pt idx="3">
-                  <c:v>01/19</c:v>
-                </c:pt>
-                <c:pt idx="4">
-                  <c:v>01/26</c:v>
-                </c:pt>
-                <c:pt idx="5">
-                  <c:v>02/02</c:v>
-                </c:pt>
-                <c:pt idx="6">
-                  <c:v>02/09</c:v>
-                </c:pt>
-                <c:pt idx="7">
-                  <c:v>02/16</c:v>
-                </c:pt>
-                <c:pt idx="8">
-                  <c:v>02/23</c:v>
-                </c:pt>
-                <c:pt idx="9">
-                  <c:v>03/02</c:v>
-                </c:pt>
-                <c:pt idx="10">
-                  <c:v>03/09</c:v>
-                </c:pt>
-                <c:pt idx="11">
-                  <c:v>03/16</c:v>
-                </c:pt>
-                <c:pt idx="12">
-                  <c:v>03/23</c:v>
-                </c:pt>
-                <c:pt idx="13">
-                  <c:v>03/30</c:v>
-                </c:pt>
-                <c:pt idx="14">
-                  <c:v>04/06</c:v>
-                </c:pt>
-                <c:pt idx="15">
-                  <c:v>04/13</c:v>
-                </c:pt>
-                <c:pt idx="16">
-                  <c:v>04/20</c:v>
-                </c:pt>
-                <c:pt idx="17">
-                  <c:v>04/27</c:v>
-                </c:pt>
-                <c:pt idx="18">
-                  <c:v>05/04</c:v>
-                </c:pt>
-                <c:pt idx="19">
-                  <c:v>05/11</c:v>
-                </c:pt>
-                <c:pt idx="20">
-                  <c:v>05/18</c:v>
-                </c:pt>
-                <c:pt idx="21">
-                  <c:v>05/25</c:v>
-                </c:pt>
-                <c:pt idx="22">
-                  <c:v>06/01</c:v>
-                </c:pt>
-                <c:pt idx="23">
-                  <c:v>06/08</c:v>
-                </c:pt>
-                <c:pt idx="24">
-                  <c:v>06/15</c:v>
-                </c:pt>
-              </c:strCache>
-            </c:strRef>
-          </c:cat>
-          <c:val>
-            <c:numRef>
-              <c:f>Sheet1!$B$2:$B$26</c:f>
-              <c:numCache>
-                <c:formatCode>General</c:formatCode>
-                <c:ptCount val="25"/>
-                <c:pt idx="0">
-                  <c:v>102.9</c:v>
-                </c:pt>
-                <c:pt idx="1">
-                  <c:v>38.2</c:v>
-                </c:pt>
-                <c:pt idx="2">
-                  <c:v>92.9</c:v>
-                </c:pt>
-                <c:pt idx="3">
-                  <c:v>71.2</c:v>
-                </c:pt>
-                <c:pt idx="4">
-                  <c:v>91.8</c:v>
-                </c:pt>
-                <c:pt idx="5">
-                  <c:v>61.2</c:v>
-                </c:pt>
-                <c:pt idx="6">
-                  <c:v>55.9</c:v>
-                </c:pt>
-                <c:pt idx="7">
-                  <c:v>101.8</c:v>
-                </c:pt>
-                <c:pt idx="8">
-                  <c:v>141.2</c:v>
-                </c:pt>
-                <c:pt idx="9">
-                  <c:v>114.7</c:v>
-                </c:pt>
-                <c:pt idx="10">
-                  <c:v>147.6</c:v>
-                </c:pt>
-                <c:pt idx="11">
-                  <c:v>189.4</c:v>
-                </c:pt>
-                <c:pt idx="12">
-                  <c:v>87.6</c:v>
-                </c:pt>
-                <c:pt idx="13">
-                  <c:v>93.5</c:v>
-                </c:pt>
-                <c:pt idx="14">
-                  <c:v>128.8</c:v>
-                </c:pt>
-                <c:pt idx="15">
-                  <c:v>190.0</c:v>
-                </c:pt>
-                <c:pt idx="16">
-                  <c:v>141.2</c:v>
-                </c:pt>
-                <c:pt idx="17">
-                  <c:v>110.6</c:v>
-                </c:pt>
-                <c:pt idx="18">
-                  <c:v>108.2</c:v>
-                </c:pt>
-                <c:pt idx="19">
-                  <c:v>95.9</c:v>
-                </c:pt>
-                <c:pt idx="20">
-                  <c:v>118.8</c:v>
-                </c:pt>
-                <c:pt idx="21">
-                  <c:v>112.4</c:v>
-                </c:pt>
-                <c:pt idx="22">
-                  <c:v>83.5</c:v>
-                </c:pt>
-                <c:pt idx="23">
-                  <c:v>61.8</c:v>
-                </c:pt>
-                <c:pt idx="24">
-                  <c:v>64.7</c:v>
-                </c:pt>
-              </c:numCache>
-            </c:numRef>
-          </c:val>
-          <c:smooth val="0"/>
-        </c:ser>
-        <c:ser>
-          <c:idx val="1"/>
-          <c:order val="1"/>
-          <c:tx>
-            <c:strRef>
-              <c:f>Sheet1!$C$1</c:f>
-              <c:strCache>
-                <c:ptCount val="1"/>
-                <c:pt idx="0">
-                  <c:v>Ask (100%)</c:v>
-                </c:pt>
-              </c:strCache>
-            </c:strRef>
-          </c:tx>
-          <c:spPr>
-            <a:ln w="15875">
-              <a:solidFill>
-                <a:srgbClr val="9AA7B4"/>
-              </a:solidFill>
-              <a:prstDash val="dash"/>
-            </a:ln>
-          </c:spPr>
-          <c:marker>
-            <c:symbol val="none"/>
-          </c:marker>
-          <c:cat>
-            <c:strRef>
-              <c:f>Sheet1!$A$2:$A$26</c:f>
-              <c:strCache>
-                <c:ptCount val="25"/>
-                <c:pt idx="0">
-                  <c:v>12/29</c:v>
-                </c:pt>
-                <c:pt idx="1">
-                  <c:v>01/05</c:v>
-                </c:pt>
-                <c:pt idx="2">
-                  <c:v>01/12</c:v>
-                </c:pt>
-                <c:pt idx="3">
-                  <c:v>01/19</c:v>
-                </c:pt>
-                <c:pt idx="4">
-                  <c:v>01/26</c:v>
-                </c:pt>
-                <c:pt idx="5">
-                  <c:v>02/02</c:v>
-                </c:pt>
-                <c:pt idx="6">
-                  <c:v>02/09</c:v>
-                </c:pt>
-                <c:pt idx="7">
-                  <c:v>02/16</c:v>
-                </c:pt>
-                <c:pt idx="8">
-                  <c:v>02/23</c:v>
-                </c:pt>
-                <c:pt idx="9">
-                  <c:v>03/02</c:v>
-                </c:pt>
-                <c:pt idx="10">
-                  <c:v>03/09</c:v>
-                </c:pt>
-                <c:pt idx="11">
-                  <c:v>03/16</c:v>
-                </c:pt>
-                <c:pt idx="12">
-                  <c:v>03/23</c:v>
-                </c:pt>
-                <c:pt idx="13">
-                  <c:v>03/30</c:v>
-                </c:pt>
-                <c:pt idx="14">
-                  <c:v>04/06</c:v>
-                </c:pt>
-                <c:pt idx="15">
-                  <c:v>04/13</c:v>
-                </c:pt>
-                <c:pt idx="16">
-                  <c:v>04/20</c:v>
-                </c:pt>
-                <c:pt idx="17">
-                  <c:v>04/27</c:v>
-                </c:pt>
-                <c:pt idx="18">
-                  <c:v>05/04</c:v>
-                </c:pt>
-                <c:pt idx="19">
-                  <c:v>05/11</c:v>
-                </c:pt>
-                <c:pt idx="20">
-                  <c:v>05/18</c:v>
-                </c:pt>
-                <c:pt idx="21">
-                  <c:v>05/25</c:v>
-                </c:pt>
-                <c:pt idx="22">
-                  <c:v>06/01</c:v>
-                </c:pt>
-                <c:pt idx="23">
-                  <c:v>06/08</c:v>
-                </c:pt>
-                <c:pt idx="24">
-                  <c:v>06/15</c:v>
-                </c:pt>
-              </c:strCache>
-            </c:strRef>
-          </c:cat>
-          <c:val>
-            <c:numRef>
-              <c:f>Sheet1!$C$2:$C$26</c:f>
-              <c:numCache>
-                <c:formatCode>General</c:formatCode>
-                <c:ptCount val="25"/>
-                <c:pt idx="0">
-                  <c:v>100</c:v>
-                </c:pt>
-                <c:pt idx="1">
-                  <c:v>100</c:v>
-                </c:pt>
-                <c:pt idx="2">
-                  <c:v>100</c:v>
-                </c:pt>
-                <c:pt idx="3">
-                  <c:v>100</c:v>
-                </c:pt>
-                <c:pt idx="4">
-                  <c:v>100</c:v>
-                </c:pt>
-                <c:pt idx="5">
-                  <c:v>100</c:v>
-                </c:pt>
-                <c:pt idx="6">
-                  <c:v>100</c:v>
-                </c:pt>
-                <c:pt idx="7">
-                  <c:v>100</c:v>
-                </c:pt>
-                <c:pt idx="8">
-                  <c:v>100</c:v>
-                </c:pt>
-                <c:pt idx="9">
-                  <c:v>100</c:v>
-                </c:pt>
-                <c:pt idx="10">
-                  <c:v>100</c:v>
-                </c:pt>
-                <c:pt idx="11">
-                  <c:v>100</c:v>
-                </c:pt>
-                <c:pt idx="12">
-                  <c:v>100</c:v>
-                </c:pt>
-                <c:pt idx="13">
-                  <c:v>100</c:v>
-                </c:pt>
-                <c:pt idx="14">
-                  <c:v>100</c:v>
-                </c:pt>
-                <c:pt idx="15">
-                  <c:v>100</c:v>
-                </c:pt>
-                <c:pt idx="16">
-                  <c:v>100</c:v>
-                </c:pt>
-                <c:pt idx="17">
-                  <c:v>100</c:v>
-                </c:pt>
-                <c:pt idx="18">
-                  <c:v>100</c:v>
-                </c:pt>
-                <c:pt idx="19">
-                  <c:v>100</c:v>
-                </c:pt>
-                <c:pt idx="20">
-                  <c:v>100</c:v>
-                </c:pt>
-                <c:pt idx="21">
-                  <c:v>100</c:v>
-                </c:pt>
-                <c:pt idx="22">
-                  <c:v>100</c:v>
-                </c:pt>
-                <c:pt idx="23">
-                  <c:v>100</c:v>
-                </c:pt>
-                <c:pt idx="24">
-                  <c:v>100</c:v>
-                </c:pt>
-              </c:numCache>
-            </c:numRef>
-          </c:val>
-          <c:smooth val="0"/>
-        </c:ser>
-        <c:marker val="1"/>
-        <c:smooth val="0"/>
-        <c:axId val="2118791784"/>
-        <c:axId val="2140495176"/>
-      </c:lineChart>
-      <c:catAx>
-        <c:axId val="2118791784"/>
-        <c:scaling>
-          <c:orientation val="minMax"/>
-        </c:scaling>
-        <c:delete val="0"/>
-        <c:axPos val="b"/>
-        <c:majorTickMark val="out"/>
-        <c:minorTickMark val="none"/>
-        <c:tickLblPos val="nextTo"/>
-        <c:txPr>
-          <a:bodyPr/>
-          <a:lstStyle/>
-          <a:p>
-            <a:pPr>
-              <a:defRPr sz="600"/>
-            </a:pPr>
-          </a:p>
-        </c:txPr>
-        <c:crossAx val="2140495176"/>
-        <c:crosses val="autoZero"/>
-        <c:auto val="1"/>
-        <c:lblAlgn val="ctr"/>
-        <c:lblOffset val="100"/>
-        <c:noMultiLvlLbl val="0"/>
-      </c:catAx>
-      <c:valAx>
-        <c:axId val="2140495176"/>
-        <c:scaling>
-          <c:min val="0.0"/>
-        </c:scaling>
-        <c:delete val="0"/>
-        <c:axPos val="l"/>
-        <c:majorGridlines/>
-        <c:numFmt formatCode="0&quot;%&quot;" sourceLinked="0"/>
-        <c:majorTickMark val="out"/>
-        <c:minorTickMark val="none"/>
-        <c:tickLblPos val="nextTo"/>
-        <c:txPr>
-          <a:bodyPr/>
-          <a:lstStyle/>
-          <a:p>
-            <a:pPr>
-              <a:defRPr sz="700"/>
-            </a:pPr>
-          </a:p>
-        </c:txPr>
-        <c:crossAx val="2118791784"/>
-        <c:crosses val="autoZero"/>
-      </c:valAx>
-    </c:plotArea>
-    <c:plotVisOnly val="1"/>
-    <c:dispBlanksAs val="gap"/>
-    <c:showDLblsOverMax val="0"/>
-  </c:chart>
-  <c:txPr>
-    <a:bodyPr/>
-    <a:lstStyle/>
-    <a:p>
-      <a:pPr>
-        <a:defRPr sz="700"/>
-      </a:pPr>
-      <a:endParaRPr lang="en-US"/>
-    </a:p>
-  </c:txPr>
-  <c:externalData r:id="rId1">
-    <c:autoUpdate val="0"/>
-  </c:externalData>
-  <c:dispBlanksAs val="gap"/>
-</c:chartSpace>
-</file>
-
-<file path=ppt/charts/chart3.xml><?xml version="1.0" encoding="utf-8"?>
-<c:chartSpace xmlns:c="http://schemas.openxmlformats.org/drawingml/2006/chart" xmlns:a="http://schemas.openxmlformats.org/drawingml/2006/main" xmlns:r="http://schemas.openxmlformats.org/officeDocument/2006/relationships">
-  <c:date1904 val="0"/>
-  <c:chart>
-    <c:autoTitleDeleted val="1"/>
-    <c:plotArea>
-      <c:lineChart>
-        <c:grouping val="standard"/>
-        <c:varyColors val="0"/>
-        <c:ser>
-          <c:idx val="0"/>
-          <c:order val="0"/>
-          <c:tx>
-            <c:strRef>
-              <c:f>Sheet1!$B$1</c:f>
-              <c:strCache>
-                <c:ptCount val="1"/>
-                <c:pt idx="0">
-                  <c:v>Pelvic Block 506</c:v>
-                </c:pt>
-              </c:strCache>
-            </c:strRef>
-          </c:tx>
-          <c:spPr>
-            <a:ln w="25400">
-              <a:solidFill>
-                <a:srgbClr val="12345B"/>
-              </a:solidFill>
-            </a:ln>
-          </c:spPr>
-          <c:marker>
-            <c:symbol val="none"/>
-          </c:marker>
-          <c:cat>
-            <c:strRef>
-              <c:f>Sheet1!$A$2:$A$26</c:f>
-              <c:strCache>
-                <c:ptCount val="25"/>
-                <c:pt idx="0">
-                  <c:v>12/29</c:v>
-                </c:pt>
-                <c:pt idx="1">
-                  <c:v>01/05</c:v>
-                </c:pt>
-                <c:pt idx="2">
-                  <c:v>01/12</c:v>
-                </c:pt>
-                <c:pt idx="3">
-                  <c:v>01/19</c:v>
-                </c:pt>
-                <c:pt idx="4">
-                  <c:v>01/26</c:v>
-                </c:pt>
-                <c:pt idx="5">
-                  <c:v>02/02</c:v>
-                </c:pt>
-                <c:pt idx="6">
-                  <c:v>02/09</c:v>
-                </c:pt>
-                <c:pt idx="7">
-                  <c:v>02/16</c:v>
-                </c:pt>
-                <c:pt idx="8">
-                  <c:v>02/23</c:v>
-                </c:pt>
-                <c:pt idx="9">
-                  <c:v>03/02</c:v>
-                </c:pt>
-                <c:pt idx="10">
-                  <c:v>03/09</c:v>
-                </c:pt>
-                <c:pt idx="11">
-                  <c:v>03/16</c:v>
-                </c:pt>
-                <c:pt idx="12">
-                  <c:v>03/23</c:v>
-                </c:pt>
-                <c:pt idx="13">
-                  <c:v>03/30</c:v>
-                </c:pt>
-                <c:pt idx="14">
-                  <c:v>04/06</c:v>
-                </c:pt>
-                <c:pt idx="15">
-                  <c:v>04/13</c:v>
-                </c:pt>
-                <c:pt idx="16">
-                  <c:v>04/20</c:v>
-                </c:pt>
-                <c:pt idx="17">
-                  <c:v>04/27</c:v>
-                </c:pt>
-                <c:pt idx="18">
-                  <c:v>05/04</c:v>
-                </c:pt>
-                <c:pt idx="19">
-                  <c:v>05/11</c:v>
-                </c:pt>
-                <c:pt idx="20">
-                  <c:v>05/18</c:v>
-                </c:pt>
-                <c:pt idx="21">
-                  <c:v>05/25</c:v>
-                </c:pt>
-                <c:pt idx="22">
-                  <c:v>06/01</c:v>
-                </c:pt>
-                <c:pt idx="23">
-                  <c:v>06/08</c:v>
-                </c:pt>
-                <c:pt idx="24">
-                  <c:v>06/15</c:v>
-                </c:pt>
-              </c:strCache>
-            </c:strRef>
-          </c:cat>
-          <c:val>
-            <c:numRef>
-              <c:f>Sheet1!$B$2:$B$26</c:f>
-              <c:numCache>
-                <c:formatCode>General</c:formatCode>
-                <c:ptCount val="25"/>
-                <c:pt idx="1">
-                  <c:v>333.3</c:v>
-                </c:pt>
-                <c:pt idx="2">
-                  <c:v>13.3</c:v>
-                </c:pt>
-                <c:pt idx="3">
-                  <c:v>45.0</c:v>
-                </c:pt>
-                <c:pt idx="4">
-                  <c:v>33.3</c:v>
-                </c:pt>
-                <c:pt idx="5">
-                  <c:v>233.3</c:v>
-                </c:pt>
-                <c:pt idx="6">
-                  <c:v>38.3</c:v>
-                </c:pt>
-                <c:pt idx="7">
-                  <c:v>70.0</c:v>
-                </c:pt>
-                <c:pt idx="8">
-                  <c:v>78.3</c:v>
-                </c:pt>
-                <c:pt idx="9">
-                  <c:v>255.0</c:v>
-                </c:pt>
-                <c:pt idx="10">
-                  <c:v>40.0</c:v>
-                </c:pt>
-                <c:pt idx="11">
-                  <c:v>88.3</c:v>
-                </c:pt>
-                <c:pt idx="12">
-                  <c:v>23.3</c:v>
-                </c:pt>
-                <c:pt idx="13">
-                  <c:v>8.3</c:v>
-                </c:pt>
-                <c:pt idx="14">
-                  <c:v>41.7</c:v>
-                </c:pt>
-                <c:pt idx="15">
-                  <c:v>100.0</c:v>
-                </c:pt>
-                <c:pt idx="16">
-                  <c:v>256.7</c:v>
-                </c:pt>
-                <c:pt idx="17">
-                  <c:v>205.0</c:v>
-                </c:pt>
-                <c:pt idx="18">
-                  <c:v>198.3</c:v>
-                </c:pt>
-                <c:pt idx="19">
-                  <c:v>248.3</c:v>
-                </c:pt>
-                <c:pt idx="20">
-                  <c:v>338.3</c:v>
-                </c:pt>
-                <c:pt idx="22">
-                  <c:v>211.7</c:v>
-                </c:pt>
-                <c:pt idx="23">
-                  <c:v>28.3</c:v>
-                </c:pt>
-                <c:pt idx="24">
-                  <c:v>220.0</c:v>
-                </c:pt>
-              </c:numCache>
-            </c:numRef>
-          </c:val>
-          <c:smooth val="0"/>
-        </c:ser>
-        <c:ser>
-          <c:idx val="1"/>
-          <c:order val="1"/>
-          <c:tx>
-            <c:strRef>
-              <c:f>Sheet1!$C$1</c:f>
-              <c:strCache>
-                <c:ptCount val="1"/>
-                <c:pt idx="0">
-                  <c:v>Ask (100%)</c:v>
-                </c:pt>
-              </c:strCache>
-            </c:strRef>
-          </c:tx>
-          <c:spPr>
-            <a:ln w="15875">
-              <a:solidFill>
-                <a:srgbClr val="9AA7B4"/>
-              </a:solidFill>
-              <a:prstDash val="dash"/>
-            </a:ln>
-          </c:spPr>
-          <c:marker>
-            <c:symbol val="none"/>
-          </c:marker>
-          <c:cat>
-            <c:strRef>
-              <c:f>Sheet1!$A$2:$A$26</c:f>
-              <c:strCache>
-                <c:ptCount val="25"/>
-                <c:pt idx="0">
-                  <c:v>12/29</c:v>
-                </c:pt>
-                <c:pt idx="1">
-                  <c:v>01/05</c:v>
-                </c:pt>
-                <c:pt idx="2">
-                  <c:v>01/12</c:v>
-                </c:pt>
-                <c:pt idx="3">
-                  <c:v>01/19</c:v>
-                </c:pt>
-                <c:pt idx="4">
-                  <c:v>01/26</c:v>
-                </c:pt>
-                <c:pt idx="5">
-                  <c:v>02/02</c:v>
-                </c:pt>
-                <c:pt idx="6">
-                  <c:v>02/09</c:v>
-                </c:pt>
-                <c:pt idx="7">
-                  <c:v>02/16</c:v>
-                </c:pt>
-                <c:pt idx="8">
-                  <c:v>02/23</c:v>
-                </c:pt>
-                <c:pt idx="9">
-                  <c:v>03/02</c:v>
-                </c:pt>
-                <c:pt idx="10">
-                  <c:v>03/09</c:v>
-                </c:pt>
-                <c:pt idx="11">
-                  <c:v>03/16</c:v>
-                </c:pt>
-                <c:pt idx="12">
-                  <c:v>03/23</c:v>
-                </c:pt>
-                <c:pt idx="13">
-                  <c:v>03/30</c:v>
-                </c:pt>
-                <c:pt idx="14">
-                  <c:v>04/06</c:v>
-                </c:pt>
-                <c:pt idx="15">
-                  <c:v>04/13</c:v>
-                </c:pt>
-                <c:pt idx="16">
-                  <c:v>04/20</c:v>
-                </c:pt>
-                <c:pt idx="17">
-                  <c:v>04/27</c:v>
-                </c:pt>
-                <c:pt idx="18">
-                  <c:v>05/04</c:v>
-                </c:pt>
-                <c:pt idx="19">
-                  <c:v>05/11</c:v>
-                </c:pt>
-                <c:pt idx="20">
-                  <c:v>05/18</c:v>
-                </c:pt>
-                <c:pt idx="21">
-                  <c:v>05/25</c:v>
-                </c:pt>
-                <c:pt idx="22">
-                  <c:v>06/01</c:v>
-                </c:pt>
-                <c:pt idx="23">
-                  <c:v>06/08</c:v>
-                </c:pt>
-                <c:pt idx="24">
-                  <c:v>06/15</c:v>
-                </c:pt>
-              </c:strCache>
-            </c:strRef>
-          </c:cat>
-          <c:val>
-            <c:numRef>
-              <c:f>Sheet1!$C$2:$C$26</c:f>
-              <c:numCache>
-                <c:formatCode>General</c:formatCode>
-                <c:ptCount val="25"/>
-                <c:pt idx="0">
-                  <c:v>100</c:v>
-                </c:pt>
-                <c:pt idx="1">
-                  <c:v>100</c:v>
-                </c:pt>
-                <c:pt idx="2">
-                  <c:v>100</c:v>
-                </c:pt>
-                <c:pt idx="3">
-                  <c:v>100</c:v>
-                </c:pt>
-                <c:pt idx="4">
-                  <c:v>100</c:v>
-                </c:pt>
-                <c:pt idx="5">
-                  <c:v>100</c:v>
-                </c:pt>
-                <c:pt idx="6">
-                  <c:v>100</c:v>
-                </c:pt>
-                <c:pt idx="7">
-                  <c:v>100</c:v>
-                </c:pt>
-                <c:pt idx="8">
-                  <c:v>100</c:v>
-                </c:pt>
-                <c:pt idx="9">
-                  <c:v>100</c:v>
-                </c:pt>
-                <c:pt idx="10">
-                  <c:v>100</c:v>
-                </c:pt>
-                <c:pt idx="11">
-                  <c:v>100</c:v>
-                </c:pt>
-                <c:pt idx="12">
-                  <c:v>100</c:v>
-                </c:pt>
-                <c:pt idx="13">
-                  <c:v>100</c:v>
-                </c:pt>
-                <c:pt idx="14">
-                  <c:v>100</c:v>
-                </c:pt>
-                <c:pt idx="15">
-                  <c:v>100</c:v>
-                </c:pt>
-                <c:pt idx="16">
-                  <c:v>100</c:v>
-                </c:pt>
-                <c:pt idx="17">
-                  <c:v>100</c:v>
-                </c:pt>
-                <c:pt idx="18">
-                  <c:v>100</c:v>
-                </c:pt>
-                <c:pt idx="19">
-                  <c:v>100</c:v>
-                </c:pt>
-                <c:pt idx="20">
-                  <c:v>100</c:v>
-                </c:pt>
-                <c:pt idx="21">
-                  <c:v>100</c:v>
-                </c:pt>
-                <c:pt idx="22">
-                  <c:v>100</c:v>
-                </c:pt>
-                <c:pt idx="23">
-                  <c:v>100</c:v>
-                </c:pt>
-                <c:pt idx="24">
-                  <c:v>100</c:v>
-                </c:pt>
-              </c:numCache>
-            </c:numRef>
-          </c:val>
-          <c:smooth val="0"/>
-        </c:ser>
-        <c:marker val="1"/>
-        <c:smooth val="0"/>
-        <c:axId val="2118791784"/>
-        <c:axId val="2140495176"/>
-      </c:lineChart>
-      <c:catAx>
-        <c:axId val="2118791784"/>
-        <c:scaling>
-          <c:orientation val="minMax"/>
-        </c:scaling>
-        <c:delete val="0"/>
-        <c:axPos val="b"/>
-        <c:majorTickMark val="out"/>
-        <c:minorTickMark val="none"/>
-        <c:tickLblPos val="nextTo"/>
-        <c:txPr>
-          <a:bodyPr/>
-          <a:lstStyle/>
-          <a:p>
-            <a:pPr>
-              <a:defRPr sz="600"/>
-            </a:pPr>
-          </a:p>
-        </c:txPr>
-        <c:crossAx val="2140495176"/>
-        <c:crosses val="autoZero"/>
-        <c:auto val="1"/>
-        <c:lblAlgn val="ctr"/>
-        <c:lblOffset val="100"/>
-        <c:noMultiLvlLbl val="0"/>
-      </c:catAx>
-      <c:valAx>
-        <c:axId val="2140495176"/>
-        <c:scaling>
-          <c:min val="0.0"/>
-        </c:scaling>
-        <c:delete val="0"/>
-        <c:axPos val="l"/>
-        <c:majorGridlines/>
-        <c:numFmt formatCode="0&quot;%&quot;" sourceLinked="0"/>
-        <c:majorTickMark val="out"/>
-        <c:minorTickMark val="none"/>
-        <c:tickLblPos val="nextTo"/>
-        <c:txPr>
-          <a:bodyPr/>
-          <a:lstStyle/>
-          <a:p>
-            <a:pPr>
-              <a:defRPr sz="700"/>
-            </a:pPr>
-          </a:p>
-        </c:txPr>
-        <c:crossAx val="2118791784"/>
-        <c:crosses val="autoZero"/>
-      </c:valAx>
-    </c:plotArea>
-    <c:plotVisOnly val="1"/>
-    <c:dispBlanksAs val="gap"/>
-    <c:showDLblsOverMax val="0"/>
-  </c:chart>
-  <c:txPr>
-    <a:bodyPr/>
-    <a:lstStyle/>
-    <a:p>
-      <a:pPr>
-        <a:defRPr sz="700"/>
-      </a:pPr>
-      <a:endParaRPr lang="en-US"/>
-    </a:p>
-  </c:txPr>
-  <c:externalData r:id="rId1">
-    <c:autoUpdate val="0"/>
-  </c:externalData>
-  <c:dispBlanksAs val="gap"/>
 </c:chartSpace>
 </file>
 
@@ -6520,6 +5580,67 @@
       </p:sp>
       <p:sp>
         <p:nvSpPr>
+          <p:cNvPr id="25" name="Text 23"/>
+          <p:cNvSpPr/>
+          <p:nvPr/>
+        </p:nvSpPr>
+        <p:spPr>
+          <a:xfrm>
+            <a:off x="6355080" y="1188720"/>
+            <a:ext cx="5376672" cy="219456"/>
+          </a:xfrm>
+          <a:prstGeom prst="rect">
+            <a:avLst/>
+          </a:prstGeom>
+          <a:noFill/>
+          <a:ln/>
+        </p:spPr>
+        <p:txBody>
+          <a:bodyPr wrap="square" lIns="0" tIns="0" rIns="0" bIns="0" rtlCol="0" anchor="ctr"/>
+          <a:lstStyle/>
+          <a:p>
+            <a:pPr marL="0" indent="0">
+              <a:buNone/>
+            </a:pPr>
+            <a:r>
+              <a:rPr lang="en-US" sz="1100" b="1" kern="0" spc="60" dirty="0">
+                <a:solidFill>
+                  <a:srgbClr val="12345B"/>
+                </a:solidFill>
+                <a:latin typeface="Calibri" pitchFamily="34" charset="0"/>
+                <a:ea typeface="Calibri" pitchFamily="34" charset="-122"/>
+                <a:cs typeface="Calibri" pitchFamily="34" charset="-120"/>
+              </a:rPr>
+              <a:t>PELVIC ATTAINMENT (506+518+541) vs 250/WK STANDARD @Martin’s — WEEKLY, 2026 YTD – Harvesting Yield </a:t>
+            </a:r>
+            <a:endParaRPr lang="en-US" sz="1100" dirty="0"/>
+          </a:p>
+        </p:txBody>
+      </p:sp>
+      <p:graphicFrame>
+        <p:nvGraphicFramePr>
+          <p:cNvPr id="26" name="Chart 0"/>
+          <p:cNvGraphicFramePr/>
+          <p:nvPr>
+            <p:extLst>
+              <p:ext uri="{D42A27DB-BD31-4B8C-83A1-F6EECF244321}">
+                <p14:modId xmlns:p14="http://schemas.microsoft.com/office/powerpoint/2010/main" val="3802844109"/>
+              </p:ext>
+            </p:extLst>
+          </p:nvPr>
+        </p:nvGraphicFramePr>
+        <p:xfrm>
+          <a:off x="6281928" y="1481328"/>
+          <a:ext cx="5486400" cy="3712464"/>
+        </p:xfrm>
+        <a:graphic>
+          <a:graphicData uri="http://schemas.openxmlformats.org/drawingml/2006/chart">
+            <c:chart xmlns:c="http://schemas.openxmlformats.org/drawingml/2006/chart" xmlns:r="http://schemas.openxmlformats.org/officeDocument/2006/relationships" r:id="rId3"/>
+          </a:graphicData>
+        </a:graphic>
+      </p:graphicFrame>
+      <p:sp>
+        <p:nvSpPr>
           <p:cNvPr id="27" name="Shape 24"/>
           <p:cNvSpPr/>
           <p:nvPr/>
@@ -6581,7 +5702,7 @@
                 <a:ea typeface="Calibri" pitchFamily="34" charset="-122"/>
                 <a:cs typeface="Calibri" pitchFamily="34" charset="-120"/>
               </a:rPr>
-              <a:t>Left: each site is independent; labor &amp; freezer are shared per site, kill capacity is set by tissues that can't come from one pig.  Right: two charts — each tissue's weekly harvested ÷ its ask (Female Pelvic 541 ÷ 170, Pelvic Block 506 ÷ 60); dashed line = 100% (ask); 506 no-harvest weeks shown as gaps.  Codes are Intuitive part numbers.</a:t>
+              <a:t>Left: each site is independent; labor &amp; freezer are shared per site, kill capacity is set by tissues that can't come from one pig.  Right: attainment = (Pelvic Block 506 + SM Intact 518 + Female Pelvic 541) harvested ÷ 250/wk (weekly); Male Pelvic excluded (wound down).  Codes are Intuitive part numbers.</a:t>
             </a:r>
             <a:endParaRPr lang="en-US" sz="850" dirty="0"/>
           </a:p>
@@ -6628,110 +5749,6 @@
           </a:p>
         </p:txBody>
       </p:sp>
-      <p:sp>
-        <p:nvSpPr>
-          <p:cNvPr id="30" name="TextBox 29"/>
-          <p:cNvSpPr txBox="1"/>
-          <p:nvPr/>
-        </p:nvSpPr>
-        <p:spPr>
-          <a:xfrm>
-            <a:off x="6199632" y="1225296"/>
-            <a:ext cx="2697480" cy="310896"/>
-          </a:xfrm>
-          <a:prstGeom prst="rect">
-            <a:avLst/>
-          </a:prstGeom>
-          <a:noFill/>
-        </p:spPr>
-        <p:txBody>
-          <a:bodyPr wrap="square">
-            <a:spAutoFit/>
-          </a:bodyPr>
-          <a:lstStyle/>
-          <a:p>
-            <a:r>
-              <a:rPr sz="1000" b="1">
-                <a:solidFill>
-                  <a:srgbClr val="12345B"/>
-                </a:solidFill>
-                <a:latin typeface="Calibri"/>
-              </a:rPr>
-              <a:t>Female Pelvic (541)  ·  vs 170/wk ask</a:t>
-            </a:r>
-          </a:p>
-        </p:txBody>
-      </p:sp>
-      <p:graphicFrame>
-        <p:nvGraphicFramePr>
-          <p:cNvPr id="31" name="Chart 30"/>
-          <p:cNvGraphicFramePr>
-            <a:graphicFrameLocks noGrp="1"/>
-          </p:cNvGraphicFramePr>
-          <p:nvPr/>
-        </p:nvGraphicFramePr>
-        <p:xfrm>
-          <a:off x="6199632" y="1572768"/>
-          <a:ext cx="2697480" cy="3291840"/>
-        </p:xfrm>
-        <a:graphic>
-          <a:graphicData uri="http://schemas.openxmlformats.org/drawingml/2006/chart">
-            <c:chart xmlns:c="http://schemas.openxmlformats.org/drawingml/2006/chart" r:id="rId4"/>
-          </a:graphicData>
-        </a:graphic>
-      </p:graphicFrame>
-      <p:sp>
-        <p:nvSpPr>
-          <p:cNvPr id="32" name="TextBox 31"/>
-          <p:cNvSpPr txBox="1"/>
-          <p:nvPr/>
-        </p:nvSpPr>
-        <p:spPr>
-          <a:xfrm>
-            <a:off x="9006840" y="1225296"/>
-            <a:ext cx="2697480" cy="310896"/>
-          </a:xfrm>
-          <a:prstGeom prst="rect">
-            <a:avLst/>
-          </a:prstGeom>
-          <a:noFill/>
-        </p:spPr>
-        <p:txBody>
-          <a:bodyPr wrap="square">
-            <a:spAutoFit/>
-          </a:bodyPr>
-          <a:lstStyle/>
-          <a:p>
-            <a:r>
-              <a:rPr sz="1000" b="1">
-                <a:solidFill>
-                  <a:srgbClr val="12345B"/>
-                </a:solidFill>
-                <a:latin typeface="Calibri"/>
-              </a:rPr>
-              <a:t>Pelvic Block (506)  ·  vs 60/wk ask</a:t>
-            </a:r>
-          </a:p>
-        </p:txBody>
-      </p:sp>
-      <p:graphicFrame>
-        <p:nvGraphicFramePr>
-          <p:cNvPr id="33" name="Chart 32"/>
-          <p:cNvGraphicFramePr>
-            <a:graphicFrameLocks noGrp="1"/>
-          </p:cNvGraphicFramePr>
-          <p:nvPr/>
-        </p:nvGraphicFramePr>
-        <p:xfrm>
-          <a:off x="9006840" y="1572768"/>
-          <a:ext cx="2697480" cy="3291840"/>
-        </p:xfrm>
-        <a:graphic>
-          <a:graphicData uri="http://schemas.openxmlformats.org/drawingml/2006/chart">
-            <c:chart xmlns:c="http://schemas.openxmlformats.org/drawingml/2006/chart" r:id="rId5"/>
-          </a:graphicData>
-        </a:graphic>
-      </p:graphicFrame>
     </p:spTree>
   </p:cSld>
   <p:clrMapOvr>

</xml_diff>

<commit_message>
Data-driven pelvic harvest standard = 290/wk + slide update
Recommend 290/wk for combined pelvics (506+541) at Martins = 125% of the
2027 build-plan demand (1.25 x 231; 506~52 + 541~179). The 25% uplift is
the deck's coverage goal and the buffer for the more-stringent, low-yield
506 (61% vs 73% historic attainment). Validated vs historic harvest
(avg 252/wk = 87% of 290).

- New Pelvic_Harvest_Standard_Martins.xlsx: recommendation, alternatives,
  build-plan demand, 25-week historic harvest/ask, 506-vs-541 stringency.
- Slide 2: combined (506+541) attainment vs 290 (was 250); title/footnote
  updated; 518/540 dropped.
- Weekly workbook: Pelvic Attainment @290 tab.

Co-Authored-By: Claude Opus 4.8 <noreply@anthropic.com>
Claude-Session: https://claude.ai/code/session_01LKMb7stbjGviiyFb298aFR
</commit_message>
<xml_diff>
--- a/tissue-capacity-model/deliverables/Tissue_Capacity_2026_2027.pptx
+++ b/tissue-capacity-model/deliverables/Tissue_Capacity_2026_2027.pptx
@@ -136,7 +136,7 @@
               <c:strCache>
                 <c:ptCount val="1"/>
                 <c:pt idx="0">
-                  <c:v>Pelvic Attainment (506+518+541)</c:v>
+                  <c:v>Pelvic Attainment (506+541)</c:v>
                 </c:pt>
               </c:strCache>
             </c:strRef>
@@ -244,79 +244,79 @@
                 <c:formatCode>General</c:formatCode>
                 <c:ptCount val="25"/>
                 <c:pt idx="0">
-                  <c:v>70</c:v>
+                  <c:v>60.3</c:v>
                 </c:pt>
                 <c:pt idx="1">
-                  <c:v>106</c:v>
+                  <c:v>91.4</c:v>
                 </c:pt>
                 <c:pt idx="2">
-                  <c:v>66.4</c:v>
+                  <c:v>57.2</c:v>
                 </c:pt>
                 <c:pt idx="3">
-                  <c:v>59.2</c:v>
+                  <c:v>51</c:v>
                 </c:pt>
                 <c:pt idx="4">
-                  <c:v>70.4</c:v>
+                  <c:v>60.7</c:v>
                 </c:pt>
                 <c:pt idx="5">
-                  <c:v>97.6</c:v>
+                  <c:v>84.1</c:v>
                 </c:pt>
                 <c:pt idx="6">
-                  <c:v>47.2</c:v>
+                  <c:v>40.7</c:v>
                 </c:pt>
                 <c:pt idx="7">
-                  <c:v>86</c:v>
+                  <c:v>74.1</c:v>
                 </c:pt>
                 <c:pt idx="8">
-                  <c:v>114.8</c:v>
+                  <c:v>99</c:v>
                 </c:pt>
                 <c:pt idx="9">
-                  <c:v>139.2</c:v>
+                  <c:v>120</c:v>
                 </c:pt>
                 <c:pt idx="10">
-                  <c:v>110</c:v>
+                  <c:v>94.8</c:v>
                 </c:pt>
                 <c:pt idx="11">
-                  <c:v>150</c:v>
+                  <c:v>129.3</c:v>
                 </c:pt>
                 <c:pt idx="12">
-                  <c:v>65.2</c:v>
+                  <c:v>56.2</c:v>
                 </c:pt>
                 <c:pt idx="13">
-                  <c:v>65.6</c:v>
+                  <c:v>56.6</c:v>
                 </c:pt>
                 <c:pt idx="14">
-                  <c:v>97.6</c:v>
+                  <c:v>84.1</c:v>
                 </c:pt>
                 <c:pt idx="15">
-                  <c:v>153.2</c:v>
+                  <c:v>132.1</c:v>
                 </c:pt>
                 <c:pt idx="16">
-                  <c:v>157.6</c:v>
+                  <c:v>135.9</c:v>
                 </c:pt>
                 <c:pt idx="17">
-                  <c:v>124.4</c:v>
+                  <c:v>107.2</c:v>
                 </c:pt>
                 <c:pt idx="18">
-                  <c:v>121.2</c:v>
+                  <c:v>104.5</c:v>
                 </c:pt>
                 <c:pt idx="19">
-                  <c:v>124.8</c:v>
+                  <c:v>107.6</c:v>
                 </c:pt>
                 <c:pt idx="20">
-                  <c:v>162</c:v>
+                  <c:v>139.7</c:v>
                 </c:pt>
                 <c:pt idx="21">
-                  <c:v>76.4</c:v>
+                  <c:v>65.9</c:v>
                 </c:pt>
                 <c:pt idx="22">
-                  <c:v>107.6</c:v>
+                  <c:v>92.8</c:v>
                 </c:pt>
                 <c:pt idx="23">
-                  <c:v>48.8</c:v>
+                  <c:v>42.1</c:v>
                 </c:pt>
                 <c:pt idx="24">
-                  <c:v>96.8</c:v>
+                  <c:v>83.4</c:v>
                 </c:pt>
               </c:numCache>
             </c:numRef>
@@ -5611,7 +5611,7 @@
                 <a:ea typeface="Calibri" pitchFamily="34" charset="-122"/>
                 <a:cs typeface="Calibri" pitchFamily="34" charset="-120"/>
               </a:rPr>
-              <a:t>PELVIC ATTAINMENT (506+518+541) vs 250/WK STANDARD @Martin’s — WEEKLY, 2026 YTD – Harvesting Yield </a:t>
+              <a:t>PELVIC ATTAINMENT (506+541) vs 290/WK STANDARD @Martin’s — WEEKLY, 2026 YTD – Harvesting Yield </a:t>
             </a:r>
             <a:endParaRPr lang="en-US" sz="1100" dirty="0"/>
           </a:p>
@@ -5702,7 +5702,7 @@
                 <a:ea typeface="Calibri" pitchFamily="34" charset="-122"/>
                 <a:cs typeface="Calibri" pitchFamily="34" charset="-120"/>
               </a:rPr>
-              <a:t>Left: each site is independent; labor &amp; freezer are shared per site, kill capacity is set by tissues that can't come from one pig.  Right: attainment = (Pelvic Block 506 + SM Intact 518 + Female Pelvic 541) harvested ÷ 250/wk (weekly); Male Pelvic excluded (wound down).  Codes are Intuitive part numbers.</a:t>
+              <a:t>Left: each site is independent; labor &amp; freezer are shared per site, kill capacity is set by tissues that can't come from one pig.  Right: attainment = (Pelvic Block 506 + Female Pelvic 541) harvested ÷ 290/wk (weekly); 290 = 125% of 2027 Martins pelvic demand; Male Pelvic excluded (wound down).  Codes are Intuitive part numbers.</a:t>
             </a:r>
             <a:endParaRPr lang="en-US" sz="850" dirty="0"/>
           </a:p>

</xml_diff>

<commit_message>
Slide 2: remove attainment graph, widen constraint map
Adopt user's revised deck and clean slide 2 after the pelvic attainment
chart was deleted: drop the chart-reference footnote text and the stale
"250 denominator / why is attainment dropping" sticky note, and widen the
constraint cards + driver-tissue lists to full width (chips moved right)
so the slide fills evenly. Slides 1 and 3 unchanged.

Co-Authored-By: Claude Opus 4.8 <noreply@anthropic.com>
Claude-Session: https://claude.ai/code/session_01LKMb7stbjGviiyFb298aFR
</commit_message>
<xml_diff>
--- a/tissue-capacity-model/deliverables/Tissue_Capacity_2026_2027.pptx
+++ b/tissue-capacity-model/deliverables/Tissue_Capacity_2026_2027.pptx
@@ -112,573 +112,6 @@
     </p:ext>
   </p:extLst>
 </p:presentation>
-</file>
-
-<file path=ppt/charts/chart1.xml><?xml version="1.0" encoding="utf-8"?>
-<c:chartSpace xmlns:c="http://schemas.openxmlformats.org/drawingml/2006/chart" xmlns:a="http://schemas.openxmlformats.org/drawingml/2006/main" xmlns:r="http://schemas.openxmlformats.org/officeDocument/2006/relationships" xmlns:c16r2="http://schemas.microsoft.com/office/drawing/2015/06/chart">
-  <c:date1904 val="0"/>
-  <c:lang val="en-US"/>
-  <c:roundedCorners val="1"/>
-  <c:style val="2"/>
-  <c:chart>
-    <c:autoTitleDeleted val="1"/>
-    <c:plotArea>
-      <c:layout/>
-      <c:lineChart>
-        <c:grouping val="standard"/>
-        <c:varyColors val="0"/>
-        <c:ser>
-          <c:idx val="0"/>
-          <c:order val="0"/>
-          <c:tx>
-            <c:strRef>
-              <c:f>Sheet1!$B$1</c:f>
-              <c:strCache>
-                <c:ptCount val="1"/>
-                <c:pt idx="0">
-                  <c:v>Pelvic Attainment (506+541)</c:v>
-                </c:pt>
-              </c:strCache>
-            </c:strRef>
-          </c:tx>
-          <c:spPr>
-            <a:ln w="31750" cap="flat">
-              <a:solidFill>
-                <a:srgbClr val="C0392B"/>
-              </a:solidFill>
-              <a:prstDash val="solid"/>
-              <a:round/>
-            </a:ln>
-            <a:effectLst/>
-          </c:spPr>
-          <c:marker>
-            <c:symbol val="none"/>
-          </c:marker>
-          <c:cat>
-            <c:strRef>
-              <c:f>Sheet1!$A$2:$A$26</c:f>
-              <c:strCache>
-                <c:ptCount val="25"/>
-                <c:pt idx="0">
-                  <c:v>12/29</c:v>
-                </c:pt>
-                <c:pt idx="1">
-                  <c:v>01/05</c:v>
-                </c:pt>
-                <c:pt idx="2">
-                  <c:v>01/12</c:v>
-                </c:pt>
-                <c:pt idx="3">
-                  <c:v>01/19</c:v>
-                </c:pt>
-                <c:pt idx="4">
-                  <c:v>01/26</c:v>
-                </c:pt>
-                <c:pt idx="5">
-                  <c:v>02/02</c:v>
-                </c:pt>
-                <c:pt idx="6">
-                  <c:v>02/09</c:v>
-                </c:pt>
-                <c:pt idx="7">
-                  <c:v>02/16</c:v>
-                </c:pt>
-                <c:pt idx="8">
-                  <c:v>02/23</c:v>
-                </c:pt>
-                <c:pt idx="9">
-                  <c:v>03/02</c:v>
-                </c:pt>
-                <c:pt idx="10">
-                  <c:v>03/09</c:v>
-                </c:pt>
-                <c:pt idx="11">
-                  <c:v>03/16</c:v>
-                </c:pt>
-                <c:pt idx="12">
-                  <c:v>03/23</c:v>
-                </c:pt>
-                <c:pt idx="13">
-                  <c:v>03/30</c:v>
-                </c:pt>
-                <c:pt idx="14">
-                  <c:v>04/06</c:v>
-                </c:pt>
-                <c:pt idx="15">
-                  <c:v>04/13</c:v>
-                </c:pt>
-                <c:pt idx="16">
-                  <c:v>04/20</c:v>
-                </c:pt>
-                <c:pt idx="17">
-                  <c:v>04/27</c:v>
-                </c:pt>
-                <c:pt idx="18">
-                  <c:v>05/04</c:v>
-                </c:pt>
-                <c:pt idx="19">
-                  <c:v>05/11</c:v>
-                </c:pt>
-                <c:pt idx="20">
-                  <c:v>05/18</c:v>
-                </c:pt>
-                <c:pt idx="21">
-                  <c:v>05/25</c:v>
-                </c:pt>
-                <c:pt idx="22">
-                  <c:v>06/01</c:v>
-                </c:pt>
-                <c:pt idx="23">
-                  <c:v>06/08</c:v>
-                </c:pt>
-                <c:pt idx="24">
-                  <c:v>06/15</c:v>
-                </c:pt>
-              </c:strCache>
-            </c:strRef>
-          </c:cat>
-          <c:val>
-            <c:numRef>
-              <c:f>Sheet1!$B$2:$B$26</c:f>
-              <c:numCache>
-                <c:formatCode>General</c:formatCode>
-                <c:ptCount val="25"/>
-                <c:pt idx="0">
-                  <c:v>60.3</c:v>
-                </c:pt>
-                <c:pt idx="1">
-                  <c:v>91.4</c:v>
-                </c:pt>
-                <c:pt idx="2">
-                  <c:v>57.2</c:v>
-                </c:pt>
-                <c:pt idx="3">
-                  <c:v>51</c:v>
-                </c:pt>
-                <c:pt idx="4">
-                  <c:v>60.7</c:v>
-                </c:pt>
-                <c:pt idx="5">
-                  <c:v>84.1</c:v>
-                </c:pt>
-                <c:pt idx="6">
-                  <c:v>40.7</c:v>
-                </c:pt>
-                <c:pt idx="7">
-                  <c:v>74.1</c:v>
-                </c:pt>
-                <c:pt idx="8">
-                  <c:v>99</c:v>
-                </c:pt>
-                <c:pt idx="9">
-                  <c:v>120</c:v>
-                </c:pt>
-                <c:pt idx="10">
-                  <c:v>94.8</c:v>
-                </c:pt>
-                <c:pt idx="11">
-                  <c:v>129.3</c:v>
-                </c:pt>
-                <c:pt idx="12">
-                  <c:v>56.2</c:v>
-                </c:pt>
-                <c:pt idx="13">
-                  <c:v>56.6</c:v>
-                </c:pt>
-                <c:pt idx="14">
-                  <c:v>84.1</c:v>
-                </c:pt>
-                <c:pt idx="15">
-                  <c:v>132.1</c:v>
-                </c:pt>
-                <c:pt idx="16">
-                  <c:v>135.9</c:v>
-                </c:pt>
-                <c:pt idx="17">
-                  <c:v>107.2</c:v>
-                </c:pt>
-                <c:pt idx="18">
-                  <c:v>104.5</c:v>
-                </c:pt>
-                <c:pt idx="19">
-                  <c:v>107.6</c:v>
-                </c:pt>
-                <c:pt idx="20">
-                  <c:v>139.7</c:v>
-                </c:pt>
-                <c:pt idx="21">
-                  <c:v>65.9</c:v>
-                </c:pt>
-                <c:pt idx="22">
-                  <c:v>92.8</c:v>
-                </c:pt>
-                <c:pt idx="23">
-                  <c:v>42.1</c:v>
-                </c:pt>
-                <c:pt idx="24">
-                  <c:v>83.4</c:v>
-                </c:pt>
-              </c:numCache>
-            </c:numRef>
-          </c:val>
-          <c:smooth val="0"/>
-          <c:extLst>
-            <c:ext xmlns:c16="http://schemas.microsoft.com/office/drawing/2014/chart" uri="{C3380CC4-5D6E-409C-BE32-E72D297353CC}">
-              <c16:uniqueId val="{00000000-AB4F-47DF-96E3-C4C373BE84C4}"/>
-            </c:ext>
-          </c:extLst>
-        </c:ser>
-        <c:ser>
-          <c:idx val="1"/>
-          <c:order val="1"/>
-          <c:tx>
-            <c:strRef>
-              <c:f>Sheet1!$D$1</c:f>
-              <c:strCache>
-                <c:ptCount val="1"/>
-                <c:pt idx="0">
-                  <c:v>Ask (100%)</c:v>
-                </c:pt>
-              </c:strCache>
-            </c:strRef>
-          </c:tx>
-          <c:spPr>
-            <a:ln w="31750" cap="flat">
-              <a:solidFill>
-                <a:srgbClr val="B7C1CB"/>
-              </a:solidFill>
-              <a:prstDash val="solid"/>
-              <a:round/>
-            </a:ln>
-            <a:effectLst/>
-          </c:spPr>
-          <c:marker>
-            <c:symbol val="none"/>
-          </c:marker>
-          <c:cat>
-            <c:strRef>
-              <c:f>Sheet1!$A$2:$A$26</c:f>
-              <c:strCache>
-                <c:ptCount val="25"/>
-                <c:pt idx="0">
-                  <c:v>12/29</c:v>
-                </c:pt>
-                <c:pt idx="1">
-                  <c:v>01/05</c:v>
-                </c:pt>
-                <c:pt idx="2">
-                  <c:v>01/12</c:v>
-                </c:pt>
-                <c:pt idx="3">
-                  <c:v>01/19</c:v>
-                </c:pt>
-                <c:pt idx="4">
-                  <c:v>01/26</c:v>
-                </c:pt>
-                <c:pt idx="5">
-                  <c:v>02/02</c:v>
-                </c:pt>
-                <c:pt idx="6">
-                  <c:v>02/09</c:v>
-                </c:pt>
-                <c:pt idx="7">
-                  <c:v>02/16</c:v>
-                </c:pt>
-                <c:pt idx="8">
-                  <c:v>02/23</c:v>
-                </c:pt>
-                <c:pt idx="9">
-                  <c:v>03/02</c:v>
-                </c:pt>
-                <c:pt idx="10">
-                  <c:v>03/09</c:v>
-                </c:pt>
-                <c:pt idx="11">
-                  <c:v>03/16</c:v>
-                </c:pt>
-                <c:pt idx="12">
-                  <c:v>03/23</c:v>
-                </c:pt>
-                <c:pt idx="13">
-                  <c:v>03/30</c:v>
-                </c:pt>
-                <c:pt idx="14">
-                  <c:v>04/06</c:v>
-                </c:pt>
-                <c:pt idx="15">
-                  <c:v>04/13</c:v>
-                </c:pt>
-                <c:pt idx="16">
-                  <c:v>04/20</c:v>
-                </c:pt>
-                <c:pt idx="17">
-                  <c:v>04/27</c:v>
-                </c:pt>
-                <c:pt idx="18">
-                  <c:v>05/04</c:v>
-                </c:pt>
-                <c:pt idx="19">
-                  <c:v>05/11</c:v>
-                </c:pt>
-                <c:pt idx="20">
-                  <c:v>05/18</c:v>
-                </c:pt>
-                <c:pt idx="21">
-                  <c:v>05/25</c:v>
-                </c:pt>
-                <c:pt idx="22">
-                  <c:v>06/01</c:v>
-                </c:pt>
-                <c:pt idx="23">
-                  <c:v>06/08</c:v>
-                </c:pt>
-                <c:pt idx="24">
-                  <c:v>06/15</c:v>
-                </c:pt>
-              </c:strCache>
-            </c:strRef>
-          </c:cat>
-          <c:val>
-            <c:numRef>
-              <c:f>Sheet1!$D$2:$D$26</c:f>
-              <c:numCache>
-                <c:formatCode>General</c:formatCode>
-                <c:ptCount val="25"/>
-                <c:pt idx="0">
-                  <c:v>100</c:v>
-                </c:pt>
-                <c:pt idx="1">
-                  <c:v>100</c:v>
-                </c:pt>
-                <c:pt idx="2">
-                  <c:v>100</c:v>
-                </c:pt>
-                <c:pt idx="3">
-                  <c:v>100</c:v>
-                </c:pt>
-                <c:pt idx="4">
-                  <c:v>100</c:v>
-                </c:pt>
-                <c:pt idx="5">
-                  <c:v>100</c:v>
-                </c:pt>
-                <c:pt idx="6">
-                  <c:v>100</c:v>
-                </c:pt>
-                <c:pt idx="7">
-                  <c:v>100</c:v>
-                </c:pt>
-                <c:pt idx="8">
-                  <c:v>100</c:v>
-                </c:pt>
-                <c:pt idx="9">
-                  <c:v>100</c:v>
-                </c:pt>
-                <c:pt idx="10">
-                  <c:v>100</c:v>
-                </c:pt>
-                <c:pt idx="11">
-                  <c:v>100</c:v>
-                </c:pt>
-                <c:pt idx="12">
-                  <c:v>100</c:v>
-                </c:pt>
-                <c:pt idx="13">
-                  <c:v>100</c:v>
-                </c:pt>
-                <c:pt idx="14">
-                  <c:v>100</c:v>
-                </c:pt>
-                <c:pt idx="15">
-                  <c:v>100</c:v>
-                </c:pt>
-                <c:pt idx="16">
-                  <c:v>100</c:v>
-                </c:pt>
-                <c:pt idx="17">
-                  <c:v>100</c:v>
-                </c:pt>
-                <c:pt idx="18">
-                  <c:v>100</c:v>
-                </c:pt>
-                <c:pt idx="19">
-                  <c:v>100</c:v>
-                </c:pt>
-                <c:pt idx="20">
-                  <c:v>100</c:v>
-                </c:pt>
-                <c:pt idx="21">
-                  <c:v>100</c:v>
-                </c:pt>
-                <c:pt idx="22">
-                  <c:v>100</c:v>
-                </c:pt>
-                <c:pt idx="23">
-                  <c:v>100</c:v>
-                </c:pt>
-                <c:pt idx="24">
-                  <c:v>100</c:v>
-                </c:pt>
-              </c:numCache>
-            </c:numRef>
-          </c:val>
-          <c:smooth val="0"/>
-          <c:extLst>
-            <c:ext xmlns:c16="http://schemas.microsoft.com/office/drawing/2014/chart" uri="{C3380CC4-5D6E-409C-BE32-E72D297353CC}">
-              <c16:uniqueId val="{00000002-AB4F-47DF-96E3-C4C373BE84C4}"/>
-            </c:ext>
-          </c:extLst>
-        </c:ser>
-        <c:dLbls>
-          <c:showLegendKey val="0"/>
-          <c:showVal val="0"/>
-          <c:showCatName val="0"/>
-          <c:showSerName val="0"/>
-          <c:showPercent val="0"/>
-          <c:showBubbleSize val="0"/>
-        </c:dLbls>
-        <c:smooth val="0"/>
-        <c:axId val="2094734554"/>
-        <c:axId val="2094734552"/>
-      </c:lineChart>
-      <c:catAx>
-        <c:axId val="2094734554"/>
-        <c:scaling>
-          <c:orientation val="minMax"/>
-        </c:scaling>
-        <c:delete val="0"/>
-        <c:axPos val="b"/>
-        <c:numFmt formatCode="General" sourceLinked="1"/>
-        <c:majorTickMark val="out"/>
-        <c:minorTickMark val="none"/>
-        <c:tickLblPos val="low"/>
-        <c:spPr>
-          <a:ln w="12700" cap="flat">
-            <a:solidFill>
-              <a:srgbClr val="888888"/>
-            </a:solidFill>
-            <a:prstDash val="solid"/>
-            <a:round/>
-          </a:ln>
-        </c:spPr>
-        <c:txPr>
-          <a:bodyPr/>
-          <a:lstStyle/>
-          <a:p>
-            <a:pPr>
-              <a:defRPr sz="750" b="0" i="0" u="none" strike="noStrike">
-                <a:solidFill>
-                  <a:srgbClr val="64748B"/>
-                </a:solidFill>
-                <a:latin typeface="Arial"/>
-              </a:defRPr>
-            </a:pPr>
-            <a:endParaRPr lang="en-US"/>
-          </a:p>
-        </c:txPr>
-        <c:crossAx val="2094734552"/>
-        <c:crosses val="autoZero"/>
-        <c:auto val="1"/>
-        <c:lblAlgn val="ctr"/>
-        <c:lblOffset val="100"/>
-        <c:noMultiLvlLbl val="1"/>
-      </c:catAx>
-      <c:valAx>
-        <c:axId val="2094734552"/>
-        <c:scaling>
-          <c:orientation val="minMax"/>
-          <c:max val="120"/>
-          <c:min val="0"/>
-        </c:scaling>
-        <c:delete val="0"/>
-        <c:axPos val="l"/>
-        <c:majorGridlines>
-          <c:spPr>
-            <a:ln w="6350" cap="flat">
-              <a:solidFill>
-                <a:srgbClr val="E8EDF2"/>
-              </a:solidFill>
-              <a:prstDash val="solid"/>
-              <a:round/>
-            </a:ln>
-          </c:spPr>
-        </c:majorGridlines>
-        <c:numFmt formatCode="0&quot;%&quot;" sourceLinked="0"/>
-        <c:majorTickMark val="out"/>
-        <c:minorTickMark val="none"/>
-        <c:tickLblPos val="nextTo"/>
-        <c:spPr>
-          <a:ln w="12700" cap="flat">
-            <a:solidFill>
-              <a:srgbClr val="888888"/>
-            </a:solidFill>
-            <a:prstDash val="solid"/>
-            <a:round/>
-          </a:ln>
-        </c:spPr>
-        <c:txPr>
-          <a:bodyPr/>
-          <a:lstStyle/>
-          <a:p>
-            <a:pPr>
-              <a:defRPr sz="800" b="0" i="0" u="none" strike="noStrike">
-                <a:solidFill>
-                  <a:srgbClr val="64748B"/>
-                </a:solidFill>
-                <a:latin typeface="Arial"/>
-              </a:defRPr>
-            </a:pPr>
-            <a:endParaRPr lang="en-US"/>
-          </a:p>
-        </c:txPr>
-        <c:crossAx val="2094734554"/>
-        <c:crosses val="autoZero"/>
-        <c:crossBetween val="between"/>
-        <c:majorUnit val="20"/>
-      </c:valAx>
-      <c:spPr>
-        <a:noFill/>
-        <a:ln>
-          <a:noFill/>
-        </a:ln>
-        <a:effectLst/>
-      </c:spPr>
-    </c:plotArea>
-    <c:legend>
-      <c:legendPos val="b"/>
-      <c:overlay val="0"/>
-      <c:txPr>
-        <a:bodyPr/>
-        <a:lstStyle/>
-        <a:p>
-          <a:pPr>
-            <a:defRPr sz="900">
-              <a:solidFill>
-                <a:srgbClr val="20303D"/>
-              </a:solidFill>
-            </a:defRPr>
-          </a:pPr>
-          <a:endParaRPr lang="en-US"/>
-        </a:p>
-      </c:txPr>
-    </c:legend>
-    <c:plotVisOnly val="1"/>
-    <c:dispBlanksAs val="span"/>
-    <c:showDLblsOverMax val="1"/>
-  </c:chart>
-  <c:spPr>
-    <a:solidFill>
-      <a:srgbClr val="FFFFFF"/>
-    </a:solidFill>
-    <a:ln>
-      <a:noFill/>
-    </a:ln>
-    <a:effectLst/>
-  </c:spPr>
-  <c:externalData r:id="rId1">
-    <c:autoUpdate val="0"/>
-  </c:externalData>
-</c:chartSpace>
 </file>
 
 <file path=ppt/notesMasters/notesMaster1.xml><?xml version="1.0" encoding="utf-8"?>
@@ -1580,43 +1013,7 @@
                 </a:solidFill>
                 <a:latin typeface="Calibri"/>
               </a:rPr>
-              <a:t>   ▸ The labor reallocation lifted Martins to 1.14× — now freezer-/labor-bound. Pelvic-yield gains free pigs &amp; labor but don't move freezer, so Martins stays ~1.14× until freezer is addressed too — see slide 3.</a:t>
-            </a:r>
-            <a:r>
-              <a:rPr sz="1100" b="1" i="1" dirty="0" err="1">
-                <a:solidFill>
-                  <a:srgbClr val="12345B"/>
-                </a:solidFill>
-                <a:latin typeface="Calibri"/>
-              </a:rPr>
-              <a:t/>
-            </a:r>
-            <a:r>
-              <a:rPr sz="1100" b="1" i="1" dirty="0">
-                <a:solidFill>
-                  <a:srgbClr val="12345B"/>
-                </a:solidFill>
-                <a:latin typeface="Calibri"/>
-              </a:rPr>
-              <a:t/>
-            </a:r>
-            <a:r>
-              <a:rPr sz="1100" b="1" i="1" dirty="0" err="1">
-                <a:solidFill>
-                  <a:srgbClr val="12345B"/>
-                </a:solidFill>
-                <a:latin typeface="Calibri"/>
-              </a:rPr>
-              <a:t/>
-            </a:r>
-            <a:r>
-              <a:rPr sz="1100" b="1" i="1" dirty="0">
-                <a:solidFill>
-                  <a:srgbClr val="12345B"/>
-                </a:solidFill>
-                <a:latin typeface="Calibri"/>
-              </a:rPr>
-              <a:t/>
+              <a:t>   </a:t>
             </a:r>
             <a:endParaRPr lang="en-US" sz="1450" dirty="0"/>
           </a:p>
@@ -4789,7 +4186,7 @@
         <p:spPr>
           <a:xfrm>
             <a:off x="457200" y="1225296"/>
-            <a:ext cx="5623560" cy="960120"/>
+            <a:ext cx="11274552" cy="960120"/>
           </a:xfrm>
           <a:prstGeom prst="roundRect">
             <a:avLst>
@@ -4868,8 +4265,8 @@
         </p:nvSpPr>
         <p:spPr>
           <a:xfrm>
-            <a:off x="2286000" y="1344168"/>
-            <a:ext cx="2286000" cy="274320"/>
+            <a:off x="8503920" y="1344168"/>
+            <a:ext cx="3108960" cy="274320"/>
           </a:xfrm>
           <a:prstGeom prst="roundRect">
             <a:avLst>
@@ -4897,8 +4294,8 @@
         </p:nvSpPr>
         <p:spPr>
           <a:xfrm>
-            <a:off x="2286000" y="1339596"/>
-            <a:ext cx="2286000" cy="283464"/>
+            <a:off x="8503920" y="1339596"/>
+            <a:ext cx="3108960" cy="283464"/>
           </a:xfrm>
           <a:prstGeom prst="rect">
             <a:avLst/>
@@ -4937,7 +4334,7 @@
         <p:spPr>
           <a:xfrm>
             <a:off x="658368" y="1673352"/>
-            <a:ext cx="5257800" cy="457200"/>
+            <a:ext cx="10607040" cy="457200"/>
           </a:xfrm>
           <a:prstGeom prst="rect">
             <a:avLst/>
@@ -4976,7 +4373,7 @@
         <p:spPr>
           <a:xfrm>
             <a:off x="457200" y="2240280"/>
-            <a:ext cx="5623560" cy="960120"/>
+            <a:ext cx="11274552" cy="960120"/>
           </a:xfrm>
           <a:prstGeom prst="roundRect">
             <a:avLst>
@@ -5055,8 +4452,8 @@
         </p:nvSpPr>
         <p:spPr>
           <a:xfrm>
-            <a:off x="2286000" y="2359152"/>
-            <a:ext cx="2286000" cy="274320"/>
+            <a:off x="8503920" y="2359152"/>
+            <a:ext cx="3108960" cy="274320"/>
           </a:xfrm>
           <a:prstGeom prst="roundRect">
             <a:avLst>
@@ -5084,8 +4481,8 @@
         </p:nvSpPr>
         <p:spPr>
           <a:xfrm>
-            <a:off x="2286000" y="2354580"/>
-            <a:ext cx="2286000" cy="283464"/>
+            <a:off x="8503920" y="2354580"/>
+            <a:ext cx="3108960" cy="283464"/>
           </a:xfrm>
           <a:prstGeom prst="rect">
             <a:avLst/>
@@ -5124,7 +4521,7 @@
         <p:spPr>
           <a:xfrm>
             <a:off x="658368" y="2688336"/>
-            <a:ext cx="5257800" cy="457200"/>
+            <a:ext cx="10607040" cy="457200"/>
           </a:xfrm>
           <a:prstGeom prst="rect">
             <a:avLst/>
@@ -5163,7 +4560,7 @@
         <p:spPr>
           <a:xfrm>
             <a:off x="457200" y="3255264"/>
-            <a:ext cx="5623560" cy="960120"/>
+            <a:ext cx="11274552" cy="960120"/>
           </a:xfrm>
           <a:prstGeom prst="roundRect">
             <a:avLst>
@@ -5242,8 +4639,8 @@
         </p:nvSpPr>
         <p:spPr>
           <a:xfrm>
-            <a:off x="2286000" y="3374136"/>
-            <a:ext cx="2286000" cy="274320"/>
+            <a:off x="8503920" y="3374136"/>
+            <a:ext cx="3108960" cy="274320"/>
           </a:xfrm>
           <a:prstGeom prst="roundRect">
             <a:avLst>
@@ -5271,8 +4668,8 @@
         </p:nvSpPr>
         <p:spPr>
           <a:xfrm>
-            <a:off x="2286000" y="3369564"/>
-            <a:ext cx="2286000" cy="283464"/>
+            <a:off x="8503920" y="3369564"/>
+            <a:ext cx="3108960" cy="283464"/>
           </a:xfrm>
           <a:prstGeom prst="rect">
             <a:avLst/>
@@ -5311,7 +4708,7 @@
         <p:spPr>
           <a:xfrm>
             <a:off x="658368" y="3703320"/>
-            <a:ext cx="5257800" cy="457200"/>
+            <a:ext cx="10607040" cy="457200"/>
           </a:xfrm>
           <a:prstGeom prst="rect">
             <a:avLst/>
@@ -5350,7 +4747,7 @@
         <p:spPr>
           <a:xfrm>
             <a:off x="457200" y="4270248"/>
-            <a:ext cx="5623560" cy="960120"/>
+            <a:ext cx="11274552" cy="960120"/>
           </a:xfrm>
           <a:prstGeom prst="roundRect">
             <a:avLst>
@@ -5429,8 +4826,8 @@
         </p:nvSpPr>
         <p:spPr>
           <a:xfrm>
-            <a:off x="2286000" y="4389120"/>
-            <a:ext cx="2286000" cy="274320"/>
+            <a:off x="8503920" y="4389120"/>
+            <a:ext cx="3108960" cy="274320"/>
           </a:xfrm>
           <a:prstGeom prst="roundRect">
             <a:avLst>
@@ -5458,8 +4855,8 @@
         </p:nvSpPr>
         <p:spPr>
           <a:xfrm>
-            <a:off x="2286000" y="4384548"/>
-            <a:ext cx="2286000" cy="283464"/>
+            <a:off x="8503920" y="4384548"/>
+            <a:ext cx="3108960" cy="283464"/>
           </a:xfrm>
           <a:prstGeom prst="rect">
             <a:avLst/>
@@ -5498,7 +4895,7 @@
         <p:spPr>
           <a:xfrm>
             <a:off x="658368" y="4718304"/>
-            <a:ext cx="5257800" cy="219456"/>
+            <a:ext cx="10607040" cy="219456"/>
           </a:xfrm>
           <a:prstGeom prst="rect">
             <a:avLst/>
@@ -5537,7 +4934,7 @@
         <p:spPr>
           <a:xfrm>
             <a:off x="658368" y="4937760"/>
-            <a:ext cx="5257800" cy="237744"/>
+            <a:ext cx="10607040" cy="237744"/>
           </a:xfrm>
           <a:prstGeom prst="rect">
             <a:avLst/>
@@ -5578,67 +4975,6 @@
           </a:p>
         </p:txBody>
       </p:sp>
-      <p:sp>
-        <p:nvSpPr>
-          <p:cNvPr id="25" name="Text 23"/>
-          <p:cNvSpPr/>
-          <p:nvPr/>
-        </p:nvSpPr>
-        <p:spPr>
-          <a:xfrm>
-            <a:off x="6355080" y="1188720"/>
-            <a:ext cx="5376672" cy="219456"/>
-          </a:xfrm>
-          <a:prstGeom prst="rect">
-            <a:avLst/>
-          </a:prstGeom>
-          <a:noFill/>
-          <a:ln/>
-        </p:spPr>
-        <p:txBody>
-          <a:bodyPr wrap="square" lIns="0" tIns="0" rIns="0" bIns="0" rtlCol="0" anchor="ctr"/>
-          <a:lstStyle/>
-          <a:p>
-            <a:pPr marL="0" indent="0">
-              <a:buNone/>
-            </a:pPr>
-            <a:r>
-              <a:rPr lang="en-US" sz="1100" b="1" kern="0" spc="60" dirty="0">
-                <a:solidFill>
-                  <a:srgbClr val="12345B"/>
-                </a:solidFill>
-                <a:latin typeface="Calibri" pitchFamily="34" charset="0"/>
-                <a:ea typeface="Calibri" pitchFamily="34" charset="-122"/>
-                <a:cs typeface="Calibri" pitchFamily="34" charset="-120"/>
-              </a:rPr>
-              <a:t>PELVIC ATTAINMENT (506+541) vs 290/WK STANDARD @Martin’s — WEEKLY, 2026 YTD – Harvesting Yield </a:t>
-            </a:r>
-            <a:endParaRPr lang="en-US" sz="1100" dirty="0"/>
-          </a:p>
-        </p:txBody>
-      </p:sp>
-      <p:graphicFrame>
-        <p:nvGraphicFramePr>
-          <p:cNvPr id="26" name="Chart 0"/>
-          <p:cNvGraphicFramePr/>
-          <p:nvPr>
-            <p:extLst>
-              <p:ext uri="{D42A27DB-BD31-4B8C-83A1-F6EECF244321}">
-                <p14:modId xmlns:p14="http://schemas.microsoft.com/office/powerpoint/2010/main" val="3802844109"/>
-              </p:ext>
-            </p:extLst>
-          </p:nvPr>
-        </p:nvGraphicFramePr>
-        <p:xfrm>
-          <a:off x="6281928" y="1481328"/>
-          <a:ext cx="5486400" cy="3712464"/>
-        </p:xfrm>
-        <a:graphic>
-          <a:graphicData uri="http://schemas.openxmlformats.org/drawingml/2006/chart">
-            <c:chart xmlns:c="http://schemas.openxmlformats.org/drawingml/2006/chart" xmlns:r="http://schemas.openxmlformats.org/officeDocument/2006/relationships" r:id="rId3"/>
-          </a:graphicData>
-        </a:graphic>
-      </p:graphicFrame>
       <p:sp>
         <p:nvSpPr>
           <p:cNvPr id="27" name="Shape 24"/>
@@ -5702,50 +5038,9 @@
                 <a:ea typeface="Calibri" pitchFamily="34" charset="-122"/>
                 <a:cs typeface="Calibri" pitchFamily="34" charset="-120"/>
               </a:rPr>
-              <a:t>Left: each site is independent; labor &amp; freezer are shared per site, kill capacity is set by tissues that can't come from one pig.  Right: attainment = (Pelvic Block 506 + Female Pelvic 541) harvested ÷ 290/wk (weekly); 290 = 125% of 2027 Martins pelvic demand; Male Pelvic excluded (wound down).  Codes are Intuitive part numbers.</a:t>
+              <a:t>Each site is independent; labor &amp; freezer are shared per site, while kill capacity is set by tissues that can't come from one pig.  Codes are Intuitive part numbers.</a:t>
             </a:r>
             <a:endParaRPr lang="en-US" sz="850" dirty="0"/>
-          </a:p>
-        </p:txBody>
-      </p:sp>
-      <p:sp>
-        <p:nvSpPr>
-          <p:cNvPr id="29" name="TextBox 28">
-            <a:extLst>
-              <a:ext uri="{FF2B5EF4-FFF2-40B4-BE49-F238E27FC236}">
-                <a16:creationId xmlns:a16="http://schemas.microsoft.com/office/drawing/2014/main" id="{8A7D2B7E-C16B-22F9-D6E8-0AEDF44B6CC5}"/>
-              </a:ext>
-            </a:extLst>
-          </p:cNvPr>
-          <p:cNvSpPr txBox="1"/>
-          <p:nvPr/>
-        </p:nvSpPr>
-        <p:spPr>
-          <a:xfrm>
-            <a:off x="3268980" y="6071616"/>
-            <a:ext cx="8181599" cy="646331"/>
-          </a:xfrm>
-          <a:prstGeom prst="rect">
-            <a:avLst/>
-          </a:prstGeom>
-          <a:noFill/>
-        </p:spPr>
-        <p:txBody>
-          <a:bodyPr wrap="none" rtlCol="0">
-            <a:spAutoFit/>
-          </a:bodyPr>
-          <a:lstStyle/>
-          <a:p>
-            <a:r>
-              <a:rPr lang="en-US" dirty="0"/>
-              <a:t>✓ 250 denominator applied</a:t>
-            </a:r>
-          </a:p>
-          <a:p>
-            <a:r>
-              <a:rPr lang="en-US" dirty="0"/>
-              <a:t>Why is the attainment dropping? Possible culprits: Seasonality, harvesting yield, labor</a:t>
-            </a:r>
           </a:p>
         </p:txBody>
       </p:sp>

</xml_diff>